<commit_message>
docs: tighten Yoda investor pitch deck
</commit_message>
<xml_diff>
--- a/slide-deck/yoda-business-plan/yoda-business-plan.pptx
+++ b/slide-deck/yoda-business-plan/yoda-business-plan.pptx
@@ -18,14 +18,9 @@
     <p:sldId id="266" r:id="rId12"/>
     <p:sldId id="267" r:id="rId13"/>
     <p:sldId id="268" r:id="rId14"/>
-    <p:sldId id="269" r:id="rId15"/>
-    <p:sldId id="270" r:id="rId16"/>
-    <p:sldId id="271" r:id="rId17"/>
-    <p:sldId id="272" r:id="rId18"/>
-    <p:sldId id="273" r:id="rId19"/>
   </p:sldIdLst>
   <p:notesMasterIdLst>
-    <p:notesMasterId r:id="rId20"/>
+    <p:notesMasterId r:id="rId15"/>
   </p:notesMasterIdLst>
   <p:sldSz cx="9144000" cy="5143500"/>
   <p:notesSz cx="5143500" cy="9144000"/>
@@ -612,46 +607,47 @@
 - The source skill's generic hand-drawn rule is intentionally overridden by this deck's confirmed custom investor style and the user's request for real evidence.
 ## STYLE_INSTRUCTIONS
 &lt;STYLE_INSTRUCTIONS&gt;
-Design Aesthetic: 苹果发布会式清晰度、咨询报告式可信度与创业团队真实感的结合。整体采用暖白、暖灰背景和精确的现代几何排版，只使用 Yoda 绿作为品牌强调色；每页用一句结论统领一个观点，让真实截图、数据或流程承担主要叙事。
+Design Aesthetic: 简单、具体、可信，带一点野心。像优秀种子轮融资材料，而不是产品功能说明书。使用苹果发布会式的清晰度、咨询报告式的证据意识和创业团队的真实感。
 Background:
-  Texture: clean，纯色背景，无纸张纹理、渐变噪点或装饰图案
-  Base Color: 暖白 #F7F5F0 为主，暖灰 #E9E9E6 用于分区和数据底板
+  Texture: clean，纯色，无纹理、网格、渐变或装饰背景
+  Base Color: 暖白 #F7F6F2；只在少数对比页使用极浅暖灰 #EFEEE9
 Typography:
-  Headlines: 粗体几何无衬线，笔画干净、结构克制、尺度强烈；中文视觉接近现代黑体
-  Body: 清晰现代无衬线，适合屏幕阅读；正文视觉尺寸不小于 20pt，数字可用等宽特征增强可信度
+  Headlines: 现代粗体无衬线，结论式标题，54–72px，严格控制在两行内
+  Body: 现代无衬线，24–30px；脚注可缩小但必须清晰
+  Numbers: 大号、直接、附口径，不放在多层卡片中
 Color Palette:
-  Primary Text: 墨黑 #111111 - 标题、关键结论和核心数字
-  Background: 暖白 #F7F5F0 - 主要画布
-  Surface: 暖灰 #E9E9E6 - 卡片、对照区和数据底板
-  Accent 1: Yoda Green #5DC98F - 唯一品牌强调色，用于关键节点、箭头和数字
-  Secondary Text: 中灰 #71717A - 注释、来源和非核心信息
+  Primary Text: #111111
+  Secondary Text: #62645F
+  Hairline: #D7D6D0
+  Brand Accent: Yoda Deep Green #173D2A
+  Secondary Accent: Yoda Green #5DC98F，仅用于一个关键节点或数字
 Visual Elements:
-  - 真实 Yoda 产品截图、用户现场、活动照片、访谈或数据证据优先于图库照片
-  - 使用细线流程图、简洁箭头、少量圆角底板和大数字，不使用 3D 插画或装饰性图标堆叠
-  - 图表弱化坐标轴，直接标注趋势、口径和结论
-  - 每页最多一个主视觉；照片保持真实色彩，只做必要裁切和轻微降饱和
+  - 真实产品截图、真实用户现场和真实数据优先
+  - 只使用细线、少量色块、流程轨道和大数字
+  - 每页最多一个主视觉；圆角底板最多一块
+  - 不使用图标墙、胶囊标签堆叠、装饰性箭头、阴影卡片阵列或复杂坐标轴
 Density Guidelines:
-  - Content per slide: 一个核心观点，标题 + 最多 2–3 个支撑点；数据页允许 3–5 个关键数字
-  - Whitespace: 四周至少保留 12%–15% 安全边距，主视觉与文字之间保持明显呼吸感
+  - 每页一个结论，最多 2 个支撑层级
+  - 四周保留 80–100px 安全边距
+  - 页面至少 40% 留白
 Style Rules:
-  Do: 标题直接写结论；优先使用真实证据；保持 16:9；统一左对齐或明确的中心对齐；所有小字确保可读；每个数字附口径或日期
-  Don't: 不使用深色满版背景；不堆复杂坐标轴；不使用无关图库人物；不编造客户、订单、留存或收入；不把 Agent 团队写成产品类别；不使用发光、玻璃拟态、过多描边和装饰线
+  Do: 标题直接表达结论；每页为口头讲述提供一个视觉锚点；明确数据日期与证据边界
+  Don't: 不伪造产品 UI、客户、订单、留存或收入；不重复解释 Agent 团队；不让技术名词成为标题主体；不使用深色满版背景
 &lt;/STYLE_INSTRUCTIONS&gt;
 ## SLIDE CONTENT
-## Slide 1 of 18
+## Slide 1 of 13
 **Type**: Cover
 **Filename**: 01-slide-cover.png
 // NARRATIVE GOAL
-在一秒内建立产品类别、核心用户与品牌认知，不从技术功能清单开场。
+一句话说明产品是谁、服务谁、创造什么价值。
 // KEY CONTENT
 Headline: Yoda：超级开发者的 AI Harness 工作台
 Sub-headline: 统一 Agent、上下文与交付，让 AI 真正进入持续创造
-Body: Your Orchestra of Delegated Agents · 融资版 BP · 2026.07
+Body: 融资版 BP · 2026.07
 // VISUAL
-暖白画布中央放置 Yoda 标志与大标题；右下角用一条极细的 Yoda 绿路径连接“想法 → AI → 作品”，形成克制但有方向感的品牌记忆。封面不使用产品功能列表。
+暖白底，大标题占据左侧；右侧只有一条从“想法”走向“作品”的细绿色轨道。无功能标签、无多余口号。
 // LAYOUT
 Layout: title-hero
-标题占据视觉中心偏左区域，标志与副标题形成清晰纵向层级；右下角保留大面积留白。
 ## Production Note
 +Render with deterministic HTML/CSS/SVG composition so Chinese text, data values, citations and evidence boundaries remain exact. Rasterize the final 1600 × 900 canvas to PNG.
 </a:t>
@@ -835,49 +831,50 @@
 - The source skill's generic hand-drawn rule is intentionally overridden by this deck's confirmed custom investor style and the user's request for real evidence.
 ## STYLE_INSTRUCTIONS
 &lt;STYLE_INSTRUCTIONS&gt;
-Design Aesthetic: 苹果发布会式清晰度、咨询报告式可信度与创业团队真实感的结合。整体采用暖白、暖灰背景和精确的现代几何排版，只使用 Yoda 绿作为品牌强调色；每页用一句结论统领一个观点，让真实截图、数据或流程承担主要叙事。
+Design Aesthetic: 简单、具体、可信，带一点野心。像优秀种子轮融资材料，而不是产品功能说明书。使用苹果发布会式的清晰度、咨询报告式的证据意识和创业团队的真实感。
 Background:
-  Texture: clean，纯色背景，无纸张纹理、渐变噪点或装饰图案
-  Base Color: 暖白 #F7F5F0 为主，暖灰 #E9E9E6 用于分区和数据底板
+  Texture: clean，纯色，无纹理、网格、渐变或装饰背景
+  Base Color: 暖白 #F7F6F2；只在少数对比页使用极浅暖灰 #EFEEE9
 Typography:
-  Headlines: 粗体几何无衬线，笔画干净、结构克制、尺度强烈；中文视觉接近现代黑体
-  Body: 清晰现代无衬线，适合屏幕阅读；正文视觉尺寸不小于 20pt，数字可用等宽特征增强可信度
+  Headlines: 现代粗体无衬线，结论式标题，54–72px，严格控制在两行内
+  Body: 现代无衬线，24–30px；脚注可缩小但必须清晰
+  Numbers: 大号、直接、附口径，不放在多层卡片中
 Color Palette:
-  Primary Text: 墨黑 #111111 - 标题、关键结论和核心数字
-  Background: 暖白 #F7F5F0 - 主要画布
-  Surface: 暖灰 #E9E9E6 - 卡片、对照区和数据底板
-  Accent 1: Yoda Green #5DC98F - 唯一品牌强调色，用于关键节点、箭头和数字
-  Secondary Text: 中灰 #71717A - 注释、来源和非核心信息
+  Primary Text: #111111
+  Secondary Text: #62645F
+  Hairline: #D7D6D0
+  Brand Accent: Yoda Deep Green #173D2A
+  Secondary Accent: Yoda Green #5DC98F，仅用于一个关键节点或数字
 Visual Elements:
-  - 真实 Yoda 产品截图、用户现场、活动照片、访谈或数据证据优先于图库照片
-  - 使用细线流程图、简洁箭头、少量圆角底板和大数字，不使用 3D 插画或装饰性图标堆叠
-  - 图表弱化坐标轴，直接标注趋势、口径和结论
-  - 每页最多一个主视觉；照片保持真实色彩，只做必要裁切和轻微降饱和
+  - 真实产品截图、真实用户现场和真实数据优先
+  - 只使用细线、少量色块、流程轨道和大数字
+  - 每页最多一个主视觉；圆角底板最多一块
+  - 不使用图标墙、胶囊标签堆叠、装饰性箭头、阴影卡片阵列或复杂坐标轴
 Density Guidelines:
-  - Content per slide: 一个核心观点，标题 + 最多 2–3 个支撑点；数据页允许 3–5 个关键数字
-  - Whitespace: 四周至少保留 12%–15% 安全边距，主视觉与文字之间保持明显呼吸感
+  - 每页一个结论，最多 2 个支撑层级
+  - 四周保留 80–100px 安全边距
+  - 页面至少 40% 留白
 Style Rules:
-  Do: 标题直接写结论；优先使用真实证据；保持 16:9；统一左对齐或明确的中心对齐；所有小字确保可读；每个数字附口径或日期
-  Don't: 不使用深色满版背景；不堆复杂坐标轴；不使用无关图库人物；不编造客户、订单、留存或收入；不把 Agent 团队写成产品类别；不使用发光、玻璃拟态、过多描边和装饰线
+  Do: 标题直接表达结论；每页为口头讲述提供一个视觉锚点；明确数据日期与证据边界
+  Don't: 不伪造产品 UI、客户、订单、留存或收入；不重复解释 Agent 团队；不让技术名词成为标题主体；不使用深色满版背景
 &lt;/STYLE_INSTRUCTIONS&gt;
 ## SLIDE CONTENT
-## Slide 10 of 18
+## Slide 10 of 13
 **Type**: Content
-**Filename**: 10-slide-market-entry.png
+**Filename**: 10-slide-differentiation.png
 // NARRATIVE GOAL
-解释用户定位的层次：超级开发者是最锋利的入口，而不是把 Yoda 锁死在开发者市场。
+让投资人理解竞争边界和差异化，不列竞品 Logo 墙。
 // KEY CONTENT
-Headline: 超级开发者是入口，所有 AI 原生创作者是终局
-Sub-headline: 市场边界不由“会不会编程”决定，而由“是否持续驾驭 AI 完成真实成果”决定
+Headline: Yoda 不卷模型，也不把 Agent 团队当产品终局
+Sub-headline: Yoda 占据跨客户端组织工作、沉淀资产与完成交付的 Harness 层
 Body:
-- 核心：超级开发者
-- 辐射：内容创作者、广义 Coding 用户、AI 原生个人与团队
-- 扩展：高校、培训机构与 AI 原生组织
+- 供应商中立：31 种 Agent Client
+- 资产沉淀：Skills、Memory、工作流
+- 交付闭环：Review、Test、CI/CD、Release
 // VISUAL
-三个由内向外扩展的同心层：中心小而高亮，外围逐步扩大；避免传统用户画像头像，使用真实作品类型的小缩略图作为外围语义。
+三层结构中只高亮 Yoda Harness；右侧三条差异化证据，不使用竞品 Logo。
 // LAYOUT
-Layout: hierarchical-layers
-同心结构居右，左侧标题与一句市场判断；每层只保留一个短标签。
+Layout: layered-comparison
 ## Production Note
 +Render with deterministic HTML/CSS/SVG composition so Chinese text, data values, citations and evidence boundaries remain exact. Rasterize the final 1600 × 900 canvas to PNG.
 </a:t>
@@ -1061,50 +1058,51 @@
 - The source skill's generic hand-drawn rule is intentionally overridden by this deck's confirmed custom investor style and the user's request for real evidence.
 ## STYLE_INSTRUCTIONS
 &lt;STYLE_INSTRUCTIONS&gt;
-Design Aesthetic: 苹果发布会式清晰度、咨询报告式可信度与创业团队真实感的结合。整体采用暖白、暖灰背景和精确的现代几何排版，只使用 Yoda 绿作为品牌强调色；每页用一句结论统领一个观点，让真实截图、数据或流程承担主要叙事。
+Design Aesthetic: 简单、具体、可信，带一点野心。像优秀种子轮融资材料，而不是产品功能说明书。使用苹果发布会式的清晰度、咨询报告式的证据意识和创业团队的真实感。
 Background:
-  Texture: clean，纯色背景，无纸张纹理、渐变噪点或装饰图案
-  Base Color: 暖白 #F7F5F0 为主，暖灰 #E9E9E6 用于分区和数据底板
+  Texture: clean，纯色，无纹理、网格、渐变或装饰背景
+  Base Color: 暖白 #F7F6F2；只在少数对比页使用极浅暖灰 #EFEEE9
 Typography:
-  Headlines: 粗体几何无衬线，笔画干净、结构克制、尺度强烈；中文视觉接近现代黑体
-  Body: 清晰现代无衬线，适合屏幕阅读；正文视觉尺寸不小于 20pt，数字可用等宽特征增强可信度
+  Headlines: 现代粗体无衬线，结论式标题，54–72px，严格控制在两行内
+  Body: 现代无衬线，24–30px；脚注可缩小但必须清晰
+  Numbers: 大号、直接、附口径，不放在多层卡片中
 Color Palette:
-  Primary Text: 墨黑 #111111 - 标题、关键结论和核心数字
-  Background: 暖白 #F7F5F0 - 主要画布
-  Surface: 暖灰 #E9E9E6 - 卡片、对照区和数据底板
-  Accent 1: Yoda Green #5DC98F - 唯一品牌强调色，用于关键节点、箭头和数字
-  Secondary Text: 中灰 #71717A - 注释、来源和非核心信息
+  Primary Text: #111111
+  Secondary Text: #62645F
+  Hairline: #D7D6D0
+  Brand Accent: Yoda Deep Green #173D2A
+  Secondary Accent: Yoda Green #5DC98F，仅用于一个关键节点或数字
 Visual Elements:
-  - 真实 Yoda 产品截图、用户现场、活动照片、访谈或数据证据优先于图库照片
-  - 使用细线流程图、简洁箭头、少量圆角底板和大数字，不使用 3D 插画或装饰性图标堆叠
-  - 图表弱化坐标轴，直接标注趋势、口径和结论
-  - 每页最多一个主视觉；照片保持真实色彩，只做必要裁切和轻微降饱和
+  - 真实产品截图、真实用户现场和真实数据优先
+  - 只使用细线、少量色块、流程轨道和大数字
+  - 每页最多一个主视觉；圆角底板最多一块
+  - 不使用图标墙、胶囊标签堆叠、装饰性箭头、阴影卡片阵列或复杂坐标轴
 Density Guidelines:
-  - Content per slide: 一个核心观点，标题 + 最多 2–3 个支撑点；数据页允许 3–5 个关键数字
-  - Whitespace: 四周至少保留 12%–15% 安全边距，主视觉与文字之间保持明显呼吸感
+  - 每页一个结论，最多 2 个支撑层级
+  - 四周保留 80–100px 安全边距
+  - 页面至少 40% 留白
 Style Rules:
-  Do: 标题直接写结论；优先使用真实证据；保持 16:9；统一左对齐或明确的中心对齐；所有小字确保可读；每个数字附口径或日期
-  Don't: 不使用深色满版背景；不堆复杂坐标轴；不使用无关图库人物；不编造客户、订单、留存或收入；不把 Agent 团队写成产品类别；不使用发光、玻璃拟态、过多描边和装饰线
+  Do: 标题直接表达结论；每页为口头讲述提供一个视觉锚点；明确数据日期与证据边界
+  Don't: 不伪造产品 UI、客户、订单、留存或收入；不重复解释 Agent 团队；不让技术名词成为标题主体；不使用深色满版背景
 &lt;/STYLE_INSTRUCTIONS&gt;
 ## SLIDE CONTENT
-## Slide 11 of 18
+## Slide 11 of 13
 **Type**: Content
-**Filename**: 11-slide-market-size.png
+**Filename**: 11-slide-growth.png
 // NARRATIVE GOAL
-用透明口径表达市场天花板与经营目标，不把创作者经济总产值冒充软件收入。
+把 18–24 个月计划压缩为四个可验证阶段。
 // KEY CONTENT
-Headline: 创作者工具市场提供 248 亿美元理论 TAM
-Sub-headline: 先从 AI 原生创作者切入，再用真实付费持续校准市场边界
+Headline: 下一阶段只验证一件事：可重复增长
+Sub-headline: 先做实体验与数据，再验证个人付费和机构年约
 Body:
-- TAM：248 亿美元/年 = 2.07 亿创作者 × 120 美元年费
-- SAM：24.8 亿美元/年 = TAM × 10% 近期适配率
-- 三年 SOM：240 万美元 ARR = 2 万付费账户 × 120 美元年费
-- 来源：Visa 2025 Creator Report；适配率与价格为待验证假设
+- 0–3 月：体验、埋点、20 位深访
+- 4–6 月：自然增长、2–3 家设计伙伴
+- 7–12 月：个人付费与机构试点
+- 13–24 月：机构年约、渠道与英文市场
 // VISUAL
-三个由大到小的数字区块横向排列，TAM 最大、SAM 次之、SOM 最小；用细小公式直接展示口径，不使用夸张漏斗或全球地图。
+一条四阶段时间轴；每段只有阶段名、目标和一个关键验证信号。
 // LAYOUT
-Layout: three-columns
-每列仅包含数字、名称、公式一行；底部统一放来源和“理论上限/假设/经营目标”标签。
+Layout: timeline-horizontal
 ## Production Note
 +Render with deterministic HTML/CSS/SVG composition so Chinese text, data values, citations and evidence boundaries remain exact. Rasterize the final 1600 × 900 canvas to PNG.
 </a:t>
@@ -1288,49 +1286,50 @@
 - The source skill's generic hand-drawn rule is intentionally overridden by this deck's confirmed custom investor style and the user's request for real evidence.
 ## STYLE_INSTRUCTIONS
 &lt;STYLE_INSTRUCTIONS&gt;
-Design Aesthetic: 苹果发布会式清晰度、咨询报告式可信度与创业团队真实感的结合。整体采用暖白、暖灰背景和精确的现代几何排版，只使用 Yoda 绿作为品牌强调色；每页用一句结论统领一个观点，让真实截图、数据或流程承担主要叙事。
+Design Aesthetic: 简单、具体、可信，带一点野心。像优秀种子轮融资材料，而不是产品功能说明书。使用苹果发布会式的清晰度、咨询报告式的证据意识和创业团队的真实感。
 Background:
-  Texture: clean，纯色背景，无纸张纹理、渐变噪点或装饰图案
-  Base Color: 暖白 #F7F5F0 为主，暖灰 #E9E9E6 用于分区和数据底板
+  Texture: clean，纯色，无纹理、网格、渐变或装饰背景
+  Base Color: 暖白 #F7F6F2；只在少数对比页使用极浅暖灰 #EFEEE9
 Typography:
-  Headlines: 粗体几何无衬线，笔画干净、结构克制、尺度强烈；中文视觉接近现代黑体
-  Body: 清晰现代无衬线，适合屏幕阅读；正文视觉尺寸不小于 20pt，数字可用等宽特征增强可信度
+  Headlines: 现代粗体无衬线，结论式标题，54–72px，严格控制在两行内
+  Body: 现代无衬线，24–30px；脚注可缩小但必须清晰
+  Numbers: 大号、直接、附口径，不放在多层卡片中
 Color Palette:
-  Primary Text: 墨黑 #111111 - 标题、关键结论和核心数字
-  Background: 暖白 #F7F5F0 - 主要画布
-  Surface: 暖灰 #E9E9E6 - 卡片、对照区和数据底板
-  Accent 1: Yoda Green #5DC98F - 唯一品牌强调色，用于关键节点、箭头和数字
-  Secondary Text: 中灰 #71717A - 注释、来源和非核心信息
+  Primary Text: #111111
+  Secondary Text: #62645F
+  Hairline: #D7D6D0
+  Brand Accent: Yoda Deep Green #173D2A
+  Secondary Accent: Yoda Green #5DC98F，仅用于一个关键节点或数字
 Visual Elements:
-  - 真实 Yoda 产品截图、用户现场、活动照片、访谈或数据证据优先于图库照片
-  - 使用细线流程图、简洁箭头、少量圆角底板和大数字，不使用 3D 插画或装饰性图标堆叠
-  - 图表弱化坐标轴，直接标注趋势、口径和结论
-  - 每页最多一个主视觉；照片保持真实色彩，只做必要裁切和轻微降饱和
+  - 真实产品截图、真实用户现场和真实数据优先
+  - 只使用细线、少量色块、流程轨道和大数字
+  - 每页最多一个主视觉；圆角底板最多一块
+  - 不使用图标墙、胶囊标签堆叠、装饰性箭头、阴影卡片阵列或复杂坐标轴
 Density Guidelines:
-  - Content per slide: 一个核心观点，标题 + 最多 2–3 个支撑点；数据页允许 3–5 个关键数字
-  - Whitespace: 四周至少保留 12%–15% 安全边距，主视觉与文字之间保持明显呼吸感
+  - 每页一个结论，最多 2 个支撑层级
+  - 四周保留 80–100px 安全边距
+  - 页面至少 40% 留白
 Style Rules:
-  Do: 标题直接写结论；优先使用真实证据；保持 16:9；统一左对齐或明确的中心对齐；所有小字确保可读；每个数字附口径或日期
-  Don't: 不使用深色满版背景；不堆复杂坐标轴；不使用无关图库人物；不编造客户、订单、留存或收入；不把 Agent 团队写成产品类别；不使用发光、玻璃拟态、过多描边和装饰线
+  Do: 标题直接表达结论；每页为口头讲述提供一个视觉锚点；明确数据日期与证据边界
+  Don't: 不伪造产品 UI、客户、订单、留存或收入；不重复解释 Agent 团队；不让技术名词成为标题主体；不使用深色满版背景
 &lt;/STYLE_INSTRUCTIONS&gt;
 ## SLIDE CONTENT
-## Slide 12 of 18
+## Slide 12 of 13
 **Type**: Content
-**Filename**: 12-slide-competition.png
+**Filename**: 12-slide-team.png
 // NARRATIVE GOAL
-澄清竞争边界：Yoda 不与模型、单一 IDE 或 Agent 团队产品争夺同一个位置。
+用真实执行数据证明 Founder–Product Fit。
 // KEY CONTENT
-Headline: Yoda 不与模型或 Agent 团队正面竞争
-Sub-headline: 模型和 Agent 是执行能力，Yoda 是跨工具组织工作与积累资产的 Harness 层
+Headline: Yoda 用 Yoda 开发自己，迭代速度就是第一份背书
+Sub-headline: 创始人长期横跨开发工具、内容创作与 AI 产品化
 Body:
-- 下层：GPT、Claude、Codex 等模型与 MaaS
-- 中层：Agent IDE/CLI、云端 Agent、多 Agent 团队
-- 上层：Yoda 统一上下文、流程、治理与交付
+- 1,645 次 main 提交
+- 73 个公开 Release
+- 31 种 Agent Client 适配
 // VISUAL
-产业栈分层图而非传统竞品表。最底层是模型，中层是多种执行方式，最上层是一条跨供应商的 Yoda Harness；右侧标注竞争楔子“供应商中立 + 持续资产 + 交付闭环”。
+左侧真实分享现场照片；右侧一句结论和三个无底板大数字。
 // LAYOUT
-Layout: hierarchical-layers
-三层纵向结构，Yoda 层使用绿色，其他层为暖灰；不使用竞品 Logo 墙。
+Layout: split-screen
 ## Production Note
 +Render with deterministic HTML/CSS/SVG composition so Chinese text, data values, citations and evidence boundaries remain exact. Rasterize the final 1600 × 900 canvas to PNG.
 </a:t>
@@ -1514,49 +1513,51 @@
 - The source skill's generic hand-drawn rule is intentionally overridden by this deck's confirmed custom investor style and the user's request for real evidence.
 ## STYLE_INSTRUCTIONS
 &lt;STYLE_INSTRUCTIONS&gt;
-Design Aesthetic: 苹果发布会式清晰度、咨询报告式可信度与创业团队真实感的结合。整体采用暖白、暖灰背景和精确的现代几何排版，只使用 Yoda 绿作为品牌强调色；每页用一句结论统领一个观点，让真实截图、数据或流程承担主要叙事。
+Design Aesthetic: 简单、具体、可信，带一点野心。像优秀种子轮融资材料，而不是产品功能说明书。使用苹果发布会式的清晰度、咨询报告式的证据意识和创业团队的真实感。
 Background:
-  Texture: clean，纯色背景，无纸张纹理、渐变噪点或装饰图案
-  Base Color: 暖白 #F7F5F0 为主，暖灰 #E9E9E6 用于分区和数据底板
+  Texture: clean，纯色，无纹理、网格、渐变或装饰背景
+  Base Color: 暖白 #F7F6F2；只在少数对比页使用极浅暖灰 #EFEEE9
 Typography:
-  Headlines: 粗体几何无衬线，笔画干净、结构克制、尺度强烈；中文视觉接近现代黑体
-  Body: 清晰现代无衬线，适合屏幕阅读；正文视觉尺寸不小于 20pt，数字可用等宽特征增强可信度
+  Headlines: 现代粗体无衬线，结论式标题，54–72px，严格控制在两行内
+  Body: 现代无衬线，24–30px；脚注可缩小但必须清晰
+  Numbers: 大号、直接、附口径，不放在多层卡片中
 Color Palette:
-  Primary Text: 墨黑 #111111 - 标题、关键结论和核心数字
-  Background: 暖白 #F7F5F0 - 主要画布
-  Surface: 暖灰 #E9E9E6 - 卡片、对照区和数据底板
-  Accent 1: Yoda Green #5DC98F - 唯一品牌强调色，用于关键节点、箭头和数字
-  Secondary Text: 中灰 #71717A - 注释、来源和非核心信息
+  Primary Text: #111111
+  Secondary Text: #62645F
+  Hairline: #D7D6D0
+  Brand Accent: Yoda Deep Green #173D2A
+  Secondary Accent: Yoda Green #5DC98F，仅用于一个关键节点或数字
 Visual Elements:
-  - 真实 Yoda 产品截图、用户现场、活动照片、访谈或数据证据优先于图库照片
-  - 使用细线流程图、简洁箭头、少量圆角底板和大数字，不使用 3D 插画或装饰性图标堆叠
-  - 图表弱化坐标轴，直接标注趋势、口径和结论
-  - 每页最多一个主视觉；照片保持真实色彩，只做必要裁切和轻微降饱和
+  - 真实产品截图、真实用户现场和真实数据优先
+  - 只使用细线、少量色块、流程轨道和大数字
+  - 每页最多一个主视觉；圆角底板最多一块
+  - 不使用图标墙、胶囊标签堆叠、装饰性箭头、阴影卡片阵列或复杂坐标轴
 Density Guidelines:
-  - Content per slide: 一个核心观点，标题 + 最多 2–3 个支撑点；数据页允许 3–5 个关键数字
-  - Whitespace: 四周至少保留 12%–15% 安全边距，主视觉与文字之间保持明显呼吸感
+  - 每页一个结论，最多 2 个支撑层级
+  - 四周保留 80–100px 安全边距
+  - 页面至少 40% 留白
 Style Rules:
-  Do: 标题直接写结论；优先使用真实证据；保持 16:9；统一左对齐或明确的中心对齐；所有小字确保可读；每个数字附口径或日期
-  Don't: 不使用深色满版背景；不堆复杂坐标轴；不使用无关图库人物；不编造客户、订单、留存或收入；不把 Agent 团队写成产品类别；不使用发光、玻璃拟态、过多描边和装饰线
+  Do: 标题直接表达结论；每页为口头讲述提供一个视觉锚点；明确数据日期与证据边界
+  Don't: 不伪造产品 UI、客户、订单、留存或收入；不重复解释 Agent 团队；不让技术名词成为标题主体；不使用深色满版背景
 &lt;/STYLE_INSTRUCTIONS&gt;
 ## SLIDE CONTENT
-## Slide 13 of 18
-**Type**: Content
-**Filename**: 13-slide-dual-business-model.png
+## Slide 13 of 13
+**Type**: Closing
+**Filename**: 13-slide-fundraise.png
 // NARRATIVE GOAL
-展示商业模式不是单一订阅，也不是定制外包，而是共用产品底座的 C/B 双轨增长。
+清楚给出融资条件、用途和本轮资金要买到的结果。
 // KEY CONTENT
-Headline: C 端口碑与 B 端年约，共用同一套 Harness 底座
-Sub-headline: 个人用户提供产品反馈和传播，机构客户提供更高客单价与稳定年度收入
+Headline: 融资 200 万元，购买 18–24 个月的验证窗口
+Sub-headline: 或 30 万美元，出让 10% 股权
 Body:
-- C 端：开源 Desktop → Relay / Creator Pro → Studio / Marketplace
-- B 端：付费试点 → Education / Organization Edition → 部署、培训、维护与 SLA
-- Apache-2.0 下，收费点不是“允许二开”，而是官方产品化与持续服务
+- 60% 技术研发与产品体验
+- 30% 市场推广
+- 10% 基础设施与运营
+- 下一阶段目标：验证留存、个人付费与机构年约能否形成可重复增长
 // VISUAL
-左右两条路径从同一个 Yoda Harness 底座向上生长，最终分别形成个人经常性收入与机构 ARR；两条路径在产品反馈和模板资产处形成一个小闭环。
+左侧大号融资金额；右侧三条极简资金比例线和最终验证目标。该页直接作为结束页，不追加致谢页。
 // LAYOUT
-Layout: two-columns
-左右等宽，底部共享绿色底座；不画复杂飞轮，仅保留一次反馈回路。
+Layout: closing-ask
 ## Production Note
 +Render with deterministic HTML/CSS/SVG composition so Chinese text, data values, citations and evidence boundaries remain exact. Rasterize the final 1600 × 900 canvas to PNG.
 </a:t>
@@ -1583,1143 +1584,6 @@
             <a:fld id="{F7021451-1387-4CA6-816F-3879F97B5CBC}" type="slidenum">
               <a:rPr lang="en-US"/>
               <a:t>13</a:t>
-            </a:fld>
-            <a:endParaRPr lang="en-US"/>
-          </a:p>
-        </p:txBody>
-      </p:sp>
-    </p:spTree>
-    <p:extLst>
-      <p:ext uri="{BB962C8B-B14F-4D97-AF65-F5344CB8AC3E}">
-        <p14:creationId xmlns:p14="http://schemas.microsoft.com/office/powerpoint/2010/main" val="1024086991"/>
-      </p:ext>
-    </p:extLst>
-  </p:cSld>
-  <p:clrMapOvr>
-    <a:masterClrMapping/>
-  </p:clrMapOvr>
-</p:notes>
-</file>
-
-<file path=ppt/notesSlides/notesSlide14.xml><?xml version="1.0" encoding="utf-8"?>
-<p:notes xmlns:a="http://schemas.openxmlformats.org/drawingml/2006/main" xmlns:r="http://schemas.openxmlformats.org/officeDocument/2006/relationships" xmlns:p="http://schemas.openxmlformats.org/presentationml/2006/main">
-  <p:cSld>
-    <p:spTree>
-      <p:nvGrpSpPr>
-        <p:cNvPr id="1" name=""/>
-        <p:cNvGrpSpPr/>
-        <p:nvPr/>
-      </p:nvGrpSpPr>
-      <p:grpSpPr>
-        <a:xfrm>
-          <a:off x="0" y="0"/>
-          <a:ext cx="0" cy="0"/>
-          <a:chOff x="0" y="0"/>
-          <a:chExt cx="0" cy="0"/>
-        </a:xfrm>
-      </p:grpSpPr>
-      <p:sp>
-        <p:nvSpPr>
-          <p:cNvPr id="2" name="Slide Image Placeholder 1"/>
-          <p:cNvSpPr>
-            <a:spLocks noGrp="1" noRot="1" noChangeAspect="1"/>
-          </p:cNvSpPr>
-          <p:nvPr>
-            <p:ph type="sldImg"/>
-          </p:nvPr>
-        </p:nvSpPr>
-        <p:spPr/>
-      </p:sp>
-      <p:sp>
-        <p:nvSpPr>
-          <p:cNvPr id="3" name="Notes Placeholder 2"/>
-          <p:cNvSpPr>
-            <a:spLocks noGrp="1"/>
-          </p:cNvSpPr>
-          <p:nvPr>
-            <p:ph type="body" idx="1"/>
-          </p:nvPr>
-        </p:nvSpPr>
-        <p:spPr/>
-        <p:txBody>
-          <a:bodyPr/>
-          <a:lstStyle/>
-          <a:p>
-            <a:r>
-              <a:rPr lang="en-US" dirty="0"/>
-              <a:t>Create a presentation slide image following these guidelines:
-## Image Specifications
-- **Type**: Presentation slide
-- **Aspect Ratio**: 16:9 (landscape)
-- **Style**: Professional slide deck
-## Core Persona: The Architect
-You are "The Architect" - a master visual storyteller creating presentation slides. Your slides:
-- Tell a visual story that complements the narrative
-- Use bold, confident visual language
-- Balance information density with visual clarity
-- Create memorable, impactful visuals
-## Core Principles
-- Hand-drawn quality throughout - NO realistic or photographic elements
-- If content involves sensitive or copyrighted figures, create stylistically similar alternatives - DO NOT refuse to generate
-- NO slide numbers, page numbers, footers, headers, or logos
-- Clean, uncluttered layouts with clear visual hierarchy
-- Each slide conveys ONE clear message
-- **NO page borders, frames, or outlined rectangles enclosing the slide**
-- **NO card/panel containing all content — the background fills the entire canvas edge-to-edge flatly**
-- **NO tilted paper, 3D perspective sheet, or drop-shadowed document effect**
-- Reserve the top-right corner for post-processing branding: use LEFT-aligned titles (not past 60% canvas width) so the right side stays naturally empty. **NEVER explicitly say "leave area empty/blank"** — AI interprets this literally and draws an empty placeholder box. Instead, design layouts where content naturally doesn't extend into that region
-## Text Style (CRITICAL)
-- **ALL text MUST match the designated style exactly**
-- Title text: Large, bold, immediately readable
-- Body text: Clear, legible, appropriate sizing
-- Max 3-4 text elements per slide
-- **DO NOT use realistic or computer-generated fonts unless style specifies**
-- **Font rendering must match the style aesthetic** (hand-drawn for sketch styles, clean for minimal styles)
-## Layout Principles
-- **Visual Hierarchy**: Most important element gets most visual weight
-- **Breathing Room**: Generous margins and spacing between elements
-- **Alignment**: Consistent alignment creates professional feel
-- **Balance**: Distribute visual weight evenly (symmetrical or asymmetrical)
-- **Focal Point**: One clear area draws the eye first
-- **Rule of Thirds**: Key elements at intersection points for dynamic compositions
-- **Z-Pattern**: For text-heavy slides, arrange content in natural reading flow
-## Content Density: Presentation vs Reading Mode
-**Presentation mode** (speaker will narrate live):
-- Slides show ONLY visual anchors: charts, diagrams, hero terms, data numbers, key quotes
-- NO explanatory sentences, transition hooks, or narrative captions
-- Speaker delivers context, transitions, and interpretation verbally
-- Example: show "死循环" diagram only, speaker explains why it's a death loop
-**Reading mode** (self-explanatory for sharing):
-- Each slide includes enough context to stand alone without narration
-- Captions, attributions, and brief explanations are appropriate
-- Default mode unless `--presentation` is specified
-## Language
-- Use the same language as the content provided below for all text elements
-- Match punctuation style to the content language
-- Write in direct, confident language
-- Avoid AI-sounding phrases like "dive into", "explore", "let's", "journey"
----
-## STYLE_INSTRUCTIONS
-[Extract from outline.md - do NOT re-read style files]
-The STYLE_INSTRUCTIONS block from the outline contains:
-- Design Aesthetic
-- Background (Texture + Base Color)
-- Typography (Headlines + Body descriptions)
-- Color Palette (with hex codes)
-- Visual Elements
-- Density Guidelines
-- Style Rules (Do/Don't)
-Copy the entire `&lt;STYLE_INSTRUCTIONS&gt;...&lt;/STYLE_INSTRUCTIONS&gt;` block from the outline here.
----
-## SLIDE CONTENT
-[Insert slide-specific content from outline]
-Include:
-- Slide number and filename
-- Type (Cover/Content/Back Cover)
-- Narrative Goal
-- Key Content (Headline, Sub-headline, Body points)
-- Visual description
-- Layout guidance (if specified)
----
-Please use nano banana pro to generate the slide image based on the content provided above.
----
-Create a presentation slide image following these guidelines:
-## Image Specifications
-- Type: Presentation slide
-- Aspect Ratio: 16:9 landscape
-- Canvas: 1600 × 900
-- Mode: Reading and sharing; every slide must stand alone
-- Language: Simplified Chinese
-## Core Principles
-- Convey ONE clear conclusion per slide.
-- Preserve every Chinese phrase and number verbatim.
-- Use exact, clean geometric Chinese typography; body text must visually equal at least 20pt.
-- Use real referenced product/event images faithfully when supplied; do not redraw or fabricate them.
-- Use deterministic flat diagrams, charts and typography for all factual content.
-- No slide numbers, decorative borders, glassmorphism, 3D effects, irrelevant stock photos, watermarks, or invented customer evidence.
-- The source skill's generic hand-drawn rule is intentionally overridden by this deck's confirmed custom investor style and the user's request for real evidence.
-## STYLE_INSTRUCTIONS
-&lt;STYLE_INSTRUCTIONS&gt;
-Design Aesthetic: 苹果发布会式清晰度、咨询报告式可信度与创业团队真实感的结合。整体采用暖白、暖灰背景和精确的现代几何排版，只使用 Yoda 绿作为品牌强调色；每页用一句结论统领一个观点，让真实截图、数据或流程承担主要叙事。
-Background:
-  Texture: clean，纯色背景，无纸张纹理、渐变噪点或装饰图案
-  Base Color: 暖白 #F7F5F0 为主，暖灰 #E9E9E6 用于分区和数据底板
-Typography:
-  Headlines: 粗体几何无衬线，笔画干净、结构克制、尺度强烈；中文视觉接近现代黑体
-  Body: 清晰现代无衬线，适合屏幕阅读；正文视觉尺寸不小于 20pt，数字可用等宽特征增强可信度
-Color Palette:
-  Primary Text: 墨黑 #111111 - 标题、关键结论和核心数字
-  Background: 暖白 #F7F5F0 - 主要画布
-  Surface: 暖灰 #E9E9E6 - 卡片、对照区和数据底板
-  Accent 1: Yoda Green #5DC98F - 唯一品牌强调色，用于关键节点、箭头和数字
-  Secondary Text: 中灰 #71717A - 注释、来源和非核心信息
-Visual Elements:
-  - 真实 Yoda 产品截图、用户现场、活动照片、访谈或数据证据优先于图库照片
-  - 使用细线流程图、简洁箭头、少量圆角底板和大数字，不使用 3D 插画或装饰性图标堆叠
-  - 图表弱化坐标轴，直接标注趋势、口径和结论
-  - 每页最多一个主视觉；照片保持真实色彩，只做必要裁切和轻微降饱和
-Density Guidelines:
-  - Content per slide: 一个核心观点，标题 + 最多 2–3 个支撑点；数据页允许 3–5 个关键数字
-  - Whitespace: 四周至少保留 12%–15% 安全边距，主视觉与文字之间保持明显呼吸感
-Style Rules:
-  Do: 标题直接写结论；优先使用真实证据；保持 16:9；统一左对齐或明确的中心对齐；所有小字确保可读；每个数字附口径或日期
-  Don't: 不使用深色满版背景；不堆复杂坐标轴；不使用无关图库人物；不编造客户、订单、留存或收入；不把 Agent 团队写成产品类别；不使用发光、玻璃拟态、过多描边和装饰线
-&lt;/STYLE_INSTRUCTIONS&gt;
-## SLIDE CONTENT
-## Slide 14 of 18
-**Type**: Content
-**Filename**: 14-slide-education-wedge.png
-// NARRATIVE GOAL
-把高校教育从泛泛的 B 端想象落实为具体买方、交付包与付费验证路径。
-// KEY CONTENT
-Headline: 高校教育是最清晰的 B 端切口
-Sub-headline: 学校需要的不是另一个聊天框，而是统一实践环境、课程资产、治理边界与持续支持
-Body:
-- 一门课程 / 一个实验室 / 一期训练营的付费试点
-- Yoda Education：桌面端 + 机构配置 + 课程模板 + 管理能力 + 教师培训
-- 试点验收后转机构年约，再扩展学院、校区或部门
-// VISUAL
-左侧使用“手工川 AI 创造营 EP03”真实活动照片的干净裁切，右侧是一条三阶段销售路径“付费试点 → 标准产品包 → 机构年约”。照片注明“创作者培训现场，仅作场景与渠道证明，不是 Yoda 客户案例”。
-// LAYOUT
-Layout: split-screen
-照片约占 45%，流程约占 55%；明确证据边界，避免把活动参与者包装成客户。
-## Production Note
-+Render with deterministic HTML/CSS/SVG composition so Chinese text, data values, citations and evidence boundaries remain exact. Rasterize the final 1600 × 900 canvas to PNG.
-</a:t>
-            </a:r>
-            <a:endParaRPr lang="en-US" dirty="0"/>
-          </a:p>
-        </p:txBody>
-      </p:sp>
-      <p:sp>
-        <p:nvSpPr>
-          <p:cNvPr id="4" name="Slide Number Placeholder 3"/>
-          <p:cNvSpPr>
-            <a:spLocks noGrp="1"/>
-          </p:cNvSpPr>
-          <p:nvPr>
-            <p:ph type="sldNum" sz="quarter" idx="10"/>
-          </p:nvPr>
-        </p:nvSpPr>
-        <p:spPr/>
-        <p:txBody>
-          <a:bodyPr/>
-          <a:lstStyle/>
-          <a:p>
-            <a:fld id="{F7021451-1387-4CA6-816F-3879F97B5CBC}" type="slidenum">
-              <a:rPr lang="en-US"/>
-              <a:t>14</a:t>
-            </a:fld>
-            <a:endParaRPr lang="en-US"/>
-          </a:p>
-        </p:txBody>
-      </p:sp>
-    </p:spTree>
-    <p:extLst>
-      <p:ext uri="{BB962C8B-B14F-4D97-AF65-F5344CB8AC3E}">
-        <p14:creationId xmlns:p14="http://schemas.microsoft.com/office/powerpoint/2010/main" val="1024086991"/>
-      </p:ext>
-    </p:extLst>
-  </p:cSld>
-  <p:clrMapOvr>
-    <a:masterClrMapping/>
-  </p:clrMapOvr>
-</p:notes>
-</file>
-
-<file path=ppt/notesSlides/notesSlide15.xml><?xml version="1.0" encoding="utf-8"?>
-<p:notes xmlns:a="http://schemas.openxmlformats.org/drawingml/2006/main" xmlns:r="http://schemas.openxmlformats.org/officeDocument/2006/relationships" xmlns:p="http://schemas.openxmlformats.org/presentationml/2006/main">
-  <p:cSld>
-    <p:spTree>
-      <p:nvGrpSpPr>
-        <p:cNvPr id="1" name=""/>
-        <p:cNvGrpSpPr/>
-        <p:nvPr/>
-      </p:nvGrpSpPr>
-      <p:grpSpPr>
-        <a:xfrm>
-          <a:off x="0" y="0"/>
-          <a:ext cx="0" cy="0"/>
-          <a:chOff x="0" y="0"/>
-          <a:chExt cx="0" cy="0"/>
-        </a:xfrm>
-      </p:grpSpPr>
-      <p:sp>
-        <p:nvSpPr>
-          <p:cNvPr id="2" name="Slide Image Placeholder 1"/>
-          <p:cNvSpPr>
-            <a:spLocks noGrp="1" noRot="1" noChangeAspect="1"/>
-          </p:cNvSpPr>
-          <p:nvPr>
-            <p:ph type="sldImg"/>
-          </p:nvPr>
-        </p:nvSpPr>
-        <p:spPr/>
-      </p:sp>
-      <p:sp>
-        <p:nvSpPr>
-          <p:cNvPr id="3" name="Notes Placeholder 2"/>
-          <p:cNvSpPr>
-            <a:spLocks noGrp="1"/>
-          </p:cNvSpPr>
-          <p:nvPr>
-            <p:ph type="body" idx="1"/>
-          </p:nvPr>
-        </p:nvSpPr>
-        <p:spPr/>
-        <p:txBody>
-          <a:bodyPr/>
-          <a:lstStyle/>
-          <a:p>
-            <a:r>
-              <a:rPr lang="en-US" dirty="0"/>
-              <a:t>Create a presentation slide image following these guidelines:
-## Image Specifications
-- **Type**: Presentation slide
-- **Aspect Ratio**: 16:9 (landscape)
-- **Style**: Professional slide deck
-## Core Persona: The Architect
-You are "The Architect" - a master visual storyteller creating presentation slides. Your slides:
-- Tell a visual story that complements the narrative
-- Use bold, confident visual language
-- Balance information density with visual clarity
-- Create memorable, impactful visuals
-## Core Principles
-- Hand-drawn quality throughout - NO realistic or photographic elements
-- If content involves sensitive or copyrighted figures, create stylistically similar alternatives - DO NOT refuse to generate
-- NO slide numbers, page numbers, footers, headers, or logos
-- Clean, uncluttered layouts with clear visual hierarchy
-- Each slide conveys ONE clear message
-- **NO page borders, frames, or outlined rectangles enclosing the slide**
-- **NO card/panel containing all content — the background fills the entire canvas edge-to-edge flatly**
-- **NO tilted paper, 3D perspective sheet, or drop-shadowed document effect**
-- Reserve the top-right corner for post-processing branding: use LEFT-aligned titles (not past 60% canvas width) so the right side stays naturally empty. **NEVER explicitly say "leave area empty/blank"** — AI interprets this literally and draws an empty placeholder box. Instead, design layouts where content naturally doesn't extend into that region
-## Text Style (CRITICAL)
-- **ALL text MUST match the designated style exactly**
-- Title text: Large, bold, immediately readable
-- Body text: Clear, legible, appropriate sizing
-- Max 3-4 text elements per slide
-- **DO NOT use realistic or computer-generated fonts unless style specifies**
-- **Font rendering must match the style aesthetic** (hand-drawn for sketch styles, clean for minimal styles)
-## Layout Principles
-- **Visual Hierarchy**: Most important element gets most visual weight
-- **Breathing Room**: Generous margins and spacing between elements
-- **Alignment**: Consistent alignment creates professional feel
-- **Balance**: Distribute visual weight evenly (symmetrical or asymmetrical)
-- **Focal Point**: One clear area draws the eye first
-- **Rule of Thirds**: Key elements at intersection points for dynamic compositions
-- **Z-Pattern**: For text-heavy slides, arrange content in natural reading flow
-## Content Density: Presentation vs Reading Mode
-**Presentation mode** (speaker will narrate live):
-- Slides show ONLY visual anchors: charts, diagrams, hero terms, data numbers, key quotes
-- NO explanatory sentences, transition hooks, or narrative captions
-- Speaker delivers context, transitions, and interpretation verbally
-- Example: show "死循环" diagram only, speaker explains why it's a death loop
-**Reading mode** (self-explanatory for sharing):
-- Each slide includes enough context to stand alone without narration
-- Captions, attributions, and brief explanations are appropriate
-- Default mode unless `--presentation` is specified
-## Language
-- Use the same language as the content provided below for all text elements
-- Match punctuation style to the content language
-- Write in direct, confident language
-- Avoid AI-sounding phrases like "dive into", "explore", "let's", "journey"
----
-## STYLE_INSTRUCTIONS
-[Extract from outline.md - do NOT re-read style files]
-The STYLE_INSTRUCTIONS block from the outline contains:
-- Design Aesthetic
-- Background (Texture + Base Color)
-- Typography (Headlines + Body descriptions)
-- Color Palette (with hex codes)
-- Visual Elements
-- Density Guidelines
-- Style Rules (Do/Don't)
-Copy the entire `&lt;STYLE_INSTRUCTIONS&gt;...&lt;/STYLE_INSTRUCTIONS&gt;` block from the outline here.
----
-## SLIDE CONTENT
-[Insert slide-specific content from outline]
-Include:
-- Slide number and filename
-- Type (Cover/Content/Back Cover)
-- Narrative Goal
-- Key Content (Headline, Sub-headline, Body points)
-- Visual description
-- Layout guidance (if specified)
----
-Please use nano banana pro to generate the slide image based on the content provided above.
----
-Create a presentation slide image following these guidelines:
-## Image Specifications
-- Type: Presentation slide
-- Aspect Ratio: 16:9 landscape
-- Canvas: 1600 × 900
-- Mode: Reading and sharing; every slide must stand alone
-- Language: Simplified Chinese
-## Core Principles
-- Convey ONE clear conclusion per slide.
-- Preserve every Chinese phrase and number verbatim.
-- Use exact, clean geometric Chinese typography; body text must visually equal at least 20pt.
-- Use real referenced product/event images faithfully when supplied; do not redraw or fabricate them.
-- Use deterministic flat diagrams, charts and typography for all factual content.
-- No slide numbers, decorative borders, glassmorphism, 3D effects, irrelevant stock photos, watermarks, or invented customer evidence.
-- The source skill's generic hand-drawn rule is intentionally overridden by this deck's confirmed custom investor style and the user's request for real evidence.
-## STYLE_INSTRUCTIONS
-&lt;STYLE_INSTRUCTIONS&gt;
-Design Aesthetic: 苹果发布会式清晰度、咨询报告式可信度与创业团队真实感的结合。整体采用暖白、暖灰背景和精确的现代几何排版，只使用 Yoda 绿作为品牌强调色；每页用一句结论统领一个观点，让真实截图、数据或流程承担主要叙事。
-Background:
-  Texture: clean，纯色背景，无纸张纹理、渐变噪点或装饰图案
-  Base Color: 暖白 #F7F5F0 为主，暖灰 #E9E9E6 用于分区和数据底板
-Typography:
-  Headlines: 粗体几何无衬线，笔画干净、结构克制、尺度强烈；中文视觉接近现代黑体
-  Body: 清晰现代无衬线，适合屏幕阅读；正文视觉尺寸不小于 20pt，数字可用等宽特征增强可信度
-Color Palette:
-  Primary Text: 墨黑 #111111 - 标题、关键结论和核心数字
-  Background: 暖白 #F7F5F0 - 主要画布
-  Surface: 暖灰 #E9E9E6 - 卡片、对照区和数据底板
-  Accent 1: Yoda Green #5DC98F - 唯一品牌强调色，用于关键节点、箭头和数字
-  Secondary Text: 中灰 #71717A - 注释、来源和非核心信息
-Visual Elements:
-  - 真实 Yoda 产品截图、用户现场、活动照片、访谈或数据证据优先于图库照片
-  - 使用细线流程图、简洁箭头、少量圆角底板和大数字，不使用 3D 插画或装饰性图标堆叠
-  - 图表弱化坐标轴，直接标注趋势、口径和结论
-  - 每页最多一个主视觉；照片保持真实色彩，只做必要裁切和轻微降饱和
-Density Guidelines:
-  - Content per slide: 一个核心观点，标题 + 最多 2–3 个支撑点；数据页允许 3–5 个关键数字
-  - Whitespace: 四周至少保留 12%–15% 安全边距，主视觉与文字之间保持明显呼吸感
-Style Rules:
-  Do: 标题直接写结论；优先使用真实证据；保持 16:9；统一左对齐或明确的中心对齐；所有小字确保可读；每个数字附口径或日期
-  Don't: 不使用深色满版背景；不堆复杂坐标轴；不使用无关图库人物；不编造客户、订单、留存或收入；不把 Agent 团队写成产品类别；不使用发光、玻璃拟态、过多描边和装饰线
-&lt;/STYLE_INSTRUCTIONS&gt;
-## SLIDE CONTENT
-## Slide 15 of 18
-**Type**: Content
-**Filename**: 15-slide-early-traction.png
-// NARRATIVE GOAL
-诚实呈现早期使用信号与商业化起点，让投资人区分产品活跃、登录漏斗和付费验证。
-// KEY CONTENT
-Headline: 产品已获得早期使用，付费验证仍在起点
-Sub-headline: 当前数据证明有人下载、Clone 和授权，但尚不能证明留存与商业模式成立
-Body:
-- 50 Stars · 18 Forks · 73 个公开 Release
-- 最近 14 天：426 次 Clone · 126 个独立 Cloner
-- 73 个独立授权用户；Relay 3 个试用账户、0 个付费
-- 数据截至：GitHub 2026-07-22；账号与 Relay 2026-07-21
-// VISUAL
-左侧“使用信号”放 4 个大数字，右侧“尚未验证”只放三项：D7/D30 留存、作品完成率、付费续约。0 付费用黑色大数字而非藏在脚注，形成诚实可信的反差。
-// LAYOUT
-Layout: dashboard
-仪表盘极简化，无图标；数字和日期占主导，右下保留“非去重下载/机器请求不计入用户”口径说明。
-## Production Note
-+Render with deterministic HTML/CSS/SVG composition so Chinese text, data values, citations and evidence boundaries remain exact. Rasterize the final 1600 × 900 canvas to PNG.
-</a:t>
-            </a:r>
-            <a:endParaRPr lang="en-US" dirty="0"/>
-          </a:p>
-        </p:txBody>
-      </p:sp>
-      <p:sp>
-        <p:nvSpPr>
-          <p:cNvPr id="4" name="Slide Number Placeholder 3"/>
-          <p:cNvSpPr>
-            <a:spLocks noGrp="1"/>
-          </p:cNvSpPr>
-          <p:nvPr>
-            <p:ph type="sldNum" sz="quarter" idx="10"/>
-          </p:nvPr>
-        </p:nvSpPr>
-        <p:spPr/>
-        <p:txBody>
-          <a:bodyPr/>
-          <a:lstStyle/>
-          <a:p>
-            <a:fld id="{F7021451-1387-4CA6-816F-3879F97B5CBC}" type="slidenum">
-              <a:rPr lang="en-US"/>
-              <a:t>15</a:t>
-            </a:fld>
-            <a:endParaRPr lang="en-US"/>
-          </a:p>
-        </p:txBody>
-      </p:sp>
-    </p:spTree>
-    <p:extLst>
-      <p:ext uri="{BB962C8B-B14F-4D97-AF65-F5344CB8AC3E}">
-        <p14:creationId xmlns:p14="http://schemas.microsoft.com/office/powerpoint/2010/main" val="1024086991"/>
-      </p:ext>
-    </p:extLst>
-  </p:cSld>
-  <p:clrMapOvr>
-    <a:masterClrMapping/>
-  </p:clrMapOvr>
-</p:notes>
-</file>
-
-<file path=ppt/notesSlides/notesSlide16.xml><?xml version="1.0" encoding="utf-8"?>
-<p:notes xmlns:a="http://schemas.openxmlformats.org/drawingml/2006/main" xmlns:r="http://schemas.openxmlformats.org/officeDocument/2006/relationships" xmlns:p="http://schemas.openxmlformats.org/presentationml/2006/main">
-  <p:cSld>
-    <p:spTree>
-      <p:nvGrpSpPr>
-        <p:cNvPr id="1" name=""/>
-        <p:cNvGrpSpPr/>
-        <p:nvPr/>
-      </p:nvGrpSpPr>
-      <p:grpSpPr>
-        <a:xfrm>
-          <a:off x="0" y="0"/>
-          <a:ext cx="0" cy="0"/>
-          <a:chOff x="0" y="0"/>
-          <a:chExt cx="0" cy="0"/>
-        </a:xfrm>
-      </p:grpSpPr>
-      <p:sp>
-        <p:nvSpPr>
-          <p:cNvPr id="2" name="Slide Image Placeholder 1"/>
-          <p:cNvSpPr>
-            <a:spLocks noGrp="1" noRot="1" noChangeAspect="1"/>
-          </p:cNvSpPr>
-          <p:nvPr>
-            <p:ph type="sldImg"/>
-          </p:nvPr>
-        </p:nvSpPr>
-        <p:spPr/>
-      </p:sp>
-      <p:sp>
-        <p:nvSpPr>
-          <p:cNvPr id="3" name="Notes Placeholder 2"/>
-          <p:cNvSpPr>
-            <a:spLocks noGrp="1"/>
-          </p:cNvSpPr>
-          <p:nvPr>
-            <p:ph type="body" idx="1"/>
-          </p:nvPr>
-        </p:nvSpPr>
-        <p:spPr/>
-        <p:txBody>
-          <a:bodyPr/>
-          <a:lstStyle/>
-          <a:p>
-            <a:r>
-              <a:rPr lang="en-US" dirty="0"/>
-              <a:t>Create a presentation slide image following these guidelines:
-## Image Specifications
-- **Type**: Presentation slide
-- **Aspect Ratio**: 16:9 (landscape)
-- **Style**: Professional slide deck
-## Core Persona: The Architect
-You are "The Architect" - a master visual storyteller creating presentation slides. Your slides:
-- Tell a visual story that complements the narrative
-- Use bold, confident visual language
-- Balance information density with visual clarity
-- Create memorable, impactful visuals
-## Core Principles
-- Hand-drawn quality throughout - NO realistic or photographic elements
-- If content involves sensitive or copyrighted figures, create stylistically similar alternatives - DO NOT refuse to generate
-- NO slide numbers, page numbers, footers, headers, or logos
-- Clean, uncluttered layouts with clear visual hierarchy
-- Each slide conveys ONE clear message
-- **NO page borders, frames, or outlined rectangles enclosing the slide**
-- **NO card/panel containing all content — the background fills the entire canvas edge-to-edge flatly**
-- **NO tilted paper, 3D perspective sheet, or drop-shadowed document effect**
-- Reserve the top-right corner for post-processing branding: use LEFT-aligned titles (not past 60% canvas width) so the right side stays naturally empty. **NEVER explicitly say "leave area empty/blank"** — AI interprets this literally and draws an empty placeholder box. Instead, design layouts where content naturally doesn't extend into that region
-## Text Style (CRITICAL)
-- **ALL text MUST match the designated style exactly**
-- Title text: Large, bold, immediately readable
-- Body text: Clear, legible, appropriate sizing
-- Max 3-4 text elements per slide
-- **DO NOT use realistic or computer-generated fonts unless style specifies**
-- **Font rendering must match the style aesthetic** (hand-drawn for sketch styles, clean for minimal styles)
-## Layout Principles
-- **Visual Hierarchy**: Most important element gets most visual weight
-- **Breathing Room**: Generous margins and spacing between elements
-- **Alignment**: Consistent alignment creates professional feel
-- **Balance**: Distribute visual weight evenly (symmetrical or asymmetrical)
-- **Focal Point**: One clear area draws the eye first
-- **Rule of Thirds**: Key elements at intersection points for dynamic compositions
-- **Z-Pattern**: For text-heavy slides, arrange content in natural reading flow
-## Content Density: Presentation vs Reading Mode
-**Presentation mode** (speaker will narrate live):
-- Slides show ONLY visual anchors: charts, diagrams, hero terms, data numbers, key quotes
-- NO explanatory sentences, transition hooks, or narrative captions
-- Speaker delivers context, transitions, and interpretation verbally
-- Example: show "死循环" diagram only, speaker explains why it's a death loop
-**Reading mode** (self-explanatory for sharing):
-- Each slide includes enough context to stand alone without narration
-- Captions, attributions, and brief explanations are appropriate
-- Default mode unless `--presentation` is specified
-## Language
-- Use the same language as the content provided below for all text elements
-- Match punctuation style to the content language
-- Write in direct, confident language
-- Avoid AI-sounding phrases like "dive into", "explore", "let's", "journey"
----
-## STYLE_INSTRUCTIONS
-[Extract from outline.md - do NOT re-read style files]
-The STYLE_INSTRUCTIONS block from the outline contains:
-- Design Aesthetic
-- Background (Texture + Base Color)
-- Typography (Headlines + Body descriptions)
-- Color Palette (with hex codes)
-- Visual Elements
-- Density Guidelines
-- Style Rules (Do/Don't)
-Copy the entire `&lt;STYLE_INSTRUCTIONS&gt;...&lt;/STYLE_INSTRUCTIONS&gt;` block from the outline here.
----
-## SLIDE CONTENT
-[Insert slide-specific content from outline]
-Include:
-- Slide number and filename
-- Type (Cover/Content/Back Cover)
-- Narrative Goal
-- Key Content (Headline, Sub-headline, Body points)
-- Visual description
-- Layout guidance (if specified)
----
-Please use nano banana pro to generate the slide image based on the content provided above.
----
-Create a presentation slide image following these guidelines:
-## Image Specifications
-- Type: Presentation slide
-- Aspect Ratio: 16:9 landscape
-- Canvas: 1600 × 900
-- Mode: Reading and sharing; every slide must stand alone
-- Language: Simplified Chinese
-## Core Principles
-- Convey ONE clear conclusion per slide.
-- Preserve every Chinese phrase and number verbatim.
-- Use exact, clean geometric Chinese typography; body text must visually equal at least 20pt.
-- Use real referenced product/event images faithfully when supplied; do not redraw or fabricate them.
-- Use deterministic flat diagrams, charts and typography for all factual content.
-- No slide numbers, decorative borders, glassmorphism, 3D effects, irrelevant stock photos, watermarks, or invented customer evidence.
-- The source skill's generic hand-drawn rule is intentionally overridden by this deck's confirmed custom investor style and the user's request for real evidence.
-## STYLE_INSTRUCTIONS
-&lt;STYLE_INSTRUCTIONS&gt;
-Design Aesthetic: 苹果发布会式清晰度、咨询报告式可信度与创业团队真实感的结合。整体采用暖白、暖灰背景和精确的现代几何排版，只使用 Yoda 绿作为品牌强调色；每页用一句结论统领一个观点，让真实截图、数据或流程承担主要叙事。
-Background:
-  Texture: clean，纯色背景，无纸张纹理、渐变噪点或装饰图案
-  Base Color: 暖白 #F7F5F0 为主，暖灰 #E9E9E6 用于分区和数据底板
-Typography:
-  Headlines: 粗体几何无衬线，笔画干净、结构克制、尺度强烈；中文视觉接近现代黑体
-  Body: 清晰现代无衬线，适合屏幕阅读；正文视觉尺寸不小于 20pt，数字可用等宽特征增强可信度
-Color Palette:
-  Primary Text: 墨黑 #111111 - 标题、关键结论和核心数字
-  Background: 暖白 #F7F5F0 - 主要画布
-  Surface: 暖灰 #E9E9E6 - 卡片、对照区和数据底板
-  Accent 1: Yoda Green #5DC98F - 唯一品牌强调色，用于关键节点、箭头和数字
-  Secondary Text: 中灰 #71717A - 注释、来源和非核心信息
-Visual Elements:
-  - 真实 Yoda 产品截图、用户现场、活动照片、访谈或数据证据优先于图库照片
-  - 使用细线流程图、简洁箭头、少量圆角底板和大数字，不使用 3D 插画或装饰性图标堆叠
-  - 图表弱化坐标轴，直接标注趋势、口径和结论
-  - 每页最多一个主视觉；照片保持真实色彩，只做必要裁切和轻微降饱和
-Density Guidelines:
-  - Content per slide: 一个核心观点，标题 + 最多 2–3 个支撑点；数据页允许 3–5 个关键数字
-  - Whitespace: 四周至少保留 12%–15% 安全边距，主视觉与文字之间保持明显呼吸感
-Style Rules:
-  Do: 标题直接写结论；优先使用真实证据；保持 16:9；统一左对齐或明确的中心对齐；所有小字确保可读；每个数字附口径或日期
-  Don't: 不使用深色满版背景；不堆复杂坐标轴；不使用无关图库人物；不编造客户、订单、留存或收入；不把 Agent 团队写成产品类别；不使用发光、玻璃拟态、过多描边和装饰线
-&lt;/STYLE_INSTRUCTIONS&gt;
-## SLIDE CONTENT
-## Slide 16 of 18
-**Type**: Content
-**Filename**: 16-slide-founder-product-fit.png
-// NARRATIVE GOAL
-证明创始人与产品的独特匹配：既是第一重度用户，也是内容、社区与 B 端触达的第一增长渠道。
-// KEY CONTENT
-Headline: Yoda 用 Yoda 开发自己，迭代速度就是第一份背书
-Sub-headline: 创始人手工川长期横跨内容创作、开发工具与 AI 产品化
-Body:
-- 自 2026-05-10 起：1,645 个 main 提交 · 73 个公开 Release · 31 种 Agent Client
-- LovStudio、Lovpen、Lovcode 等产品与 OPC / AI Coding 内容积累
-- 高校、商学院、开发者社区和孵化器触点，为早期设计伙伴提供入口
-// VISUAL
-左侧使用创始人真实工作/分享照片，右侧用一条“内容创作者 → AI 产品创始人 → Yoda 第一用户”的三节点时间线；底部放一张真实 Yoda 开发 Yoda 工作区小截图。不得使用夸张光环或人物抠图海报效果。
-// LAYOUT
-Layout: split-screen
-人物现场照片约 40%，证据与时间线约 60%；所有数字注明统计口径，不写成个人代码量。
-## Production Note
-+Render with deterministic HTML/CSS/SVG composition so Chinese text, data values, citations and evidence boundaries remain exact. Rasterize the final 1600 × 900 canvas to PNG.
-</a:t>
-            </a:r>
-            <a:endParaRPr lang="en-US" dirty="0"/>
-          </a:p>
-        </p:txBody>
-      </p:sp>
-      <p:sp>
-        <p:nvSpPr>
-          <p:cNvPr id="4" name="Slide Number Placeholder 3"/>
-          <p:cNvSpPr>
-            <a:spLocks noGrp="1"/>
-          </p:cNvSpPr>
-          <p:nvPr>
-            <p:ph type="sldNum" sz="quarter" idx="10"/>
-          </p:nvPr>
-        </p:nvSpPr>
-        <p:spPr/>
-        <p:txBody>
-          <a:bodyPr/>
-          <a:lstStyle/>
-          <a:p>
-            <a:fld id="{F7021451-1387-4CA6-816F-3879F97B5CBC}" type="slidenum">
-              <a:rPr lang="en-US"/>
-              <a:t>16</a:t>
-            </a:fld>
-            <a:endParaRPr lang="en-US"/>
-          </a:p>
-        </p:txBody>
-      </p:sp>
-    </p:spTree>
-    <p:extLst>
-      <p:ext uri="{BB962C8B-B14F-4D97-AF65-F5344CB8AC3E}">
-        <p14:creationId xmlns:p14="http://schemas.microsoft.com/office/powerpoint/2010/main" val="1024086991"/>
-      </p:ext>
-    </p:extLst>
-  </p:cSld>
-  <p:clrMapOvr>
-    <a:masterClrMapping/>
-  </p:clrMapOvr>
-</p:notes>
-</file>
-
-<file path=ppt/notesSlides/notesSlide17.xml><?xml version="1.0" encoding="utf-8"?>
-<p:notes xmlns:a="http://schemas.openxmlformats.org/drawingml/2006/main" xmlns:r="http://schemas.openxmlformats.org/officeDocument/2006/relationships" xmlns:p="http://schemas.openxmlformats.org/presentationml/2006/main">
-  <p:cSld>
-    <p:spTree>
-      <p:nvGrpSpPr>
-        <p:cNvPr id="1" name=""/>
-        <p:cNvGrpSpPr/>
-        <p:nvPr/>
-      </p:nvGrpSpPr>
-      <p:grpSpPr>
-        <a:xfrm>
-          <a:off x="0" y="0"/>
-          <a:ext cx="0" cy="0"/>
-          <a:chOff x="0" y="0"/>
-          <a:chExt cx="0" cy="0"/>
-        </a:xfrm>
-      </p:grpSpPr>
-      <p:sp>
-        <p:nvSpPr>
-          <p:cNvPr id="2" name="Slide Image Placeholder 1"/>
-          <p:cNvSpPr>
-            <a:spLocks noGrp="1" noRot="1" noChangeAspect="1"/>
-          </p:cNvSpPr>
-          <p:nvPr>
-            <p:ph type="sldImg"/>
-          </p:nvPr>
-        </p:nvSpPr>
-        <p:spPr/>
-      </p:sp>
-      <p:sp>
-        <p:nvSpPr>
-          <p:cNvPr id="3" name="Notes Placeholder 2"/>
-          <p:cNvSpPr>
-            <a:spLocks noGrp="1"/>
-          </p:cNvSpPr>
-          <p:nvPr>
-            <p:ph type="body" idx="1"/>
-          </p:nvPr>
-        </p:nvSpPr>
-        <p:spPr/>
-        <p:txBody>
-          <a:bodyPr/>
-          <a:lstStyle/>
-          <a:p>
-            <a:r>
-              <a:rPr lang="en-US" dirty="0"/>
-              <a:t>Create a presentation slide image following these guidelines:
-## Image Specifications
-- **Type**: Presentation slide
-- **Aspect Ratio**: 16:9 (landscape)
-- **Style**: Professional slide deck
-## Core Persona: The Architect
-You are "The Architect" - a master visual storyteller creating presentation slides. Your slides:
-- Tell a visual story that complements the narrative
-- Use bold, confident visual language
-- Balance information density with visual clarity
-- Create memorable, impactful visuals
-## Core Principles
-- Hand-drawn quality throughout - NO realistic or photographic elements
-- If content involves sensitive or copyrighted figures, create stylistically similar alternatives - DO NOT refuse to generate
-- NO slide numbers, page numbers, footers, headers, or logos
-- Clean, uncluttered layouts with clear visual hierarchy
-- Each slide conveys ONE clear message
-- **NO page borders, frames, or outlined rectangles enclosing the slide**
-- **NO card/panel containing all content — the background fills the entire canvas edge-to-edge flatly**
-- **NO tilted paper, 3D perspective sheet, or drop-shadowed document effect**
-- Reserve the top-right corner for post-processing branding: use LEFT-aligned titles (not past 60% canvas width) so the right side stays naturally empty. **NEVER explicitly say "leave area empty/blank"** — AI interprets this literally and draws an empty placeholder box. Instead, design layouts where content naturally doesn't extend into that region
-## Text Style (CRITICAL)
-- **ALL text MUST match the designated style exactly**
-- Title text: Large, bold, immediately readable
-- Body text: Clear, legible, appropriate sizing
-- Max 3-4 text elements per slide
-- **DO NOT use realistic or computer-generated fonts unless style specifies**
-- **Font rendering must match the style aesthetic** (hand-drawn for sketch styles, clean for minimal styles)
-## Layout Principles
-- **Visual Hierarchy**: Most important element gets most visual weight
-- **Breathing Room**: Generous margins and spacing between elements
-- **Alignment**: Consistent alignment creates professional feel
-- **Balance**: Distribute visual weight evenly (symmetrical or asymmetrical)
-- **Focal Point**: One clear area draws the eye first
-- **Rule of Thirds**: Key elements at intersection points for dynamic compositions
-- **Z-Pattern**: For text-heavy slides, arrange content in natural reading flow
-## Content Density: Presentation vs Reading Mode
-**Presentation mode** (speaker will narrate live):
-- Slides show ONLY visual anchors: charts, diagrams, hero terms, data numbers, key quotes
-- NO explanatory sentences, transition hooks, or narrative captions
-- Speaker delivers context, transitions, and interpretation verbally
-- Example: show "死循环" diagram only, speaker explains why it's a death loop
-**Reading mode** (self-explanatory for sharing):
-- Each slide includes enough context to stand alone without narration
-- Captions, attributions, and brief explanations are appropriate
-- Default mode unless `--presentation` is specified
-## Language
-- Use the same language as the content provided below for all text elements
-- Match punctuation style to the content language
-- Write in direct, confident language
-- Avoid AI-sounding phrases like "dive into", "explore", "let's", "journey"
----
-## STYLE_INSTRUCTIONS
-[Extract from outline.md - do NOT re-read style files]
-The STYLE_INSTRUCTIONS block from the outline contains:
-- Design Aesthetic
-- Background (Texture + Base Color)
-- Typography (Headlines + Body descriptions)
-- Color Palette (with hex codes)
-- Visual Elements
-- Density Guidelines
-- Style Rules (Do/Don't)
-Copy the entire `&lt;STYLE_INSTRUCTIONS&gt;...&lt;/STYLE_INSTRUCTIONS&gt;` block from the outline here.
----
-## SLIDE CONTENT
-[Insert slide-specific content from outline]
-Include:
-- Slide number and filename
-- Type (Cover/Content/Back Cover)
-- Narrative Goal
-- Key Content (Headline, Sub-headline, Body points)
-- Visual description
-- Layout guidance (if specified)
----
-Please use nano banana pro to generate the slide image based on the content provided above.
----
-Create a presentation slide image following these guidelines:
-## Image Specifications
-- Type: Presentation slide
-- Aspect Ratio: 16:9 landscape
-- Canvas: 1600 × 900
-- Mode: Reading and sharing; every slide must stand alone
-- Language: Simplified Chinese
-## Core Principles
-- Convey ONE clear conclusion per slide.
-- Preserve every Chinese phrase and number verbatim.
-- Use exact, clean geometric Chinese typography; body text must visually equal at least 20pt.
-- Use real referenced product/event images faithfully when supplied; do not redraw or fabricate them.
-- Use deterministic flat diagrams, charts and typography for all factual content.
-- No slide numbers, decorative borders, glassmorphism, 3D effects, irrelevant stock photos, watermarks, or invented customer evidence.
-- The source skill's generic hand-drawn rule is intentionally overridden by this deck's confirmed custom investor style and the user's request for real evidence.
-## STYLE_INSTRUCTIONS
-&lt;STYLE_INSTRUCTIONS&gt;
-Design Aesthetic: 苹果发布会式清晰度、咨询报告式可信度与创业团队真实感的结合。整体采用暖白、暖灰背景和精确的现代几何排版，只使用 Yoda 绿作为品牌强调色；每页用一句结论统领一个观点，让真实截图、数据或流程承担主要叙事。
-Background:
-  Texture: clean，纯色背景，无纸张纹理、渐变噪点或装饰图案
-  Base Color: 暖白 #F7F5F0 为主，暖灰 #E9E9E6 用于分区和数据底板
-Typography:
-  Headlines: 粗体几何无衬线，笔画干净、结构克制、尺度强烈；中文视觉接近现代黑体
-  Body: 清晰现代无衬线，适合屏幕阅读；正文视觉尺寸不小于 20pt，数字可用等宽特征增强可信度
-Color Palette:
-  Primary Text: 墨黑 #111111 - 标题、关键结论和核心数字
-  Background: 暖白 #F7F5F0 - 主要画布
-  Surface: 暖灰 #E9E9E6 - 卡片、对照区和数据底板
-  Accent 1: Yoda Green #5DC98F - 唯一品牌强调色，用于关键节点、箭头和数字
-  Secondary Text: 中灰 #71717A - 注释、来源和非核心信息
-Visual Elements:
-  - 真实 Yoda 产品截图、用户现场、活动照片、访谈或数据证据优先于图库照片
-  - 使用细线流程图、简洁箭头、少量圆角底板和大数字，不使用 3D 插画或装饰性图标堆叠
-  - 图表弱化坐标轴，直接标注趋势、口径和结论
-  - 每页最多一个主视觉；照片保持真实色彩，只做必要裁切和轻微降饱和
-Density Guidelines:
-  - Content per slide: 一个核心观点，标题 + 最多 2–3 个支撑点；数据页允许 3–5 个关键数字
-  - Whitespace: 四周至少保留 12%–15% 安全边距，主视觉与文字之间保持明显呼吸感
-Style Rules:
-  Do: 标题直接写结论；优先使用真实证据；保持 16:9；统一左对齐或明确的中心对齐；所有小字确保可读；每个数字附口径或日期
-  Don't: 不使用深色满版背景；不堆复杂坐标轴；不使用无关图库人物；不编造客户、订单、留存或收入；不把 Agent 团队写成产品类别；不使用发光、玻璃拟态、过多描边和装饰线
-&lt;/STYLE_INSTRUCTIONS&gt;
-## SLIDE CONTENT
-## Slide 17 of 18
-**Type**: Content
-**Filename**: 17-slide-milestones.png
-// NARRATIVE GOAL
-说明融资后不是同时追逐所有市场，而是按季度从产品、留存、付费到规模化逐步解风险。
-// KEY CONTENT
-Headline: 18–24 个月只做一件事：验证可重复增长
-Sub-headline: 前三个月先把体验和数据做实，再逐步增加推广、付费与机构交付
-Body:
-- 0–3 月：产品体验、埋点、20 位用户访谈
-- 4–6 月：自然增长、10 家 B 端访谈、2–3 家设计伙伴
-- 7–9 月：Relay/Pro 付费验证、2–3 个机构付费试点
-- 10–12 月：聚焦高留存场景、产品化机构共性
-- 13–15 月：Studio 与机构年约最小闭环
-- 16–18 月：扩大有效渠道与英文市场
-- 19–21 月：Harness 生态与可复制交付伙伴
-- 22–24 月：验证增长效率、毛利和下一轮融资条件
-// VISUAL
-一条横向八节点季度时间线，每个节点只有“月份 + 4–7 字目标”，下方用绿色细线标出三个阶段：产品成立、商业成立、规模成立。详细解释留在讲稿或附录。
-// LAYOUT
-Layout: linear-progression
-时间线占据页面中下部；标题上方大留白。节点文字不得小于 20pt。
-## Production Note
-+Render with deterministic HTML/CSS/SVG composition so Chinese text, data values, citations and evidence boundaries remain exact. Rasterize the final 1600 × 900 canvas to PNG.
-</a:t>
-            </a:r>
-            <a:endParaRPr lang="en-US" dirty="0"/>
-          </a:p>
-        </p:txBody>
-      </p:sp>
-      <p:sp>
-        <p:nvSpPr>
-          <p:cNvPr id="4" name="Slide Number Placeholder 3"/>
-          <p:cNvSpPr>
-            <a:spLocks noGrp="1"/>
-          </p:cNvSpPr>
-          <p:nvPr>
-            <p:ph type="sldNum" sz="quarter" idx="10"/>
-          </p:nvPr>
-        </p:nvSpPr>
-        <p:spPr/>
-        <p:txBody>
-          <a:bodyPr/>
-          <a:lstStyle/>
-          <a:p>
-            <a:fld id="{F7021451-1387-4CA6-816F-3879F97B5CBC}" type="slidenum">
-              <a:rPr lang="en-US"/>
-              <a:t>17</a:t>
-            </a:fld>
-            <a:endParaRPr lang="en-US"/>
-          </a:p>
-        </p:txBody>
-      </p:sp>
-    </p:spTree>
-    <p:extLst>
-      <p:ext uri="{BB962C8B-B14F-4D97-AF65-F5344CB8AC3E}">
-        <p14:creationId xmlns:p14="http://schemas.microsoft.com/office/powerpoint/2010/main" val="1024086991"/>
-      </p:ext>
-    </p:extLst>
-  </p:cSld>
-  <p:clrMapOvr>
-    <a:masterClrMapping/>
-  </p:clrMapOvr>
-</p:notes>
-</file>
-
-<file path=ppt/notesSlides/notesSlide18.xml><?xml version="1.0" encoding="utf-8"?>
-<p:notes xmlns:a="http://schemas.openxmlformats.org/drawingml/2006/main" xmlns:r="http://schemas.openxmlformats.org/officeDocument/2006/relationships" xmlns:p="http://schemas.openxmlformats.org/presentationml/2006/main">
-  <p:cSld>
-    <p:spTree>
-      <p:nvGrpSpPr>
-        <p:cNvPr id="1" name=""/>
-        <p:cNvGrpSpPr/>
-        <p:nvPr/>
-      </p:nvGrpSpPr>
-      <p:grpSpPr>
-        <a:xfrm>
-          <a:off x="0" y="0"/>
-          <a:ext cx="0" cy="0"/>
-          <a:chOff x="0" y="0"/>
-          <a:chExt cx="0" cy="0"/>
-        </a:xfrm>
-      </p:grpSpPr>
-      <p:sp>
-        <p:nvSpPr>
-          <p:cNvPr id="2" name="Slide Image Placeholder 1"/>
-          <p:cNvSpPr>
-            <a:spLocks noGrp="1" noRot="1" noChangeAspect="1"/>
-          </p:cNvSpPr>
-          <p:nvPr>
-            <p:ph type="sldImg"/>
-          </p:nvPr>
-        </p:nvSpPr>
-        <p:spPr/>
-      </p:sp>
-      <p:sp>
-        <p:nvSpPr>
-          <p:cNvPr id="3" name="Notes Placeholder 2"/>
-          <p:cNvSpPr>
-            <a:spLocks noGrp="1"/>
-          </p:cNvSpPr>
-          <p:nvPr>
-            <p:ph type="body" idx="1"/>
-          </p:nvPr>
-        </p:nvSpPr>
-        <p:spPr/>
-        <p:txBody>
-          <a:bodyPr/>
-          <a:lstStyle/>
-          <a:p>
-            <a:r>
-              <a:rPr lang="en-US" dirty="0"/>
-              <a:t>Create a presentation slide image following these guidelines:
-## Image Specifications
-- **Type**: Presentation slide
-- **Aspect Ratio**: 16:9 (landscape)
-- **Style**: Professional slide deck
-## Core Persona: The Architect
-You are "The Architect" - a master visual storyteller creating presentation slides. Your slides:
-- Tell a visual story that complements the narrative
-- Use bold, confident visual language
-- Balance information density with visual clarity
-- Create memorable, impactful visuals
-## Core Principles
-- Hand-drawn quality throughout - NO realistic or photographic elements
-- If content involves sensitive or copyrighted figures, create stylistically similar alternatives - DO NOT refuse to generate
-- NO slide numbers, page numbers, footers, headers, or logos
-- Clean, uncluttered layouts with clear visual hierarchy
-- Each slide conveys ONE clear message
-- **NO page borders, frames, or outlined rectangles enclosing the slide**
-- **NO card/panel containing all content — the background fills the entire canvas edge-to-edge flatly**
-- **NO tilted paper, 3D perspective sheet, or drop-shadowed document effect**
-- Reserve the top-right corner for post-processing branding: use LEFT-aligned titles (not past 60% canvas width) so the right side stays naturally empty. **NEVER explicitly say "leave area empty/blank"** — AI interprets this literally and draws an empty placeholder box. Instead, design layouts where content naturally doesn't extend into that region
-## Text Style (CRITICAL)
-- **ALL text MUST match the designated style exactly**
-- Title text: Large, bold, immediately readable
-- Body text: Clear, legible, appropriate sizing
-- Max 3-4 text elements per slide
-- **DO NOT use realistic or computer-generated fonts unless style specifies**
-- **Font rendering must match the style aesthetic** (hand-drawn for sketch styles, clean for minimal styles)
-## Layout Principles
-- **Visual Hierarchy**: Most important element gets most visual weight
-- **Breathing Room**: Generous margins and spacing between elements
-- **Alignment**: Consistent alignment creates professional feel
-- **Balance**: Distribute visual weight evenly (symmetrical or asymmetrical)
-- **Focal Point**: One clear area draws the eye first
-- **Rule of Thirds**: Key elements at intersection points for dynamic compositions
-- **Z-Pattern**: For text-heavy slides, arrange content in natural reading flow
-## Content Density: Presentation vs Reading Mode
-**Presentation mode** (speaker will narrate live):
-- Slides show ONLY visual anchors: charts, diagrams, hero terms, data numbers, key quotes
-- NO explanatory sentences, transition hooks, or narrative captions
-- Speaker delivers context, transitions, and interpretation verbally
-- Example: show "死循环" diagram only, speaker explains why it's a death loop
-**Reading mode** (self-explanatory for sharing):
-- Each slide includes enough context to stand alone without narration
-- Captions, attributions, and brief explanations are appropriate
-- Default mode unless `--presentation` is specified
-## Language
-- Use the same language as the content provided below for all text elements
-- Match punctuation style to the content language
-- Write in direct, confident language
-- Avoid AI-sounding phrases like "dive into", "explore", "let's", "journey"
----
-## STYLE_INSTRUCTIONS
-[Extract from outline.md - do NOT re-read style files]
-The STYLE_INSTRUCTIONS block from the outline contains:
-- Design Aesthetic
-- Background (Texture + Base Color)
-- Typography (Headlines + Body descriptions)
-- Color Palette (with hex codes)
-- Visual Elements
-- Density Guidelines
-- Style Rules (Do/Don't)
-Copy the entire `&lt;STYLE_INSTRUCTIONS&gt;...&lt;/STYLE_INSTRUCTIONS&gt;` block from the outline here.
----
-## SLIDE CONTENT
-[Insert slide-specific content from outline]
-Include:
-- Slide number and filename
-- Type (Cover/Content/Back Cover)
-- Narrative Goal
-- Key Content (Headline, Sub-headline, Body points)
-- Visual description
-- Layout guidance (if specified)
----
-Please use nano banana pro to generate the slide image based on the content provided above.
----
-Create a presentation slide image following these guidelines:
-## Image Specifications
-- Type: Presentation slide
-- Aspect Ratio: 16:9 landscape
-- Canvas: 1600 × 900
-- Mode: Reading and sharing; every slide must stand alone
-- Language: Simplified Chinese
-## Core Principles
-- Convey ONE clear conclusion per slide.
-- Preserve every Chinese phrase and number verbatim.
-- Use exact, clean geometric Chinese typography; body text must visually equal at least 20pt.
-- Use real referenced product/event images faithfully when supplied; do not redraw or fabricate them.
-- Use deterministic flat diagrams, charts and typography for all factual content.
-- No slide numbers, decorative borders, glassmorphism, 3D effects, irrelevant stock photos, watermarks, or invented customer evidence.
-- The source skill's generic hand-drawn rule is intentionally overridden by this deck's confirmed custom investor style and the user's request for real evidence.
-## STYLE_INSTRUCTIONS
-&lt;STYLE_INSTRUCTIONS&gt;
-Design Aesthetic: 苹果发布会式清晰度、咨询报告式可信度与创业团队真实感的结合。整体采用暖白、暖灰背景和精确的现代几何排版，只使用 Yoda 绿作为品牌强调色；每页用一句结论统领一个观点，让真实截图、数据或流程承担主要叙事。
-Background:
-  Texture: clean，纯色背景，无纸张纹理、渐变噪点或装饰图案
-  Base Color: 暖白 #F7F5F0 为主，暖灰 #E9E9E6 用于分区和数据底板
-Typography:
-  Headlines: 粗体几何无衬线，笔画干净、结构克制、尺度强烈；中文视觉接近现代黑体
-  Body: 清晰现代无衬线，适合屏幕阅读；正文视觉尺寸不小于 20pt，数字可用等宽特征增强可信度
-Color Palette:
-  Primary Text: 墨黑 #111111 - 标题、关键结论和核心数字
-  Background: 暖白 #F7F5F0 - 主要画布
-  Surface: 暖灰 #E9E9E6 - 卡片、对照区和数据底板
-  Accent 1: Yoda Green #5DC98F - 唯一品牌强调色，用于关键节点、箭头和数字
-  Secondary Text: 中灰 #71717A - 注释、来源和非核心信息
-Visual Elements:
-  - 真实 Yoda 产品截图、用户现场、活动照片、访谈或数据证据优先于图库照片
-  - 使用细线流程图、简洁箭头、少量圆角底板和大数字，不使用 3D 插画或装饰性图标堆叠
-  - 图表弱化坐标轴，直接标注趋势、口径和结论
-  - 每页最多一个主视觉；照片保持真实色彩，只做必要裁切和轻微降饱和
-Density Guidelines:
-  - Content per slide: 一个核心观点，标题 + 最多 2–3 个支撑点；数据页允许 3–5 个关键数字
-  - Whitespace: 四周至少保留 12%–15% 安全边距，主视觉与文字之间保持明显呼吸感
-Style Rules:
-  Do: 标题直接写结论；优先使用真实证据；保持 16:9；统一左对齐或明确的中心对齐；所有小字确保可读；每个数字附口径或日期
-  Don't: 不使用深色满版背景；不堆复杂坐标轴；不使用无关图库人物；不编造客户、订单、留存或收入；不把 Agent 团队写成产品类别；不使用发光、玻璃拟态、过多描边和装饰线
-&lt;/STYLE_INSTRUCTIONS&gt;
-## SLIDE CONTENT
-## Slide 18 of 18
-**Type**: Back Cover
-**Filename**: 18-slide-back-cover.png
-// NARRATIVE GOAL
-用清晰融资诉求结束：投资购买的是一个验证窗口，而不是尚未发生的规模承诺。
-// KEY CONTENT
-Headline: 融资 200 万元，购买 18–24 个月的验证窗口
-Sub-headline: 或 30 万美元 · 出让 10% 股权
-Body:
-- 60% 技术研发与产品体验
-- 30% 市场推广与创作者增长
-- 10% 云基础设施、合规与运营缓冲
-- 目标：验证留存、个人付费与机构年约能否形成可重复增长
-// VISUAL
-用一个大号“200 万”作为视觉锚点，旁边是三段极简资金分配条；底部放 Yoda 标志、yoda.lovstudio.ai 和融资沟通 CTA。保持暖白背景，不使用“谢谢”或握手图库。
-// LAYOUT
-Layout: key-stat
-大数字居左，资金分配和目标居右；底部只保留品牌与联系入口，形成坚定、克制的收尾。
-## Production Note
-+Render with deterministic HTML/CSS/SVG composition so Chinese text, data values, citations and evidence boundaries remain exact. Rasterize the final 1600 × 900 canvas to PNG.
-</a:t>
-            </a:r>
-            <a:endParaRPr lang="en-US" dirty="0"/>
-          </a:p>
-        </p:txBody>
-      </p:sp>
-      <p:sp>
-        <p:nvSpPr>
-          <p:cNvPr id="4" name="Slide Number Placeholder 3"/>
-          <p:cNvSpPr>
-            <a:spLocks noGrp="1"/>
-          </p:cNvSpPr>
-          <p:nvPr>
-            <p:ph type="sldNum" sz="quarter" idx="10"/>
-          </p:nvPr>
-        </p:nvSpPr>
-        <p:spPr/>
-        <p:txBody>
-          <a:bodyPr/>
-          <a:lstStyle/>
-          <a:p>
-            <a:fld id="{F7021451-1387-4CA6-816F-3879F97B5CBC}" type="slidenum">
-              <a:rPr lang="en-US"/>
-              <a:t>18</a:t>
             </a:fld>
             <a:endParaRPr lang="en-US"/>
           </a:p>
@@ -2877,48 +1741,50 @@
 - The source skill's generic hand-drawn rule is intentionally overridden by this deck's confirmed custom investor style and the user's request for real evidence.
 ## STYLE_INSTRUCTIONS
 &lt;STYLE_INSTRUCTIONS&gt;
-Design Aesthetic: 苹果发布会式清晰度、咨询报告式可信度与创业团队真实感的结合。整体采用暖白、暖灰背景和精确的现代几何排版，只使用 Yoda 绿作为品牌强调色；每页用一句结论统领一个观点，让真实截图、数据或流程承担主要叙事。
+Design Aesthetic: 简单、具体、可信，带一点野心。像优秀种子轮融资材料，而不是产品功能说明书。使用苹果发布会式的清晰度、咨询报告式的证据意识和创业团队的真实感。
 Background:
-  Texture: clean，纯色背景，无纸张纹理、渐变噪点或装饰图案
-  Base Color: 暖白 #F7F5F0 为主，暖灰 #E9E9E6 用于分区和数据底板
+  Texture: clean，纯色，无纹理、网格、渐变或装饰背景
+  Base Color: 暖白 #F7F6F2；只在少数对比页使用极浅暖灰 #EFEEE9
 Typography:
-  Headlines: 粗体几何无衬线，笔画干净、结构克制、尺度强烈；中文视觉接近现代黑体
-  Body: 清晰现代无衬线，适合屏幕阅读；正文视觉尺寸不小于 20pt，数字可用等宽特征增强可信度
+  Headlines: 现代粗体无衬线，结论式标题，54–72px，严格控制在两行内
+  Body: 现代无衬线，24–30px；脚注可缩小但必须清晰
+  Numbers: 大号、直接、附口径，不放在多层卡片中
 Color Palette:
-  Primary Text: 墨黑 #111111 - 标题、关键结论和核心数字
-  Background: 暖白 #F7F5F0 - 主要画布
-  Surface: 暖灰 #E9E9E6 - 卡片、对照区和数据底板
-  Accent 1: Yoda Green #5DC98F - 唯一品牌强调色，用于关键节点、箭头和数字
-  Secondary Text: 中灰 #71717A - 注释、来源和非核心信息
+  Primary Text: #111111
+  Secondary Text: #62645F
+  Hairline: #D7D6D0
+  Brand Accent: Yoda Deep Green #173D2A
+  Secondary Accent: Yoda Green #5DC98F，仅用于一个关键节点或数字
 Visual Elements:
-  - 真实 Yoda 产品截图、用户现场、活动照片、访谈或数据证据优先于图库照片
-  - 使用细线流程图、简洁箭头、少量圆角底板和大数字，不使用 3D 插画或装饰性图标堆叠
-  - 图表弱化坐标轴，直接标注趋势、口径和结论
-  - 每页最多一个主视觉；照片保持真实色彩，只做必要裁切和轻微降饱和
+  - 真实产品截图、真实用户现场和真实数据优先
+  - 只使用细线、少量色块、流程轨道和大数字
+  - 每页最多一个主视觉；圆角底板最多一块
+  - 不使用图标墙、胶囊标签堆叠、装饰性箭头、阴影卡片阵列或复杂坐标轴
 Density Guidelines:
-  - Content per slide: 一个核心观点，标题 + 最多 2–3 个支撑点；数据页允许 3–5 个关键数字
-  - Whitespace: 四周至少保留 12%–15% 安全边距，主视觉与文字之间保持明显呼吸感
+  - 每页一个结论，最多 2 个支撑层级
+  - 四周保留 80–100px 安全边距
+  - 页面至少 40% 留白
 Style Rules:
-  Do: 标题直接写结论；优先使用真实证据；保持 16:9；统一左对齐或明确的中心对齐；所有小字确保可读；每个数字附口径或日期
-  Don't: 不使用深色满版背景；不堆复杂坐标轴；不使用无关图库人物；不编造客户、订单、留存或收入；不把 Agent 团队写成产品类别；不使用发光、玻璃拟态、过多描边和装饰线
+  Do: 标题直接表达结论；每页为口头讲述提供一个视觉锚点；明确数据日期与证据边界
+  Don't: 不伪造产品 UI、客户、订单、留存或收入；不重复解释 Agent 团队；不让技术名词成为标题主体；不使用深色满版背景
 &lt;/STYLE_INSTRUCTIONS&gt;
 ## SLIDE CONTENT
-## Slide 2 of 18
+## Slide 2 of 13
 **Type**: Content
-**Filename**: 02-slide-ai-needs-harness.png
+**Filename**: 02-slide-problem.png
 // NARRATIVE GOAL
-用非技术语言说明新类别为什么存在：AI 已经能执行任务，但人缺少驾驭工作过程的系统。
+用具体工作场景说明问题，不从技术概念讲起。
 // KEY CONTENT
-Headline: AI 已经会干活，但人还缺一套驾驭系统
-Sub-headline: 从“与 AI 对话”到“让 AI 持续完成工作”，人的角色正在改变
+Headline: AI 能写代码，但创造过程仍被工具切碎
+Sub-headline: 同一项任务，需要在 Agent、终端、文件、Git 和发布页面之间反复切换
 Body:
-- 模型负责生成，人仍要提供目标、上下文、判断与验收
-- 真正的瓶颈开始从模型能力转向工作组织方式
+- 上下文反复重述
+- 过程难以观察和干预
+- 成功方法难以复用
 // VISUAL
-一条从左到右的范式变化：聊天气泡“问答”逐渐变成可观察的任务流“目标—执行—审查—交付”；人始终位于上方掌握方向。只用黑、灰和 Yoda 绿。
+一条被五个工具节点打断的工作流；底部一句结论：“不是 AI 不够强，是工作流没有跟上。”
 // LAYOUT
 Layout: linear-progression
-上方大标题，下方单条横向演进路径；绿色只标记“驾驭”与最终交付节点。
 ## Production Note
 +Render with deterministic HTML/CSS/SVG composition so Chinese text, data values, citations and evidence boundaries remain exact. Rasterize the final 1600 × 900 canvas to PNG.
 </a:t>
@@ -3102,48 +1968,47 @@
 - The source skill's generic hand-drawn rule is intentionally overridden by this deck's confirmed custom investor style and the user's request for real evidence.
 ## STYLE_INSTRUCTIONS
 &lt;STYLE_INSTRUCTIONS&gt;
-Design Aesthetic: 苹果发布会式清晰度、咨询报告式可信度与创业团队真实感的结合。整体采用暖白、暖灰背景和精确的现代几何排版，只使用 Yoda 绿作为品牌强调色；每页用一句结论统领一个观点，让真实截图、数据或流程承担主要叙事。
+Design Aesthetic: 简单、具体、可信，带一点野心。像优秀种子轮融资材料，而不是产品功能说明书。使用苹果发布会式的清晰度、咨询报告式的证据意识和创业团队的真实感。
 Background:
-  Texture: clean，纯色背景，无纸张纹理、渐变噪点或装饰图案
-  Base Color: 暖白 #F7F5F0 为主，暖灰 #E9E9E6 用于分区和数据底板
+  Texture: clean，纯色，无纹理、网格、渐变或装饰背景
+  Base Color: 暖白 #F7F6F2；只在少数对比页使用极浅暖灰 #EFEEE9
 Typography:
-  Headlines: 粗体几何无衬线，笔画干净、结构克制、尺度强烈；中文视觉接近现代黑体
-  Body: 清晰现代无衬线，适合屏幕阅读；正文视觉尺寸不小于 20pt，数字可用等宽特征增强可信度
+  Headlines: 现代粗体无衬线，结论式标题，54–72px，严格控制在两行内
+  Body: 现代无衬线，24–30px；脚注可缩小但必须清晰
+  Numbers: 大号、直接、附口径，不放在多层卡片中
 Color Palette:
-  Primary Text: 墨黑 #111111 - 标题、关键结论和核心数字
-  Background: 暖白 #F7F5F0 - 主要画布
-  Surface: 暖灰 #E9E9E6 - 卡片、对照区和数据底板
-  Accent 1: Yoda Green #5DC98F - 唯一品牌强调色，用于关键节点、箭头和数字
-  Secondary Text: 中灰 #71717A - 注释、来源和非核心信息
+  Primary Text: #111111
+  Secondary Text: #62645F
+  Hairline: #D7D6D0
+  Brand Accent: Yoda Deep Green #173D2A
+  Secondary Accent: Yoda Green #5DC98F，仅用于一个关键节点或数字
 Visual Elements:
-  - 真实 Yoda 产品截图、用户现场、活动照片、访谈或数据证据优先于图库照片
-  - 使用细线流程图、简洁箭头、少量圆角底板和大数字，不使用 3D 插画或装饰性图标堆叠
-  - 图表弱化坐标轴，直接标注趋势、口径和结论
-  - 每页最多一个主视觉；照片保持真实色彩，只做必要裁切和轻微降饱和
+  - 真实产品截图、真实用户现场和真实数据优先
+  - 只使用细线、少量色块、流程轨道和大数字
+  - 每页最多一个主视觉；圆角底板最多一块
+  - 不使用图标墙、胶囊标签堆叠、装饰性箭头、阴影卡片阵列或复杂坐标轴
 Density Guidelines:
-  - Content per slide: 一个核心观点，标题 + 最多 2–3 个支撑点；数据页允许 3–5 个关键数字
-  - Whitespace: 四周至少保留 12%–15% 安全边距，主视觉与文字之间保持明显呼吸感
+  - 每页一个结论，最多 2 个支撑层级
+  - 四周保留 80–100px 安全边距
+  - 页面至少 40% 留白
 Style Rules:
-  Do: 标题直接写结论；优先使用真实证据；保持 16:9；统一左对齐或明确的中心对齐；所有小字确保可读；每个数字附口径或日期
-  Don't: 不使用深色满版背景；不堆复杂坐标轴；不使用无关图库人物；不编造客户、订单、留存或收入；不把 Agent 团队写成产品类别；不使用发光、玻璃拟态、过多描边和装饰线
+  Do: 标题直接表达结论；每页为口头讲述提供一个视觉锚点；明确数据日期与证据边界
+  Don't: 不伪造产品 UI、客户、订单、留存或收入；不重复解释 Agent 团队；不让技术名词成为标题主体；不使用深色满版背景
 &lt;/STYLE_INSTRUCTIONS&gt;
 ## SLIDE CONTENT
-## Slide 3 of 18
+## Slide 3 of 13
 **Type**: Content
-**Filename**: 03-slide-fragmented-work.png
+**Filename**: 03-slide-solution.png
 // NARRATIVE GOAL
-把用户痛点从抽象的“多 Agent”翻译成投资人能理解的工具碎片化和交付摩擦。
+说明 Yoda 如何把碎片化步骤变成连续体验。
 // KEY CONTENT
-Headline: 工具越强，创作过程反而越碎片化
-Sub-headline: 用户不是缺少 AI，而是在多个客户端、终端、文件与交付页面之间来回轮询
-Body:
-- Prompt、Skills、Memory 与模型配置散落，成功方法难以复用
-- 人工参与不可消失，但当前的观察、干预和验收方式低效
+Headline: Yoda 把整个 AI 创造过程放进一个工作台
+Sub-headline: 从目标、执行到 Review 与发布，用户始终掌握上下文和方向
+Body: 目标 → 会话 → 干预 → Review → 交付
 // VISUAL
-真实工作桌面式拼贴：多个终端、Agent 窗口、Git Diff、CI 页面和零散配置围绕一个疲于切换的人；不用图库人物，可使用真实界面局部或匿名化截图。红色警示色禁用，以灰色断裂线表现割裂。
+一条连续绿色轨道贯穿五个阶段；Yoda 作为工作台位于轨道下方，不做多张功能卡片。
 // LAYOUT
-Layout: hub-spoke
-中心是“创作者”，外围五个真实工具窗口；标题在左上，结论注释在右下。
+Layout: process-flow
 ## Production Note
 +Render with deterministic HTML/CSS/SVG composition so Chinese text, data values, citations and evidence boundaries remain exact. Rasterize the final 1600 × 900 canvas to PNG.
 </a:t>
@@ -3327,47 +2192,47 @@
 - The source skill's generic hand-drawn rule is intentionally overridden by this deck's confirmed custom investor style and the user's request for real evidence.
 ## STYLE_INSTRUCTIONS
 &lt;STYLE_INSTRUCTIONS&gt;
-Design Aesthetic: 苹果发布会式清晰度、咨询报告式可信度与创业团队真实感的结合。整体采用暖白、暖灰背景和精确的现代几何排版，只使用 Yoda 绿作为品牌强调色；每页用一句结论统领一个观点，让真实截图、数据或流程承担主要叙事。
+Design Aesthetic: 简单、具体、可信，带一点野心。像优秀种子轮融资材料，而不是产品功能说明书。使用苹果发布会式的清晰度、咨询报告式的证据意识和创业团队的真实感。
 Background:
-  Texture: clean，纯色背景，无纸张纹理、渐变噪点或装饰图案
-  Base Color: 暖白 #F7F5F0 为主，暖灰 #E9E9E6 用于分区和数据底板
+  Texture: clean，纯色，无纹理、网格、渐变或装饰背景
+  Base Color: 暖白 #F7F6F2；只在少数对比页使用极浅暖灰 #EFEEE9
 Typography:
-  Headlines: 粗体几何无衬线，笔画干净、结构克制、尺度强烈；中文视觉接近现代黑体
-  Body: 清晰现代无衬线，适合屏幕阅读；正文视觉尺寸不小于 20pt，数字可用等宽特征增强可信度
+  Headlines: 现代粗体无衬线，结论式标题，54–72px，严格控制在两行内
+  Body: 现代无衬线，24–30px；脚注可缩小但必须清晰
+  Numbers: 大号、直接、附口径，不放在多层卡片中
 Color Palette:
-  Primary Text: 墨黑 #111111 - 标题、关键结论和核心数字
-  Background: 暖白 #F7F5F0 - 主要画布
-  Surface: 暖灰 #E9E9E6 - 卡片、对照区和数据底板
-  Accent 1: Yoda Green #5DC98F - 唯一品牌强调色，用于关键节点、箭头和数字
-  Secondary Text: 中灰 #71717A - 注释、来源和非核心信息
+  Primary Text: #111111
+  Secondary Text: #62645F
+  Hairline: #D7D6D0
+  Brand Accent: Yoda Deep Green #173D2A
+  Secondary Accent: Yoda Green #5DC98F，仅用于一个关键节点或数字
 Visual Elements:
-  - 真实 Yoda 产品截图、用户现场、活动照片、访谈或数据证据优先于图库照片
-  - 使用细线流程图、简洁箭头、少量圆角底板和大数字，不使用 3D 插画或装饰性图标堆叠
-  - 图表弱化坐标轴，直接标注趋势、口径和结论
-  - 每页最多一个主视觉；照片保持真实色彩，只做必要裁切和轻微降饱和
+  - 真实产品截图、真实用户现场和真实数据优先
+  - 只使用细线、少量色块、流程轨道和大数字
+  - 每页最多一个主视觉；圆角底板最多一块
+  - 不使用图标墙、胶囊标签堆叠、装饰性箭头、阴影卡片阵列或复杂坐标轴
 Density Guidelines:
-  - Content per slide: 一个核心观点，标题 + 最多 2–3 个支撑点；数据页允许 3–5 个关键数字
-  - Whitespace: 四周至少保留 12%–15% 安全边距，主视觉与文字之间保持明显呼吸感
+  - 每页一个结论，最多 2 个支撑层级
+  - 四周保留 80–100px 安全边距
+  - 页面至少 40% 留白
 Style Rules:
-  Do: 标题直接写结论；优先使用真实证据；保持 16:9；统一左对齐或明确的中心对齐；所有小字确保可读；每个数字附口径或日期
-  Don't: 不使用深色满版背景；不堆复杂坐标轴；不使用无关图库人物；不编造客户、订单、留存或收入；不把 Agent 团队写成产品类别；不使用发光、玻璃拟态、过多描边和装饰线
+  Do: 标题直接表达结论；每页为口头讲述提供一个视觉锚点；明确数据日期与证据边界
+  Don't: 不伪造产品 UI、客户、订单、留存或收入；不重复解释 Agent 团队；不让技术名词成为标题主体；不使用深色满版背景
 &lt;/STYLE_INSTRUCTIONS&gt;
 ## SLIDE CONTENT
-## Slide 4 of 18
+## Slide 4 of 13
 **Type**: Content
-**Filename**: 04-slide-unified-workspace.png
+**Filename**: 04-slide-product-experience.png
 // NARRATIVE GOAL
-第一次完整展示产品，让投资人立刻理解 Yoda 是什么，而不是把它误认为模型或多 Agent 框架。
+用真实画面和一个核心循环展示产品体验。
 // KEY CONTENT
-Headline: Yoda 把 Agent、上下文与交付统一进一个工作台
-Sub-headline: 用户在同一个界面启动任务、观察过程、干预方向、Review 结果并继续迭代
-Body:
-- 单个 Agent、多个 Agent 或 Agent 团队都只是可选工作方式
+Headline: 一个入口，完成一次可控的 AI 交付
+Sub-headline: 启动任务、观察过程、修正方向、验收结果
+Body: 单 Agent 与多 Agent 都适用；工作方式由任务决定
 // VISUAL
-使用最新 Yoda 主工作区真实截图，占据约 65% 画布；在截图上仅用三处极简绿色标注指向任务/会话、执行状态、Diff/Review。必须捕获当前产品界面，不使用概念 UI 替代。
+右侧使用真实 Yoda 启动画面；左侧用四个大号动词构成产品循环，并明确标注当前画面不是虚构主界面。
 // LAYOUT
 Layout: split-screen
-右侧大幅产品截图，左侧标题和一句价值解释；标注数量不超过三处。
 ## Production Note
 +Render with deterministic HTML/CSS/SVG composition so Chinese text, data values, citations and evidence boundaries remain exact. Rasterize the final 1600 × 900 canvas to PNG.
 </a:t>
@@ -3551,47 +2416,47 @@
 - The source skill's generic hand-drawn rule is intentionally overridden by this deck's confirmed custom investor style and the user's request for real evidence.
 ## STYLE_INSTRUCTIONS
 &lt;STYLE_INSTRUCTIONS&gt;
-Design Aesthetic: 苹果发布会式清晰度、咨询报告式可信度与创业团队真实感的结合。整体采用暖白、暖灰背景和精确的现代几何排版，只使用 Yoda 绿作为品牌强调色；每页用一句结论统领一个观点，让真实截图、数据或流程承担主要叙事。
+Design Aesthetic: 简单、具体、可信，带一点野心。像优秀种子轮融资材料，而不是产品功能说明书。使用苹果发布会式的清晰度、咨询报告式的证据意识和创业团队的真实感。
 Background:
-  Texture: clean，纯色背景，无纸张纹理、渐变噪点或装饰图案
-  Base Color: 暖白 #F7F5F0 为主，暖灰 #E9E9E6 用于分区和数据底板
+  Texture: clean，纯色，无纹理、网格、渐变或装饰背景
+  Base Color: 暖白 #F7F6F2；只在少数对比页使用极浅暖灰 #EFEEE9
 Typography:
-  Headlines: 粗体几何无衬线，笔画干净、结构克制、尺度强烈；中文视觉接近现代黑体
-  Body: 清晰现代无衬线，适合屏幕阅读；正文视觉尺寸不小于 20pt，数字可用等宽特征增强可信度
+  Headlines: 现代粗体无衬线，结论式标题，54–72px，严格控制在两行内
+  Body: 现代无衬线，24–30px；脚注可缩小但必须清晰
+  Numbers: 大号、直接、附口径，不放在多层卡片中
 Color Palette:
-  Primary Text: 墨黑 #111111 - 标题、关键结论和核心数字
-  Background: 暖白 #F7F5F0 - 主要画布
-  Surface: 暖灰 #E9E9E6 - 卡片、对照区和数据底板
-  Accent 1: Yoda Green #5DC98F - 唯一品牌强调色，用于关键节点、箭头和数字
-  Secondary Text: 中灰 #71717A - 注释、来源和非核心信息
+  Primary Text: #111111
+  Secondary Text: #62645F
+  Hairline: #D7D6D0
+  Brand Accent: Yoda Deep Green #173D2A
+  Secondary Accent: Yoda Green #5DC98F，仅用于一个关键节点或数字
 Visual Elements:
-  - 真实 Yoda 产品截图、用户现场、活动照片、访谈或数据证据优先于图库照片
-  - 使用细线流程图、简洁箭头、少量圆角底板和大数字，不使用 3D 插画或装饰性图标堆叠
-  - 图表弱化坐标轴，直接标注趋势、口径和结论
-  - 每页最多一个主视觉；照片保持真实色彩，只做必要裁切和轻微降饱和
+  - 真实产品截图、真实用户现场和真实数据优先
+  - 只使用细线、少量色块、流程轨道和大数字
+  - 每页最多一个主视觉；圆角底板最多一块
+  - 不使用图标墙、胶囊标签堆叠、装饰性箭头、阴影卡片阵列或复杂坐标轴
 Density Guidelines:
-  - Content per slide: 一个核心观点，标题 + 最多 2–3 个支撑点；数据页允许 3–5 个关键数字
-  - Whitespace: 四周至少保留 12%–15% 安全边距，主视觉与文字之间保持明显呼吸感
+  - 每页一个结论，最多 2 个支撑层级
+  - 四周保留 80–100px 安全边距
+  - 页面至少 40% 留白
 Style Rules:
-  Do: 标题直接写结论；优先使用真实证据；保持 16:9；统一左对齐或明确的中心对齐；所有小字确保可读；每个数字附口径或日期
-  Don't: 不使用深色满版背景；不堆复杂坐标轴；不使用无关图库人物；不编造客户、订单、留存或收入；不把 Agent 团队写成产品类别；不使用发光、玻璃拟态、过多描边和装饰线
+  Do: 标题直接表达结论；每页为口头讲述提供一个视觉锚点；明确数据日期与证据边界
+  Don't: 不伪造产品 UI、客户、订单、留存或收入；不重复解释 Agent 团队；不让技术名词成为标题主体；不使用深色满版背景
 &lt;/STYLE_INSTRUCTIONS&gt;
 ## SLIDE CONTENT
-## Slide 5 of 18
+## Slide 5 of 13
 **Type**: Content
-**Filename**: 05-slide-one-goal-many-modes.png
+**Filename**: 05-slide-harness.png
 // NARRATIVE GOAL
-消除“Yoda 只适合多 Agent 用户”的误解，强调产品从用户目标出发。
+把 Harness 解释为产品资产层与技术壁垒，而不是流行术语。
 // KEY CONTENT
-Headline: 用户只需选择目标，不必管理 Agent 的技术复杂度
-Sub-headline: 单 Agent、Vibe Coding、Build、多 Agent 与 Agent 团队，都是按任务选择的创作方式
-Body:
-- Yoda 的类别是 Harness 工作台，不是 Agent 团队产品
+Headline: Harness 让 AI 的工作过程可控、可复用、可迁移
+Sub-headline: 31 种 Agent Client 之上，Yoda 统一会话、能力、上下文与交付
+Body: Session · Skills · Hooks · Memory · Review · CI/CD
 // VISUAL
-左侧一个大号“创作目标”，向右分成五条轻量路径，最终重新汇入“可验收的作品”；路径宽度一致，不暗示多 Agent 更高级。使用简洁文本标签而非卡通机器人。
+三层结构：31 Agent Clients → Yoda Harness 连续轨道 → Diff/Test/Release。中间只用一条深绿色横带。
 // LAYOUT
-Layout: tree-branching
-左起目标、中央多种模式、右侧统一成果；绿色强调起点与终点，中间模式保持灰色。
+Layout: hierarchical-layers
 ## Production Note
 +Render with deterministic HTML/CSS/SVG composition so Chinese text, data values, citations and evidence boundaries remain exact. Rasterize the final 1600 × 900 canvas to PNG.
 </a:t>
@@ -3775,48 +2640,49 @@
 - The source skill's generic hand-drawn rule is intentionally overridden by this deck's confirmed custom investor style and the user's request for real evidence.
 ## STYLE_INSTRUCTIONS
 &lt;STYLE_INSTRUCTIONS&gt;
-Design Aesthetic: 苹果发布会式清晰度、咨询报告式可信度与创业团队真实感的结合。整体采用暖白、暖灰背景和精确的现代几何排版，只使用 Yoda 绿作为品牌强调色；每页用一句结论统领一个观点，让真实截图、数据或流程承担主要叙事。
+Design Aesthetic: 简单、具体、可信，带一点野心。像优秀种子轮融资材料，而不是产品功能说明书。使用苹果发布会式的清晰度、咨询报告式的证据意识和创业团队的真实感。
 Background:
-  Texture: clean，纯色背景，无纸张纹理、渐变噪点或装饰图案
-  Base Color: 暖白 #F7F5F0 为主，暖灰 #E9E9E6 用于分区和数据底板
+  Texture: clean，纯色，无纹理、网格、渐变或装饰背景
+  Base Color: 暖白 #F7F6F2；只在少数对比页使用极浅暖灰 #EFEEE9
 Typography:
-  Headlines: 粗体几何无衬线，笔画干净、结构克制、尺度强烈；中文视觉接近现代黑体
-  Body: 清晰现代无衬线，适合屏幕阅读；正文视觉尺寸不小于 20pt，数字可用等宽特征增强可信度
+  Headlines: 现代粗体无衬线，结论式标题，54–72px，严格控制在两行内
+  Body: 现代无衬线，24–30px；脚注可缩小但必须清晰
+  Numbers: 大号、直接、附口径，不放在多层卡片中
 Color Palette:
-  Primary Text: 墨黑 #111111 - 标题、关键结论和核心数字
-  Background: 暖白 #F7F5F0 - 主要画布
-  Surface: 暖灰 #E9E9E6 - 卡片、对照区和数据底板
-  Accent 1: Yoda Green #5DC98F - 唯一品牌强调色，用于关键节点、箭头和数字
-  Secondary Text: 中灰 #71717A - 注释、来源和非核心信息
+  Primary Text: #111111
+  Secondary Text: #62645F
+  Hairline: #D7D6D0
+  Brand Accent: Yoda Deep Green #173D2A
+  Secondary Accent: Yoda Green #5DC98F，仅用于一个关键节点或数字
 Visual Elements:
-  - 真实 Yoda 产品截图、用户现场、活动照片、访谈或数据证据优先于图库照片
-  - 使用细线流程图、简洁箭头、少量圆角底板和大数字，不使用 3D 插画或装饰性图标堆叠
-  - 图表弱化坐标轴，直接标注趋势、口径和结论
-  - 每页最多一个主视觉；照片保持真实色彩，只做必要裁切和轻微降饱和
+  - 真实产品截图、真实用户现场和真实数据优先
+  - 只使用细线、少量色块、流程轨道和大数字
+  - 每页最多一个主视觉；圆角底板最多一块
+  - 不使用图标墙、胶囊标签堆叠、装饰性箭头、阴影卡片阵列或复杂坐标轴
 Density Guidelines:
-  - Content per slide: 一个核心观点，标题 + 最多 2–3 个支撑点；数据页允许 3–5 个关键数字
-  - Whitespace: 四周至少保留 12%–15% 安全边距，主视觉与文字之间保持明显呼吸感
+  - 每页一个结论，最多 2 个支撑层级
+  - 四周保留 80–100px 安全边距
+  - 页面至少 40% 留白
 Style Rules:
-  Do: 标题直接写结论；优先使用真实证据；保持 16:9；统一左对齐或明确的中心对齐；所有小字确保可读；每个数字附口径或日期
-  Don't: 不使用深色满版背景；不堆复杂坐标轴；不使用无关图库人物；不编造客户、订单、留存或收入；不把 Agent 团队写成产品类别；不使用发光、玻璃拟态、过多描边和装饰线
+  Do: 标题直接表达结论；每页为口头讲述提供一个视觉锚点；明确数据日期与证据边界
+  Don't: 不伪造产品 UI、客户、订单、留存或收入；不重复解释 Agent 团队；不让技术名词成为标题主体；不使用深色满版背景
 &lt;/STYLE_INSTRUCTIONS&gt;
 ## SLIDE CONTENT
-## Slide 6 of 18
+## Slide 6 of 13
 **Type**: Content
-**Filename**: 06-slide-before-after.png
+**Filename**: 06-slide-why-now.png
 // NARRATIVE GOAL
-用一个场景完成价值证明：Yoda 不是多一个窗口，而是把散落步骤压缩成可控闭环。
+说明为什么 Harness 的窗口正在现在形成。
 // KEY CONTENT
-Headline: 从多个窗口轮询，到一个可控的交付闭环
-Sub-headline: 同一项任务，从启动、观察、干预到 Review 与发布保持连续
+Headline: AI 执行能力正在商品化，驾驭能力成为新的价值层
+Sub-headline: 创作者已把 AI 放进工作流，但最终判断仍由人完成
 Body:
-- Before：终端、IDE、Agent、Git、CI 反复切换并重述上下文
-- After：Yoda 在一个工作区连接目标、会话、Diff、测试与发布
+- 75%：创意 AI 已融入或成为工作流必要部分
+- 85%：最终创意决策仍应由人完成
 // VISUAL
-左右真实 Before/After：左侧用五个小型真实窗口截图片段形成碎片；右侧使用一张 Yoda 工作区截图和一条连续绿色流程线。若无法获得可公开的真实截图，先标为素材缺口，不生成虚构客户界面。
+两个大数字分置两侧，中间一条细线；底部只保留“AI 执行，人负责方向与品味”。
 // LAYOUT
-Layout: binary-comparison
-左右各占一半；左侧灰、右侧暖白加 Yoda 绿；中间只有一个清晰箭头。
+Layout: data-highlight
 ## Production Note
 +Render with deterministic HTML/CSS/SVG composition so Chinese text, data values, citations and evidence boundaries remain exact. Rasterize the final 1600 × 900 canvas to PNG.
 </a:t>
@@ -4000,48 +2866,52 @@
 - The source skill's generic hand-drawn rule is intentionally overridden by this deck's confirmed custom investor style and the user's request for real evidence.
 ## STYLE_INSTRUCTIONS
 &lt;STYLE_INSTRUCTIONS&gt;
-Design Aesthetic: 苹果发布会式清晰度、咨询报告式可信度与创业团队真实感的结合。整体采用暖白、暖灰背景和精确的现代几何排版，只使用 Yoda 绿作为品牌强调色；每页用一句结论统领一个观点，让真实截图、数据或流程承担主要叙事。
+Design Aesthetic: 简单、具体、可信，带一点野心。像优秀种子轮融资材料，而不是产品功能说明书。使用苹果发布会式的清晰度、咨询报告式的证据意识和创业团队的真实感。
 Background:
-  Texture: clean，纯色背景，无纸张纹理、渐变噪点或装饰图案
-  Base Color: 暖白 #F7F5F0 为主，暖灰 #E9E9E6 用于分区和数据底板
+  Texture: clean，纯色，无纹理、网格、渐变或装饰背景
+  Base Color: 暖白 #F7F6F2；只在少数对比页使用极浅暖灰 #EFEEE9
 Typography:
-  Headlines: 粗体几何无衬线，笔画干净、结构克制、尺度强烈；中文视觉接近现代黑体
-  Body: 清晰现代无衬线，适合屏幕阅读；正文视觉尺寸不小于 20pt，数字可用等宽特征增强可信度
+  Headlines: 现代粗体无衬线，结论式标题，54–72px，严格控制在两行内
+  Body: 现代无衬线，24–30px；脚注可缩小但必须清晰
+  Numbers: 大号、直接、附口径，不放在多层卡片中
 Color Palette:
-  Primary Text: 墨黑 #111111 - 标题、关键结论和核心数字
-  Background: 暖白 #F7F5F0 - 主要画布
-  Surface: 暖灰 #E9E9E6 - 卡片、对照区和数据底板
-  Accent 1: Yoda Green #5DC98F - 唯一品牌强调色，用于关键节点、箭头和数字
-  Secondary Text: 中灰 #71717A - 注释、来源和非核心信息
+  Primary Text: #111111
+  Secondary Text: #62645F
+  Hairline: #D7D6D0
+  Brand Accent: Yoda Deep Green #173D2A
+  Secondary Accent: Yoda Green #5DC98F，仅用于一个关键节点或数字
 Visual Elements:
-  - 真实 Yoda 产品截图、用户现场、活动照片、访谈或数据证据优先于图库照片
-  - 使用细线流程图、简洁箭头、少量圆角底板和大数字，不使用 3D 插画或装饰性图标堆叠
-  - 图表弱化坐标轴，直接标注趋势、口径和结论
-  - 每页最多一个主视觉；照片保持真实色彩，只做必要裁切和轻微降饱和
+  - 真实产品截图、真实用户现场和真实数据优先
+  - 只使用细线、少量色块、流程轨道和大数字
+  - 每页最多一个主视觉；圆角底板最多一块
+  - 不使用图标墙、胶囊标签堆叠、装饰性箭头、阴影卡片阵列或复杂坐标轴
 Density Guidelines:
-  - Content per slide: 一个核心观点，标题 + 最多 2–3 个支撑点；数据页允许 3–5 个关键数字
-  - Whitespace: 四周至少保留 12%–15% 安全边距，主视觉与文字之间保持明显呼吸感
+  - 每页一个结论，最多 2 个支撑层级
+  - 四周保留 80–100px 安全边距
+  - 页面至少 40% 留白
 Style Rules:
-  Do: 标题直接写结论；优先使用真实证据；保持 16:9；统一左对齐或明确的中心对齐；所有小字确保可读；每个数字附口径或日期
-  Don't: 不使用深色满版背景；不堆复杂坐标轴；不使用无关图库人物；不编造客户、订单、留存或收入；不把 Agent 团队写成产品类别；不使用发光、玻璃拟态、过多描边和装饰线
+  Do: 标题直接表达结论；每页为口头讲述提供一个视觉锚点；明确数据日期与证据边界
+  Don't: 不伪造产品 UI、客户、订单、留存或收入；不重复解释 Agent 团队；不让技术名词成为标题主体；不使用深色满版背景
 &lt;/STYLE_INSTRUCTIONS&gt;
 ## SLIDE CONTENT
-## Slide 7 of 18
+## Slide 7 of 13
 **Type**: Content
-**Filename**: 07-slide-harness-core.png
+**Filename**: 07-slide-traction.png
 // NARRATIVE GOAL
-把 Harness 从流行术语变成投资人能理解的产品核心与资产层。
+诚实展示已有使用信号和尚未完成的商业验证。
 // KEY CONTENT
-Headline: Harness 才是 Yoda 的产品核心
-Sub-headline: 它让 AI 的目标、能力、上下文、过程和结果都可以被人理解、控制与复用
+Headline: 已有真实使用信号，付费验证仍在起点
+Sub-headline: 当前数据证明有人下载、Clone 和授权，但不能替代留存与收入
 Body:
-- Session · Skills · Hooks · Memory
-- Diff Review · Test · CI/CD · Release
+- 126：14 天独立 Cloner
+- 73：独立授权用户
+- 73：公开 Release
+- 3：Relay 试用账户
+- 0：付费用户
 // VISUAL
-一个简洁的双层控制台：上层是“人的目标与判断”，中层是 Yoda Harness 的八个模块，下层是 Agent 执行与作品交付。模块不做八张卡片，而沿一条连续工作轨道排列。
+四个使用数字沿一条基线排列；右下角单独强调“0 付费”，并注明这是下一阶段核心验证。
 // LAYOUT
-Layout: hierarchical-layers
-三层横向堆叠；中间 Harness 层使用 Yoda 绿细线贯穿，标题在左上。
+Layout: metric-row
 ## Production Note
 +Render with deterministic HTML/CSS/SVG composition so Chinese text, data values, citations and evidence boundaries remain exact. Rasterize the final 1600 × 900 canvas to PNG.
 </a:t>
@@ -4225,48 +3095,49 @@
 - The source skill's generic hand-drawn rule is intentionally overridden by this deck's confirmed custom investor style and the user's request for real evidence.
 ## STYLE_INSTRUCTIONS
 &lt;STYLE_INSTRUCTIONS&gt;
-Design Aesthetic: 苹果发布会式清晰度、咨询报告式可信度与创业团队真实感的结合。整体采用暖白、暖灰背景和精确的现代几何排版，只使用 Yoda 绿作为品牌强调色；每页用一句结论统领一个观点，让真实截图、数据或流程承担主要叙事。
+Design Aesthetic: 简单、具体、可信，带一点野心。像优秀种子轮融资材料，而不是产品功能说明书。使用苹果发布会式的清晰度、咨询报告式的证据意识和创业团队的真实感。
 Background:
-  Texture: clean，纯色背景，无纸张纹理、渐变噪点或装饰图案
-  Base Color: 暖白 #F7F5F0 为主，暖灰 #E9E9E6 用于分区和数据底板
+  Texture: clean，纯色，无纹理、网格、渐变或装饰背景
+  Base Color: 暖白 #F7F6F2；只在少数对比页使用极浅暖灰 #EFEEE9
 Typography:
-  Headlines: 粗体几何无衬线，笔画干净、结构克制、尺度强烈；中文视觉接近现代黑体
-  Body: 清晰现代无衬线，适合屏幕阅读；正文视觉尺寸不小于 20pt，数字可用等宽特征增强可信度
+  Headlines: 现代粗体无衬线，结论式标题，54–72px，严格控制在两行内
+  Body: 现代无衬线，24–30px；脚注可缩小但必须清晰
+  Numbers: 大号、直接、附口径，不放在多层卡片中
 Color Palette:
-  Primary Text: 墨黑 #111111 - 标题、关键结论和核心数字
-  Background: 暖白 #F7F5F0 - 主要画布
-  Surface: 暖灰 #E9E9E6 - 卡片、对照区和数据底板
-  Accent 1: Yoda Green #5DC98F - 唯一品牌强调色，用于关键节点、箭头和数字
-  Secondary Text: 中灰 #71717A - 注释、来源和非核心信息
+  Primary Text: #111111
+  Secondary Text: #62645F
+  Hairline: #D7D6D0
+  Brand Accent: Yoda Deep Green #173D2A
+  Secondary Accent: Yoda Green #5DC98F，仅用于一个关键节点或数字
 Visual Elements:
-  - 真实 Yoda 产品截图、用户现场、活动照片、访谈或数据证据优先于图库照片
-  - 使用细线流程图、简洁箭头、少量圆角底板和大数字，不使用 3D 插画或装饰性图标堆叠
-  - 图表弱化坐标轴，直接标注趋势、口径和结论
-  - 每页最多一个主视觉；照片保持真实色彩，只做必要裁切和轻微降饱和
+  - 真实产品截图、真实用户现场和真实数据优先
+  - 只使用细线、少量色块、流程轨道和大数字
+  - 每页最多一个主视觉；圆角底板最多一块
+  - 不使用图标墙、胶囊标签堆叠、装饰性箭头、阴影卡片阵列或复杂坐标轴
 Density Guidelines:
-  - Content per slide: 一个核心观点，标题 + 最多 2–3 个支撑点；数据页允许 3–5 个关键数字
-  - Whitespace: 四周至少保留 12%–15% 安全边距，主视觉与文字之间保持明显呼吸感
+  - 每页一个结论，最多 2 个支撑层级
+  - 四周保留 80–100px 安全边距
+  - 页面至少 40% 留白
 Style Rules:
-  Do: 标题直接写结论；优先使用真实证据；保持 16:9；统一左对齐或明确的中心对齐；所有小字确保可读；每个数字附口径或日期
-  Don't: 不使用深色满版背景；不堆复杂坐标轴；不使用无关图库人物；不编造客户、订单、留存或收入；不把 Agent 团队写成产品类别；不使用发光、玻璃拟态、过多描边和装饰线
+  Do: 标题直接表达结论；每页为口头讲述提供一个视觉锚点；明确数据日期与证据边界
+  Don't: 不伪造产品 UI、客户、订单、留存或收入；不重复解释 Agent 团队；不让技术名词成为标题主体；不使用深色满版背景
 &lt;/STYLE_INSTRUCTIONS&gt;
 ## SLIDE CONTENT
-## Slide 8 of 18
+## Slide 8 of 13
 **Type**: Content
-**Filename**: 08-slide-provider-neutral.png
+**Filename**: 08-slide-business-model.png
 // NARRATIVE GOAL
-说明供应商中立与适配层为什么构成技术壁垒，同时避免只炫耀接入数量。
+解释 C/B 双轨如何共享产品底座，并把高校教育作为明确 B 端切口。
 // KEY CONTENT
-Headline: 31 种 Agent Client，让 Yoda 成为供应商中立的控制层
-Sub-headline: 用户可以更换模型和客户端，但持续保留自己的工作方式与 Harness 资产
+Headline: C 端验证产品，B 端教育放大客单价
+Sub-headline: 个人订阅与机构年约共享同一套 Harness 底座
 Body:
-- 统一命令、事件、会话恢复与状态语义
-- 向下连接执行工具，向上连接 Review、CI 与发布
+- C 端：Desktop → Relay / Creator Pro → Studio
+- B 端：付费试点 → Education 产品包 → 机构年约
 // VISUAL
-三层架构：顶部少量代表性 Agent Client 标志和“+26”；中央是一条醒目的 Yoda Harness 横梁；底部是 Diff、Test、CI/CD、Release。不要把 31 个 Logo 全部堆满页面。
+左侧两条简洁收入路径；右侧使用真实 AI 创造营照片，标注为渠道与培训场景证明、不是 Yoda 客户案例。
 // LAYOUT
-Layout: hierarchical-layers
-中央 Yoda 层为唯一绿色大色块，其余使用黑白灰；右下小字注明“31 种，按仓库当前统计口径”。
+Layout: split-screen
 ## Production Note
 +Render with deterministic HTML/CSS/SVG composition so Chinese text, data values, citations and evidence boundaries remain exact. Rasterize the final 1600 × 900 canvas to PNG.
 </a:t>
@@ -4450,49 +3321,50 @@
 - The source skill's generic hand-drawn rule is intentionally overridden by this deck's confirmed custom investor style and the user's request for real evidence.
 ## STYLE_INSTRUCTIONS
 &lt;STYLE_INSTRUCTIONS&gt;
-Design Aesthetic: 苹果发布会式清晰度、咨询报告式可信度与创业团队真实感的结合。整体采用暖白、暖灰背景和精确的现代几何排版，只使用 Yoda 绿作为品牌强调色；每页用一句结论统领一个观点，让真实截图、数据或流程承担主要叙事。
+Design Aesthetic: 简单、具体、可信，带一点野心。像优秀种子轮融资材料，而不是产品功能说明书。使用苹果发布会式的清晰度、咨询报告式的证据意识和创业团队的真实感。
 Background:
-  Texture: clean，纯色背景，无纸张纹理、渐变噪点或装饰图案
-  Base Color: 暖白 #F7F5F0 为主，暖灰 #E9E9E6 用于分区和数据底板
+  Texture: clean，纯色，无纹理、网格、渐变或装饰背景
+  Base Color: 暖白 #F7F6F2；只在少数对比页使用极浅暖灰 #EFEEE9
 Typography:
-  Headlines: 粗体几何无衬线，笔画干净、结构克制、尺度强烈；中文视觉接近现代黑体
-  Body: 清晰现代无衬线，适合屏幕阅读；正文视觉尺寸不小于 20pt，数字可用等宽特征增强可信度
+  Headlines: 现代粗体无衬线，结论式标题，54–72px，严格控制在两行内
+  Body: 现代无衬线，24–30px；脚注可缩小但必须清晰
+  Numbers: 大号、直接、附口径，不放在多层卡片中
 Color Palette:
-  Primary Text: 墨黑 #111111 - 标题、关键结论和核心数字
-  Background: 暖白 #F7F5F0 - 主要画布
-  Surface: 暖灰 #E9E9E6 - 卡片、对照区和数据底板
-  Accent 1: Yoda Green #5DC98F - 唯一品牌强调色，用于关键节点、箭头和数字
-  Secondary Text: 中灰 #71717A - 注释、来源和非核心信息
+  Primary Text: #111111
+  Secondary Text: #62645F
+  Hairline: #D7D6D0
+  Brand Accent: Yoda Deep Green #173D2A
+  Secondary Accent: Yoda Green #5DC98F，仅用于一个关键节点或数字
 Visual Elements:
-  - 真实 Yoda 产品截图、用户现场、活动照片、访谈或数据证据优先于图库照片
-  - 使用细线流程图、简洁箭头、少量圆角底板和大数字，不使用 3D 插画或装饰性图标堆叠
-  - 图表弱化坐标轴，直接标注趋势、口径和结论
-  - 每页最多一个主视觉；照片保持真实色彩，只做必要裁切和轻微降饱和
+  - 真实产品截图、真实用户现场和真实数据优先
+  - 只使用细线、少量色块、流程轨道和大数字
+  - 每页最多一个主视觉；圆角底板最多一块
+  - 不使用图标墙、胶囊标签堆叠、装饰性箭头、阴影卡片阵列或复杂坐标轴
 Density Guidelines:
-  - Content per slide: 一个核心观点，标题 + 最多 2–3 个支撑点；数据页允许 3–5 个关键数字
-  - Whitespace: 四周至少保留 12%–15% 安全边距，主视觉与文字之间保持明显呼吸感
+  - 每页一个结论，最多 2 个支撑层级
+  - 四周保留 80–100px 安全边距
+  - 页面至少 40% 留白
 Style Rules:
-  Do: 标题直接写结论；优先使用真实证据；保持 16:9；统一左对齐或明确的中心对齐；所有小字确保可读；每个数字附口径或日期
-  Don't: 不使用深色满版背景；不堆复杂坐标轴；不使用无关图库人物；不编造客户、订单、留存或收入；不把 Agent 团队写成产品类别；不使用发光、玻璃拟态、过多描边和装饰线
+  Do: 标题直接表达结论；每页为口头讲述提供一个视觉锚点；明确数据日期与证据边界
+  Don't: 不伪造产品 UI、客户、订单、留存或收入；不重复解释 Agent 团队；不让技术名词成为标题主体；不使用深色满版背景
 &lt;/STYLE_INSTRUCTIONS&gt;
 ## SLIDE CONTENT
-## Slide 9 of 18
+## Slide 9 of 13
 **Type**: Content
-**Filename**: 09-slide-why-now.png
+**Filename**: 09-slide-market.png
 // NARRATIVE GOAL
-用可验证趋势说明现在是 Harness 窗口，而不是宽泛重复 AI 增长叙事。
+把市场规模与切入路径放在同一张图里，避免先讲大市场再重复讲用户。
 // KEY CONTENT
-Headline: 模型商品化与创作者扩张，让 Harness 迎来窗口期
-Sub-headline: AI 越普及，人越需要统一的组织、控制与验收层
+Headline: 从超级开发者切入一个 248 亿美元创作者工具市场
+Sub-headline: 先服务高频 Coding 创作者，再扩展到 AI 原生个人与团队
 Body:
-- 75% 的受访创作者认为创意 AI 已融入或成为工作流必要部分
-- 85% 仍认为最终创意决策应由人完成
-- 来源：Adobe 2026 Creators’ Toolkit Report
+- TAM：248 亿美元
+- SAM：24.8 亿美元
+- 三年 SOM：240 万美元 ARR
 // VISUAL
-两个超大数字“75%”与“85%”分列左右，中间用一句结论连接：“AI 执行，人负责驾驭与品味”。弱化统计装饰，不画柱状图。
+左侧三个同心圆表达切入路径；右侧三行大数字表达 TAM/SAM/SOM。每个数字只配一行口径。
 // LAYOUT
-Layout: two-columns
-两个数字各自占据半页，下方保留小字号来源与调查口径提示。
+Layout: split-screen
 ## Production Note
 +Render with deterministic HTML/CSS/SVG composition so Chinese text, data values, citations and evidence boundaries remain exact. Rasterize the final 1600 × 900 canvas to PNG.
 </a:t>
@@ -5039,246 +3911,6 @@
 <file path=ppt/slides/slide13.xml><?xml version="1.0" encoding="utf-8"?>
 <p:sld xmlns:a="http://schemas.openxmlformats.org/drawingml/2006/main" xmlns:r="http://schemas.openxmlformats.org/officeDocument/2006/relationships" xmlns:p="http://schemas.openxmlformats.org/presentationml/2006/main">
   <p:cSld name="Slide 13">
-    <p:spTree>
-      <p:nvGrpSpPr>
-        <p:cNvPr id="1" name=""/>
-        <p:cNvGrpSpPr/>
-        <p:nvPr/>
-      </p:nvGrpSpPr>
-      <p:grpSpPr>
-        <a:xfrm>
-          <a:off x="0" y="0"/>
-          <a:ext cx="0" cy="0"/>
-          <a:chOff x="0" y="0"/>
-          <a:chExt cx="0" cy="0"/>
-        </a:xfrm>
-      </p:grpSpPr>
-      <p:pic>
-        <p:nvPicPr>
-          <p:cNvPr id="2" name="Image 0" descr="preencoded.png">    </p:cNvPr>
-          <p:cNvPicPr>
-            <a:picLocks noChangeAspect="1"/>
-          </p:cNvPicPr>
-          <p:nvPr/>
-        </p:nvPicPr>
-        <p:blipFill>
-          <a:blip r:embed="rId1"/>
-          <a:srcRect l="0" r="0" t="0" b="0"/>
-          <a:stretch/>
-        </p:blipFill>
-        <p:spPr>
-          <a:xfrm>
-            <a:off x="0" y="0"/>
-            <a:ext cx="9144000" cy="5143500"/>
-          </a:xfrm>
-          <a:prstGeom prst="rect">
-            <a:avLst/>
-          </a:prstGeom>
-        </p:spPr>
-      </p:pic>
-    </p:spTree>
-  </p:cSld>
-  <p:clrMapOvr>
-    <a:masterClrMapping/>
-  </p:clrMapOvr>
-</p:sld>
-</file>
-
-<file path=ppt/slides/slide14.xml><?xml version="1.0" encoding="utf-8"?>
-<p:sld xmlns:a="http://schemas.openxmlformats.org/drawingml/2006/main" xmlns:r="http://schemas.openxmlformats.org/officeDocument/2006/relationships" xmlns:p="http://schemas.openxmlformats.org/presentationml/2006/main">
-  <p:cSld name="Slide 14">
-    <p:spTree>
-      <p:nvGrpSpPr>
-        <p:cNvPr id="1" name=""/>
-        <p:cNvGrpSpPr/>
-        <p:nvPr/>
-      </p:nvGrpSpPr>
-      <p:grpSpPr>
-        <a:xfrm>
-          <a:off x="0" y="0"/>
-          <a:ext cx="0" cy="0"/>
-          <a:chOff x="0" y="0"/>
-          <a:chExt cx="0" cy="0"/>
-        </a:xfrm>
-      </p:grpSpPr>
-      <p:pic>
-        <p:nvPicPr>
-          <p:cNvPr id="2" name="Image 0" descr="preencoded.png">    </p:cNvPr>
-          <p:cNvPicPr>
-            <a:picLocks noChangeAspect="1"/>
-          </p:cNvPicPr>
-          <p:nvPr/>
-        </p:nvPicPr>
-        <p:blipFill>
-          <a:blip r:embed="rId1"/>
-          <a:srcRect l="0" r="0" t="0" b="0"/>
-          <a:stretch/>
-        </p:blipFill>
-        <p:spPr>
-          <a:xfrm>
-            <a:off x="0" y="0"/>
-            <a:ext cx="9144000" cy="5143500"/>
-          </a:xfrm>
-          <a:prstGeom prst="rect">
-            <a:avLst/>
-          </a:prstGeom>
-        </p:spPr>
-      </p:pic>
-    </p:spTree>
-  </p:cSld>
-  <p:clrMapOvr>
-    <a:masterClrMapping/>
-  </p:clrMapOvr>
-</p:sld>
-</file>
-
-<file path=ppt/slides/slide15.xml><?xml version="1.0" encoding="utf-8"?>
-<p:sld xmlns:a="http://schemas.openxmlformats.org/drawingml/2006/main" xmlns:r="http://schemas.openxmlformats.org/officeDocument/2006/relationships" xmlns:p="http://schemas.openxmlformats.org/presentationml/2006/main">
-  <p:cSld name="Slide 15">
-    <p:spTree>
-      <p:nvGrpSpPr>
-        <p:cNvPr id="1" name=""/>
-        <p:cNvGrpSpPr/>
-        <p:nvPr/>
-      </p:nvGrpSpPr>
-      <p:grpSpPr>
-        <a:xfrm>
-          <a:off x="0" y="0"/>
-          <a:ext cx="0" cy="0"/>
-          <a:chOff x="0" y="0"/>
-          <a:chExt cx="0" cy="0"/>
-        </a:xfrm>
-      </p:grpSpPr>
-      <p:pic>
-        <p:nvPicPr>
-          <p:cNvPr id="2" name="Image 0" descr="preencoded.png">    </p:cNvPr>
-          <p:cNvPicPr>
-            <a:picLocks noChangeAspect="1"/>
-          </p:cNvPicPr>
-          <p:nvPr/>
-        </p:nvPicPr>
-        <p:blipFill>
-          <a:blip r:embed="rId1"/>
-          <a:srcRect l="0" r="0" t="0" b="0"/>
-          <a:stretch/>
-        </p:blipFill>
-        <p:spPr>
-          <a:xfrm>
-            <a:off x="0" y="0"/>
-            <a:ext cx="9144000" cy="5143500"/>
-          </a:xfrm>
-          <a:prstGeom prst="rect">
-            <a:avLst/>
-          </a:prstGeom>
-        </p:spPr>
-      </p:pic>
-    </p:spTree>
-  </p:cSld>
-  <p:clrMapOvr>
-    <a:masterClrMapping/>
-  </p:clrMapOvr>
-</p:sld>
-</file>
-
-<file path=ppt/slides/slide16.xml><?xml version="1.0" encoding="utf-8"?>
-<p:sld xmlns:a="http://schemas.openxmlformats.org/drawingml/2006/main" xmlns:r="http://schemas.openxmlformats.org/officeDocument/2006/relationships" xmlns:p="http://schemas.openxmlformats.org/presentationml/2006/main">
-  <p:cSld name="Slide 16">
-    <p:spTree>
-      <p:nvGrpSpPr>
-        <p:cNvPr id="1" name=""/>
-        <p:cNvGrpSpPr/>
-        <p:nvPr/>
-      </p:nvGrpSpPr>
-      <p:grpSpPr>
-        <a:xfrm>
-          <a:off x="0" y="0"/>
-          <a:ext cx="0" cy="0"/>
-          <a:chOff x="0" y="0"/>
-          <a:chExt cx="0" cy="0"/>
-        </a:xfrm>
-      </p:grpSpPr>
-      <p:pic>
-        <p:nvPicPr>
-          <p:cNvPr id="2" name="Image 0" descr="preencoded.png">    </p:cNvPr>
-          <p:cNvPicPr>
-            <a:picLocks noChangeAspect="1"/>
-          </p:cNvPicPr>
-          <p:nvPr/>
-        </p:nvPicPr>
-        <p:blipFill>
-          <a:blip r:embed="rId1"/>
-          <a:srcRect l="0" r="0" t="0" b="0"/>
-          <a:stretch/>
-        </p:blipFill>
-        <p:spPr>
-          <a:xfrm>
-            <a:off x="0" y="0"/>
-            <a:ext cx="9144000" cy="5143500"/>
-          </a:xfrm>
-          <a:prstGeom prst="rect">
-            <a:avLst/>
-          </a:prstGeom>
-        </p:spPr>
-      </p:pic>
-    </p:spTree>
-  </p:cSld>
-  <p:clrMapOvr>
-    <a:masterClrMapping/>
-  </p:clrMapOvr>
-</p:sld>
-</file>
-
-<file path=ppt/slides/slide17.xml><?xml version="1.0" encoding="utf-8"?>
-<p:sld xmlns:a="http://schemas.openxmlformats.org/drawingml/2006/main" xmlns:r="http://schemas.openxmlformats.org/officeDocument/2006/relationships" xmlns:p="http://schemas.openxmlformats.org/presentationml/2006/main">
-  <p:cSld name="Slide 17">
-    <p:spTree>
-      <p:nvGrpSpPr>
-        <p:cNvPr id="1" name=""/>
-        <p:cNvGrpSpPr/>
-        <p:nvPr/>
-      </p:nvGrpSpPr>
-      <p:grpSpPr>
-        <a:xfrm>
-          <a:off x="0" y="0"/>
-          <a:ext cx="0" cy="0"/>
-          <a:chOff x="0" y="0"/>
-          <a:chExt cx="0" cy="0"/>
-        </a:xfrm>
-      </p:grpSpPr>
-      <p:pic>
-        <p:nvPicPr>
-          <p:cNvPr id="2" name="Image 0" descr="preencoded.png">    </p:cNvPr>
-          <p:cNvPicPr>
-            <a:picLocks noChangeAspect="1"/>
-          </p:cNvPicPr>
-          <p:nvPr/>
-        </p:nvPicPr>
-        <p:blipFill>
-          <a:blip r:embed="rId1"/>
-          <a:srcRect l="0" r="0" t="0" b="0"/>
-          <a:stretch/>
-        </p:blipFill>
-        <p:spPr>
-          <a:xfrm>
-            <a:off x="0" y="0"/>
-            <a:ext cx="9144000" cy="5143500"/>
-          </a:xfrm>
-          <a:prstGeom prst="rect">
-            <a:avLst/>
-          </a:prstGeom>
-        </p:spPr>
-      </p:pic>
-    </p:spTree>
-  </p:cSld>
-  <p:clrMapOvr>
-    <a:masterClrMapping/>
-  </p:clrMapOvr>
-</p:sld>
-</file>
-
-<file path=ppt/slides/slide18.xml><?xml version="1.0" encoding="utf-8"?>
-<p:sld xmlns:a="http://schemas.openxmlformats.org/drawingml/2006/main" xmlns:r="http://schemas.openxmlformats.org/officeDocument/2006/relationships" xmlns:p="http://schemas.openxmlformats.org/presentationml/2006/main">
-  <p:cSld name="Slide 18">
     <p:spTree>
       <p:nvGrpSpPr>
         <p:cNvPr id="1" name=""/>

</xml_diff>

<commit_message>
docs: rebuild Yoda investor deck around delegation
</commit_message>
<xml_diff>
--- a/slide-deck/yoda-business-plan/yoda-business-plan.pptx
+++ b/slide-deck/yoda-business-plan/yoda-business-plan.pptx
@@ -18,9 +18,11 @@
     <p:sldId id="266" r:id="rId12"/>
     <p:sldId id="267" r:id="rId13"/>
     <p:sldId id="268" r:id="rId14"/>
+    <p:sldId id="269" r:id="rId15"/>
+    <p:sldId id="270" r:id="rId16"/>
   </p:sldIdLst>
   <p:notesMasterIdLst>
-    <p:notesMasterId r:id="rId15"/>
+    <p:notesMasterId r:id="rId17"/>
   </p:notesMasterIdLst>
   <p:sldSz cx="9144000" cy="5143500"/>
   <p:notesSz cx="5143500" cy="9144000"/>
@@ -607,46 +609,42 @@
 - The source skill's generic hand-drawn rule is intentionally overridden by this deck's confirmed custom investor style and the user's request for real evidence.
 ## STYLE_INSTRUCTIONS
 &lt;STYLE_INSTRUCTIONS&gt;
-Design Aesthetic: 简单、具体、可信，带一点野心。像优秀种子轮融资材料，而不是产品功能说明书。使用苹果发布会式的清晰度、咨询报告式的证据意识和创业团队的真实感。
+Design Aesthetic: 专业投资人材料。以咨询报告的数据表达、产品发布会的视觉层级和真实创业项目的证据感为基准。每页标题给出结论，图表承担论证，文字只负责解释口径。
 Background:
-  Texture: clean，纯色，无纹理、网格、渐变或装饰背景
-  Base Color: 暖白 #F7F6F2；只在少数对比页使用极浅暖灰 #EFEEE9
+  Base: warm white #F6F5F1
+  Alternate: pale stone #ECEBE6
+  Chart Grid: #D4D5D0
 Typography:
-  Headlines: 现代粗体无衬线，结论式标题，54–72px，严格控制在两行内
-  Body: 现代无衬线，24–30px；脚注可缩小但必须清晰
-  Numbers: 大号、直接、附口径，不放在多层卡片中
+  Headlines: modern geometric sans, 52–68px, max two lines
+  Body: 22–28px
+  Chart Labels: 17–21px
+  Numeric Highlights: 54–110px
 Color Palette:
-  Primary Text: #111111
-  Secondary Text: #62645F
-  Hairline: #D7D6D0
-  Brand Accent: Yoda Deep Green #173D2A
-  Secondary Accent: Yoda Green #5DC98F，仅用于一个关键节点或数字
-Visual Elements:
-  - 真实产品截图、真实用户现场和真实数据优先
-  - 只使用细线、少量色块、流程轨道和大数字
-  - 每页最多一个主视觉；圆角底板最多一块
-  - 不使用图标墙、胶囊标签堆叠、装饰性箭头、阴影卡片阵列或复杂坐标轴
-Density Guidelines:
-  - 每页一个结论，最多 2 个支撑层级
-  - 四周保留 80–100px 安全边距
-  - 页面至少 40% 留白
-Style Rules:
-  Do: 标题直接表达结论；每页为口头讲述提供一个视觉锚点；明确数据日期与证据边界
-  Don't: 不伪造产品 UI、客户、订单、留存或收入；不重复解释 Agent 团队；不让技术名词成为标题主体；不使用深色满版背景
+  Ink: #111312
+  Muted: #626762
+  Yoda Deep Green: #173D2A
+  Yoda Green: #5DC98F
+  Comparison Blue: #526A7A
+  Risk Gray: #A9AAA5
+Chart Language:
+  - 使用坐标轴、刻度、图例、注释线、象限、流程轨道、阶梯和环形图
+  - 每张图必须有明确结论和口径；概念曲线标注“趋势示意”
+  - 不使用伪精确数据，不使用无来源增长曲线
+  - 产品图使用真实截图；图片附边界说明
+Layout Rules:
+  - 16:9，四周 76–92px 安全边距
+  - 每页一个主图表，至少 35% 留白
+  - 不使用多层圆角卡片、装饰图标、渐变背景、玻璃拟态或无意义插画
+  - 统一左对齐；来源置底，字号不小于 15px
 &lt;/STYLE_INSTRUCTIONS&gt;
 ## SLIDE CONTENT
-## Slide 1 of 13
+## Slide 1 of 15
 **Type**: Cover
 **Filename**: 01-slide-cover.png
-// NARRATIVE GOAL
-一句话说明产品是谁、服务谁、创造什么价值。
-// KEY CONTENT
-Headline: Yoda：超级开发者的 AI Harness 工作台
-Sub-headline: 统一 Agent、上下文与交付，让 AI 真正进入持续创造
-Body: 融资版 BP · 2026.07
-// VISUAL
-暖白底，大标题占据左侧；右侧只有一条从“想法”走向“作品”的细绿色轨道。无功能标签、无多余口号。
-// LAYOUT
+Headline: Yoda｜Agent 时代的集成委托环境
+Sub-headline: 面向超级开发者与 AI 原生团队的开源桌面工作区
+Key line: 让人管理意图、委托、证据与交付，而不只是编辑代码
+Visual: 用一条细轨道连接 Intention → Delegation → Evidence → Delivery；右侧标注 Integrated Delegation Environment。
 Layout: title-hero
 ## Production Note
 +Render with deterministic HTML/CSS/SVG composition so Chinese text, data values, citations and evidence boundaries remain exact. Rasterize the final 1600 × 900 canvas to PNG.
@@ -831,50 +829,45 @@
 - The source skill's generic hand-drawn rule is intentionally overridden by this deck's confirmed custom investor style and the user's request for real evidence.
 ## STYLE_INSTRUCTIONS
 &lt;STYLE_INSTRUCTIONS&gt;
-Design Aesthetic: 简单、具体、可信，带一点野心。像优秀种子轮融资材料，而不是产品功能说明书。使用苹果发布会式的清晰度、咨询报告式的证据意识和创业团队的真实感。
+Design Aesthetic: 专业投资人材料。以咨询报告的数据表达、产品发布会的视觉层级和真实创业项目的证据感为基准。每页标题给出结论，图表承担论证，文字只负责解释口径。
 Background:
-  Texture: clean，纯色，无纹理、网格、渐变或装饰背景
-  Base Color: 暖白 #F7F6F2；只在少数对比页使用极浅暖灰 #EFEEE9
+  Base: warm white #F6F5F1
+  Alternate: pale stone #ECEBE6
+  Chart Grid: #D4D5D0
 Typography:
-  Headlines: 现代粗体无衬线，结论式标题，54–72px，严格控制在两行内
-  Body: 现代无衬线，24–30px；脚注可缩小但必须清晰
-  Numbers: 大号、直接、附口径，不放在多层卡片中
+  Headlines: modern geometric sans, 52–68px, max two lines
+  Body: 22–28px
+  Chart Labels: 17–21px
+  Numeric Highlights: 54–110px
 Color Palette:
-  Primary Text: #111111
-  Secondary Text: #62645F
-  Hairline: #D7D6D0
-  Brand Accent: Yoda Deep Green #173D2A
-  Secondary Accent: Yoda Green #5DC98F，仅用于一个关键节点或数字
-Visual Elements:
-  - 真实产品截图、真实用户现场和真实数据优先
-  - 只使用细线、少量色块、流程轨道和大数字
-  - 每页最多一个主视觉；圆角底板最多一块
-  - 不使用图标墙、胶囊标签堆叠、装饰性箭头、阴影卡片阵列或复杂坐标轴
-Density Guidelines:
-  - 每页一个结论，最多 2 个支撑层级
-  - 四周保留 80–100px 安全边距
-  - 页面至少 40% 留白
-Style Rules:
-  Do: 标题直接表达结论；每页为口头讲述提供一个视觉锚点；明确数据日期与证据边界
-  Don't: 不伪造产品 UI、客户、订单、留存或收入；不重复解释 Agent 团队；不让技术名词成为标题主体；不使用深色满版背景
+  Ink: #111312
+  Muted: #626762
+  Yoda Deep Green: #173D2A
+  Yoda Green: #5DC98F
+  Comparison Blue: #526A7A
+  Risk Gray: #A9AAA5
+Chart Language:
+  - 使用坐标轴、刻度、图例、注释线、象限、流程轨道、阶梯和环形图
+  - 每张图必须有明确结论和口径；概念曲线标注“趋势示意”
+  - 不使用伪精确数据，不使用无来源增长曲线
+  - 产品图使用真实截图；图片附边界说明
+Layout Rules:
+  - 16:9，四周 76–92px 安全边距
+  - 每页一个主图表，至少 35% 留白
+  - 不使用多层圆角卡片、装饰图标、渐变背景、玻璃拟态或无意义插画
+  - 统一左对齐；来源置底，字号不小于 15px
 &lt;/STYLE_INSTRUCTIONS&gt;
 ## SLIDE CONTENT
-## Slide 10 of 13
+## Slide 10 of 15
 **Type**: Content
-**Filename**: 10-slide-differentiation.png
-// NARRATIVE GOAL
-让投资人理解竞争边界和差异化，不列竞品 Logo 墙。
-// KEY CONTENT
-Headline: Yoda 不卷模型，也不把 Agent 团队当产品终局
-Sub-headline: Yoda 占据跨客户端组织工作、沉淀资产与完成交付的 Harness 层
-Body:
-- 供应商中立：31 种 Agent Client
-- 资产沉淀：Skills、Memory、工作流
-- 交付闭环：Review、Test、CI/CD、Release
-// VISUAL
-三层结构中只高亮 Yoda Harness；右侧三条差异化证据，不使用竞品 Logo。
-// LAYOUT
-Layout: layered-comparison
+**Filename**: 10-slide-market.png
+Headline: 超级开发者是楔子，集成委托环境是更大的市场
+Sub-headline: 从高频 Coding 创作者扩展到 AI 原生个人与小型团队
+Chart: 同心市场 + TAM/SAM/SOM
+- TAM：248 亿美元创作者工具市场
+- SAM：24.8 亿美元，假设 10% 适配率
+- 三年 SOM：240 万美元 ARR，2 万账户 × 120 美元
+Layout: market-rings
 ## Production Note
 +Render with deterministic HTML/CSS/SVG composition so Chinese text, data values, citations and evidence boundaries remain exact. Rasterize the final 1600 × 900 canvas to PNG.
 </a:t>
@@ -1058,51 +1051,45 @@
 - The source skill's generic hand-drawn rule is intentionally overridden by this deck's confirmed custom investor style and the user's request for real evidence.
 ## STYLE_INSTRUCTIONS
 &lt;STYLE_INSTRUCTIONS&gt;
-Design Aesthetic: 简单、具体、可信，带一点野心。像优秀种子轮融资材料，而不是产品功能说明书。使用苹果发布会式的清晰度、咨询报告式的证据意识和创业团队的真实感。
+Design Aesthetic: 专业投资人材料。以咨询报告的数据表达、产品发布会的视觉层级和真实创业项目的证据感为基准。每页标题给出结论，图表承担论证，文字只负责解释口径。
 Background:
-  Texture: clean，纯色，无纹理、网格、渐变或装饰背景
-  Base Color: 暖白 #F7F6F2；只在少数对比页使用极浅暖灰 #EFEEE9
+  Base: warm white #F6F5F1
+  Alternate: pale stone #ECEBE6
+  Chart Grid: #D4D5D0
 Typography:
-  Headlines: 现代粗体无衬线，结论式标题，54–72px，严格控制在两行内
-  Body: 现代无衬线，24–30px；脚注可缩小但必须清晰
-  Numbers: 大号、直接、附口径，不放在多层卡片中
+  Headlines: modern geometric sans, 52–68px, max two lines
+  Body: 22–28px
+  Chart Labels: 17–21px
+  Numeric Highlights: 54–110px
 Color Palette:
-  Primary Text: #111111
-  Secondary Text: #62645F
-  Hairline: #D7D6D0
-  Brand Accent: Yoda Deep Green #173D2A
-  Secondary Accent: Yoda Green #5DC98F，仅用于一个关键节点或数字
-Visual Elements:
-  - 真实产品截图、真实用户现场和真实数据优先
-  - 只使用细线、少量色块、流程轨道和大数字
-  - 每页最多一个主视觉；圆角底板最多一块
-  - 不使用图标墙、胶囊标签堆叠、装饰性箭头、阴影卡片阵列或复杂坐标轴
-Density Guidelines:
-  - 每页一个结论，最多 2 个支撑层级
-  - 四周保留 80–100px 安全边距
-  - 页面至少 40% 留白
-Style Rules:
-  Do: 标题直接表达结论；每页为口头讲述提供一个视觉锚点；明确数据日期与证据边界
-  Don't: 不伪造产品 UI、客户、订单、留存或收入；不重复解释 Agent 团队；不让技术名词成为标题主体；不使用深色满版背景
+  Ink: #111312
+  Muted: #626762
+  Yoda Deep Green: #173D2A
+  Yoda Green: #5DC98F
+  Comparison Blue: #526A7A
+  Risk Gray: #A9AAA5
+Chart Language:
+  - 使用坐标轴、刻度、图例、注释线、象限、流程轨道、阶梯和环形图
+  - 每张图必须有明确结论和口径；概念曲线标注“趋势示意”
+  - 不使用伪精确数据，不使用无来源增长曲线
+  - 产品图使用真实截图；图片附边界说明
+Layout Rules:
+  - 16:9，四周 76–92px 安全边距
+  - 每页一个主图表，至少 35% 留白
+  - 不使用多层圆角卡片、装饰图标、渐变背景、玻璃拟态或无意义插画
+  - 统一左对齐；来源置底，字号不小于 15px
 &lt;/STYLE_INSTRUCTIONS&gt;
 ## SLIDE CONTENT
-## Slide 11 of 13
+## Slide 11 of 15
 **Type**: Content
-**Filename**: 11-slide-growth.png
-// NARRATIVE GOAL
-把 18–24 个月计划压缩为四个可验证阶段。
-// KEY CONTENT
-Headline: 下一阶段只验证一件事：可重复增长
-Sub-headline: 先做实体验与数据，再验证个人付费和机构年约
-Body:
-- 0–3 月：体验、埋点、20 位深访
-- 4–6 月：自然增长、2–3 家设计伙伴
-- 7–12 月：个人付费与机构试点
-- 13–24 月：机构年约、渠道与英文市场
-// VISUAL
-一条四阶段时间轴；每段只有阶段名、目标和一个关键验证信号。
-// LAYOUT
-Layout: timeline-horizontal
+**Filename**: 11-slide-competition.png
+Headline: 市场上多数产品优化“执行”，Yoda 优化“可靠委托”
+Chart: 二维竞争象限
+X 轴：单一生态绑定 → 供应商中立
+Y 轴：代码执行工具 → 委托治理系统
+Plot: VS Code/Cursor、Codex App、Conductor、Agent Team Tools、Yoda
+Footnote: 基于公开产品定位与当前功能的定性判断，不代表第三方厂商自我定义。
+Layout: quadrant-chart
 ## Production Note
 +Render with deterministic HTML/CSS/SVG composition so Chinese text, data values, citations and evidence boundaries remain exact. Rasterize the final 1600 × 900 canvas to PNG.
 </a:t>
@@ -1286,50 +1273,47 @@
 - The source skill's generic hand-drawn rule is intentionally overridden by this deck's confirmed custom investor style and the user's request for real evidence.
 ## STYLE_INSTRUCTIONS
 &lt;STYLE_INSTRUCTIONS&gt;
-Design Aesthetic: 简单、具体、可信，带一点野心。像优秀种子轮融资材料，而不是产品功能说明书。使用苹果发布会式的清晰度、咨询报告式的证据意识和创业团队的真实感。
+Design Aesthetic: 专业投资人材料。以咨询报告的数据表达、产品发布会的视觉层级和真实创业项目的证据感为基准。每页标题给出结论，图表承担论证，文字只负责解释口径。
 Background:
-  Texture: clean，纯色，无纹理、网格、渐变或装饰背景
-  Base Color: 暖白 #F7F6F2；只在少数对比页使用极浅暖灰 #EFEEE9
+  Base: warm white #F6F5F1
+  Alternate: pale stone #ECEBE6
+  Chart Grid: #D4D5D0
 Typography:
-  Headlines: 现代粗体无衬线，结论式标题，54–72px，严格控制在两行内
-  Body: 现代无衬线，24–30px；脚注可缩小但必须清晰
-  Numbers: 大号、直接、附口径，不放在多层卡片中
+  Headlines: modern geometric sans, 52–68px, max two lines
+  Body: 22–28px
+  Chart Labels: 17–21px
+  Numeric Highlights: 54–110px
 Color Palette:
-  Primary Text: #111111
-  Secondary Text: #62645F
-  Hairline: #D7D6D0
-  Brand Accent: Yoda Deep Green #173D2A
-  Secondary Accent: Yoda Green #5DC98F，仅用于一个关键节点或数字
-Visual Elements:
-  - 真实产品截图、真实用户现场和真实数据优先
-  - 只使用细线、少量色块、流程轨道和大数字
-  - 每页最多一个主视觉；圆角底板最多一块
-  - 不使用图标墙、胶囊标签堆叠、装饰性箭头、阴影卡片阵列或复杂坐标轴
-Density Guidelines:
-  - 每页一个结论，最多 2 个支撑层级
-  - 四周保留 80–100px 安全边距
-  - 页面至少 40% 留白
-Style Rules:
-  Do: 标题直接表达结论；每页为口头讲述提供一个视觉锚点；明确数据日期与证据边界
-  Don't: 不伪造产品 UI、客户、订单、留存或收入；不重复解释 Agent 团队；不让技术名词成为标题主体；不使用深色满版背景
+  Ink: #111312
+  Muted: #626762
+  Yoda Deep Green: #173D2A
+  Yoda Green: #5DC98F
+  Comparison Blue: #526A7A
+  Risk Gray: #A9AAA5
+Chart Language:
+  - 使用坐标轴、刻度、图例、注释线、象限、流程轨道、阶梯和环形图
+  - 每张图必须有明确结论和口径；概念曲线标注“趋势示意”
+  - 不使用伪精确数据，不使用无来源增长曲线
+  - 产品图使用真实截图；图片附边界说明
+Layout Rules:
+  - 16:9，四周 76–92px 安全边距
+  - 每页一个主图表，至少 35% 留白
+  - 不使用多层圆角卡片、装饰图标、渐变背景、玻璃拟态或无意义插画
+  - 统一左对齐；来源置底，字号不小于 15px
 &lt;/STYLE_INSTRUCTIONS&gt;
 ## SLIDE CONTENT
-## Slide 12 of 13
+## Slide 12 of 15
 **Type**: Content
-**Filename**: 12-slide-team.png
-// NARRATIVE GOAL
-用真实执行数据证明 Founder–Product Fit。
-// KEY CONTENT
-Headline: Yoda 用 Yoda 开发自己，迭代速度就是第一份背书
-Sub-headline: 创始人长期横跨开发工具、内容创作与 AI 产品化
-Body:
-- 1,645 次 main 提交
-- 73 个公开 Release
-- 31 种 Agent Client 适配
-// VISUAL
-左侧真实分享现场照片；右侧一句结论和三个无底板大数字。
-// LAYOUT
-Layout: split-screen
+**Filename**: 12-slide-business-model.png
+Headline: 本地核心开源，连续性与协作秩序收费
+Sub-headline: 个人为“离开电脑仍能继续”付费，团队为治理、证据和可追责协作付费
+Chart: 五级价值阶梯
+- Open Source Core：本地工作区、数据与选择权
+- Relay：跨网络连接与设备连续性
+- Creator Pro：同步、自动化、备份、长期任务
+- Education / Team：课程包、共享资产、权限、审计、预算
+- Enterprise：私有化、统一身份、内部模型、合规与 SLA
+Layout: revenue-staircase
 ## Production Note
 +Render with deterministic HTML/CSS/SVG composition so Chinese text, data values, citations and evidence boundaries remain exact. Rasterize the final 1600 × 900 canvas to PNG.
 </a:t>
@@ -1513,50 +1497,493 @@
 - The source skill's generic hand-drawn rule is intentionally overridden by this deck's confirmed custom investor style and the user's request for real evidence.
 ## STYLE_INSTRUCTIONS
 &lt;STYLE_INSTRUCTIONS&gt;
-Design Aesthetic: 简单、具体、可信，带一点野心。像优秀种子轮融资材料，而不是产品功能说明书。使用苹果发布会式的清晰度、咨询报告式的证据意识和创业团队的真实感。
+Design Aesthetic: 专业投资人材料。以咨询报告的数据表达、产品发布会的视觉层级和真实创业项目的证据感为基准。每页标题给出结论，图表承担论证，文字只负责解释口径。
 Background:
-  Texture: clean，纯色，无纹理、网格、渐变或装饰背景
-  Base Color: 暖白 #F7F6F2；只在少数对比页使用极浅暖灰 #EFEEE9
+  Base: warm white #F6F5F1
+  Alternate: pale stone #ECEBE6
+  Chart Grid: #D4D5D0
 Typography:
-  Headlines: 现代粗体无衬线，结论式标题，54–72px，严格控制在两行内
-  Body: 现代无衬线，24–30px；脚注可缩小但必须清晰
-  Numbers: 大号、直接、附口径，不放在多层卡片中
+  Headlines: modern geometric sans, 52–68px, max two lines
+  Body: 22–28px
+  Chart Labels: 17–21px
+  Numeric Highlights: 54–110px
 Color Palette:
-  Primary Text: #111111
-  Secondary Text: #62645F
-  Hairline: #D7D6D0
-  Brand Accent: Yoda Deep Green #173D2A
-  Secondary Accent: Yoda Green #5DC98F，仅用于一个关键节点或数字
-Visual Elements:
-  - 真实产品截图、真实用户现场和真实数据优先
-  - 只使用细线、少量色块、流程轨道和大数字
-  - 每页最多一个主视觉；圆角底板最多一块
-  - 不使用图标墙、胶囊标签堆叠、装饰性箭头、阴影卡片阵列或复杂坐标轴
-Density Guidelines:
-  - 每页一个结论，最多 2 个支撑层级
-  - 四周保留 80–100px 安全边距
-  - 页面至少 40% 留白
-Style Rules:
-  Do: 标题直接表达结论；每页为口头讲述提供一个视觉锚点；明确数据日期与证据边界
-  Don't: 不伪造产品 UI、客户、订单、留存或收入；不重复解释 Agent 团队；不让技术名词成为标题主体；不使用深色满版背景
+  Ink: #111312
+  Muted: #626762
+  Yoda Deep Green: #173D2A
+  Yoda Green: #5DC98F
+  Comparison Blue: #526A7A
+  Risk Gray: #A9AAA5
+Chart Language:
+  - 使用坐标轴、刻度、图例、注释线、象限、流程轨道、阶梯和环形图
+  - 每张图必须有明确结论和口径；概念曲线标注“趋势示意”
+  - 不使用伪精确数据，不使用无来源增长曲线
+  - 产品图使用真实截图；图片附边界说明
+Layout Rules:
+  - 16:9，四周 76–92px 安全边距
+  - 每页一个主图表，至少 35% 留白
+  - 不使用多层圆角卡片、装饰图标、渐变背景、玻璃拟态或无意义插画
+  - 统一左对齐；来源置底，字号不小于 15px
 &lt;/STYLE_INSTRUCTIONS&gt;
 ## SLIDE CONTENT
-## Slide 13 of 13
+## Slide 13 of 15
+**Type**: Content
+**Filename**: 13-slide-gtm.png
+Headline: 用两个高信号入口，验证 C 端口碑与 B 端年约
+Chart: 双楔子增长路径
+- C 端：开源社区 → 超级开发者 → Relay/Pro → Studio/生态
+- B 端：AI 创造营/高校 → 设计伙伴 → 标准产品包 → 机构年约
+Timeline:
+- 0–3 月：体验、埋点、20 位深访
+- 4–6 月：自然增长、2–3 家设计伙伴
+- 7–12 月：个人付费与机构试点
+- 13–24 月：机构年约、渠道与英文市场
+Layout: dual-funnel-timeline
+## Production Note
++Render with deterministic HTML/CSS/SVG composition so Chinese text, data values, citations and evidence boundaries remain exact. Rasterize the final 1600 × 900 canvas to PNG.
+</a:t>
+            </a:r>
+            <a:endParaRPr lang="en-US" dirty="0"/>
+          </a:p>
+        </p:txBody>
+      </p:sp>
+      <p:sp>
+        <p:nvSpPr>
+          <p:cNvPr id="4" name="Slide Number Placeholder 3"/>
+          <p:cNvSpPr>
+            <a:spLocks noGrp="1"/>
+          </p:cNvSpPr>
+          <p:nvPr>
+            <p:ph type="sldNum" sz="quarter" idx="10"/>
+          </p:nvPr>
+        </p:nvSpPr>
+        <p:spPr/>
+        <p:txBody>
+          <a:bodyPr/>
+          <a:lstStyle/>
+          <a:p>
+            <a:fld id="{F7021451-1387-4CA6-816F-3879F97B5CBC}" type="slidenum">
+              <a:rPr lang="en-US"/>
+              <a:t>13</a:t>
+            </a:fld>
+            <a:endParaRPr lang="en-US"/>
+          </a:p>
+        </p:txBody>
+      </p:sp>
+    </p:spTree>
+    <p:extLst>
+      <p:ext uri="{BB962C8B-B14F-4D97-AF65-F5344CB8AC3E}">
+        <p14:creationId xmlns:p14="http://schemas.microsoft.com/office/powerpoint/2010/main" val="1024086991"/>
+      </p:ext>
+    </p:extLst>
+  </p:cSld>
+  <p:clrMapOvr>
+    <a:masterClrMapping/>
+  </p:clrMapOvr>
+</p:notes>
+</file>
+
+<file path=ppt/notesSlides/notesSlide14.xml><?xml version="1.0" encoding="utf-8"?>
+<p:notes xmlns:a="http://schemas.openxmlformats.org/drawingml/2006/main" xmlns:r="http://schemas.openxmlformats.org/officeDocument/2006/relationships" xmlns:p="http://schemas.openxmlformats.org/presentationml/2006/main">
+  <p:cSld>
+    <p:spTree>
+      <p:nvGrpSpPr>
+        <p:cNvPr id="1" name=""/>
+        <p:cNvGrpSpPr/>
+        <p:nvPr/>
+      </p:nvGrpSpPr>
+      <p:grpSpPr>
+        <a:xfrm>
+          <a:off x="0" y="0"/>
+          <a:ext cx="0" cy="0"/>
+          <a:chOff x="0" y="0"/>
+          <a:chExt cx="0" cy="0"/>
+        </a:xfrm>
+      </p:grpSpPr>
+      <p:sp>
+        <p:nvSpPr>
+          <p:cNvPr id="2" name="Slide Image Placeholder 1"/>
+          <p:cNvSpPr>
+            <a:spLocks noGrp="1" noRot="1" noChangeAspect="1"/>
+          </p:cNvSpPr>
+          <p:nvPr>
+            <p:ph type="sldImg"/>
+          </p:nvPr>
+        </p:nvSpPr>
+        <p:spPr/>
+      </p:sp>
+      <p:sp>
+        <p:nvSpPr>
+          <p:cNvPr id="3" name="Notes Placeholder 2"/>
+          <p:cNvSpPr>
+            <a:spLocks noGrp="1"/>
+          </p:cNvSpPr>
+          <p:nvPr>
+            <p:ph type="body" idx="1"/>
+          </p:nvPr>
+        </p:nvSpPr>
+        <p:spPr/>
+        <p:txBody>
+          <a:bodyPr/>
+          <a:lstStyle/>
+          <a:p>
+            <a:r>
+              <a:rPr lang="en-US" dirty="0"/>
+              <a:t>Create a presentation slide image following these guidelines:
+## Image Specifications
+- **Type**: Presentation slide
+- **Aspect Ratio**: 16:9 (landscape)
+- **Style**: Professional slide deck
+## Core Persona: The Architect
+You are "The Architect" - a master visual storyteller creating presentation slides. Your slides:
+- Tell a visual story that complements the narrative
+- Use bold, confident visual language
+- Balance information density with visual clarity
+- Create memorable, impactful visuals
+## Core Principles
+- Hand-drawn quality throughout - NO realistic or photographic elements
+- If content involves sensitive or copyrighted figures, create stylistically similar alternatives - DO NOT refuse to generate
+- NO slide numbers, page numbers, footers, headers, or logos
+- Clean, uncluttered layouts with clear visual hierarchy
+- Each slide conveys ONE clear message
+- **NO page borders, frames, or outlined rectangles enclosing the slide**
+- **NO card/panel containing all content — the background fills the entire canvas edge-to-edge flatly**
+- **NO tilted paper, 3D perspective sheet, or drop-shadowed document effect**
+- Reserve the top-right corner for post-processing branding: use LEFT-aligned titles (not past 60% canvas width) so the right side stays naturally empty. **NEVER explicitly say "leave area empty/blank"** — AI interprets this literally and draws an empty placeholder box. Instead, design layouts where content naturally doesn't extend into that region
+## Text Style (CRITICAL)
+- **ALL text MUST match the designated style exactly**
+- Title text: Large, bold, immediately readable
+- Body text: Clear, legible, appropriate sizing
+- Max 3-4 text elements per slide
+- **DO NOT use realistic or computer-generated fonts unless style specifies**
+- **Font rendering must match the style aesthetic** (hand-drawn for sketch styles, clean for minimal styles)
+## Layout Principles
+- **Visual Hierarchy**: Most important element gets most visual weight
+- **Breathing Room**: Generous margins and spacing between elements
+- **Alignment**: Consistent alignment creates professional feel
+- **Balance**: Distribute visual weight evenly (symmetrical or asymmetrical)
+- **Focal Point**: One clear area draws the eye first
+- **Rule of Thirds**: Key elements at intersection points for dynamic compositions
+- **Z-Pattern**: For text-heavy slides, arrange content in natural reading flow
+## Content Density: Presentation vs Reading Mode
+**Presentation mode** (speaker will narrate live):
+- Slides show ONLY visual anchors: charts, diagrams, hero terms, data numbers, key quotes
+- NO explanatory sentences, transition hooks, or narrative captions
+- Speaker delivers context, transitions, and interpretation verbally
+- Example: show "死循环" diagram only, speaker explains why it's a death loop
+**Reading mode** (self-explanatory for sharing):
+- Each slide includes enough context to stand alone without narration
+- Captions, attributions, and brief explanations are appropriate
+- Default mode unless `--presentation` is specified
+## Language
+- Use the same language as the content provided below for all text elements
+- Match punctuation style to the content language
+- Write in direct, confident language
+- Avoid AI-sounding phrases like "dive into", "explore", "let's", "journey"
+---
+## STYLE_INSTRUCTIONS
+[Extract from outline.md - do NOT re-read style files]
+The STYLE_INSTRUCTIONS block from the outline contains:
+- Design Aesthetic
+- Background (Texture + Base Color)
+- Typography (Headlines + Body descriptions)
+- Color Palette (with hex codes)
+- Visual Elements
+- Density Guidelines
+- Style Rules (Do/Don't)
+Copy the entire `&lt;STYLE_INSTRUCTIONS&gt;...&lt;/STYLE_INSTRUCTIONS&gt;` block from the outline here.
+---
+## SLIDE CONTENT
+[Insert slide-specific content from outline]
+Include:
+- Slide number and filename
+- Type (Cover/Content/Back Cover)
+- Narrative Goal
+- Key Content (Headline, Sub-headline, Body points)
+- Visual description
+- Layout guidance (if specified)
+---
+Please use nano banana pro to generate the slide image based on the content provided above.
+---
+Create a presentation slide image following these guidelines:
+## Image Specifications
+- Type: Presentation slide
+- Aspect Ratio: 16:9 landscape
+- Canvas: 1600 × 900
+- Mode: Reading and sharing; every slide must stand alone
+- Language: Simplified Chinese
+## Core Principles
+- Convey ONE clear conclusion per slide.
+- Preserve every Chinese phrase and number verbatim.
+- Use exact, clean geometric Chinese typography; body text must visually equal at least 20pt.
+- Use real referenced product/event images faithfully when supplied; do not redraw or fabricate them.
+- Use deterministic flat diagrams, charts and typography for all factual content.
+- No slide numbers, decorative borders, glassmorphism, 3D effects, irrelevant stock photos, watermarks, or invented customer evidence.
+- The source skill's generic hand-drawn rule is intentionally overridden by this deck's confirmed custom investor style and the user's request for real evidence.
+## STYLE_INSTRUCTIONS
+&lt;STYLE_INSTRUCTIONS&gt;
+Design Aesthetic: 专业投资人材料。以咨询报告的数据表达、产品发布会的视觉层级和真实创业项目的证据感为基准。每页标题给出结论，图表承担论证，文字只负责解释口径。
+Background:
+  Base: warm white #F6F5F1
+  Alternate: pale stone #ECEBE6
+  Chart Grid: #D4D5D0
+Typography:
+  Headlines: modern geometric sans, 52–68px, max two lines
+  Body: 22–28px
+  Chart Labels: 17–21px
+  Numeric Highlights: 54–110px
+Color Palette:
+  Ink: #111312
+  Muted: #626762
+  Yoda Deep Green: #173D2A
+  Yoda Green: #5DC98F
+  Comparison Blue: #526A7A
+  Risk Gray: #A9AAA5
+Chart Language:
+  - 使用坐标轴、刻度、图例、注释线、象限、流程轨道、阶梯和环形图
+  - 每张图必须有明确结论和口径；概念曲线标注“趋势示意”
+  - 不使用伪精确数据，不使用无来源增长曲线
+  - 产品图使用真实截图；图片附边界说明
+Layout Rules:
+  - 16:9，四周 76–92px 安全边距
+  - 每页一个主图表，至少 35% 留白
+  - 不使用多层圆角卡片、装饰图标、渐变背景、玻璃拟态或无意义插画
+  - 统一左对齐；来源置底，字号不小于 15px
+&lt;/STYLE_INSTRUCTIONS&gt;
+## SLIDE CONTENT
+## Slide 14 of 15
+**Type**: Content
+**Filename**: 14-slide-founder.png
+Headline: Founder–Product Fit：Yoda 是被真实工作流“撞”出来的
+Sub-headline: 创始人同时是第一重度用户、产品经理、开发者与首批渠道
+Evidence:
+- 长期横跨开发工具、内容创作、培训与 AI 产品化
+- 用 Yoda 开发 Yoda，形成高频反馈闭环
+- 高校、商学院、开发者社区与训练营触点
+Visual: 真实分享现场照片 + 1,645 commits / 73 releases / 31 clients。
+Layout: founder-evidence
+## Production Note
++Render with deterministic HTML/CSS/SVG composition so Chinese text, data values, citations and evidence boundaries remain exact. Rasterize the final 1600 × 900 canvas to PNG.
+</a:t>
+            </a:r>
+            <a:endParaRPr lang="en-US" dirty="0"/>
+          </a:p>
+        </p:txBody>
+      </p:sp>
+      <p:sp>
+        <p:nvSpPr>
+          <p:cNvPr id="4" name="Slide Number Placeholder 3"/>
+          <p:cNvSpPr>
+            <a:spLocks noGrp="1"/>
+          </p:cNvSpPr>
+          <p:nvPr>
+            <p:ph type="sldNum" sz="quarter" idx="10"/>
+          </p:nvPr>
+        </p:nvSpPr>
+        <p:spPr/>
+        <p:txBody>
+          <a:bodyPr/>
+          <a:lstStyle/>
+          <a:p>
+            <a:fld id="{F7021451-1387-4CA6-816F-3879F97B5CBC}" type="slidenum">
+              <a:rPr lang="en-US"/>
+              <a:t>14</a:t>
+            </a:fld>
+            <a:endParaRPr lang="en-US"/>
+          </a:p>
+        </p:txBody>
+      </p:sp>
+    </p:spTree>
+    <p:extLst>
+      <p:ext uri="{BB962C8B-B14F-4D97-AF65-F5344CB8AC3E}">
+        <p14:creationId xmlns:p14="http://schemas.microsoft.com/office/powerpoint/2010/main" val="1024086991"/>
+      </p:ext>
+    </p:extLst>
+  </p:cSld>
+  <p:clrMapOvr>
+    <a:masterClrMapping/>
+  </p:clrMapOvr>
+</p:notes>
+</file>
+
+<file path=ppt/notesSlides/notesSlide15.xml><?xml version="1.0" encoding="utf-8"?>
+<p:notes xmlns:a="http://schemas.openxmlformats.org/drawingml/2006/main" xmlns:r="http://schemas.openxmlformats.org/officeDocument/2006/relationships" xmlns:p="http://schemas.openxmlformats.org/presentationml/2006/main">
+  <p:cSld>
+    <p:spTree>
+      <p:nvGrpSpPr>
+        <p:cNvPr id="1" name=""/>
+        <p:cNvGrpSpPr/>
+        <p:nvPr/>
+      </p:nvGrpSpPr>
+      <p:grpSpPr>
+        <a:xfrm>
+          <a:off x="0" y="0"/>
+          <a:ext cx="0" cy="0"/>
+          <a:chOff x="0" y="0"/>
+          <a:chExt cx="0" cy="0"/>
+        </a:xfrm>
+      </p:grpSpPr>
+      <p:sp>
+        <p:nvSpPr>
+          <p:cNvPr id="2" name="Slide Image Placeholder 1"/>
+          <p:cNvSpPr>
+            <a:spLocks noGrp="1" noRot="1" noChangeAspect="1"/>
+          </p:cNvSpPr>
+          <p:nvPr>
+            <p:ph type="sldImg"/>
+          </p:nvPr>
+        </p:nvSpPr>
+        <p:spPr/>
+      </p:sp>
+      <p:sp>
+        <p:nvSpPr>
+          <p:cNvPr id="3" name="Notes Placeholder 2"/>
+          <p:cNvSpPr>
+            <a:spLocks noGrp="1"/>
+          </p:cNvSpPr>
+          <p:nvPr>
+            <p:ph type="body" idx="1"/>
+          </p:nvPr>
+        </p:nvSpPr>
+        <p:spPr/>
+        <p:txBody>
+          <a:bodyPr/>
+          <a:lstStyle/>
+          <a:p>
+            <a:r>
+              <a:rPr lang="en-US" dirty="0"/>
+              <a:t>Create a presentation slide image following these guidelines:
+## Image Specifications
+- **Type**: Presentation slide
+- **Aspect Ratio**: 16:9 (landscape)
+- **Style**: Professional slide deck
+## Core Persona: The Architect
+You are "The Architect" - a master visual storyteller creating presentation slides. Your slides:
+- Tell a visual story that complements the narrative
+- Use bold, confident visual language
+- Balance information density with visual clarity
+- Create memorable, impactful visuals
+## Core Principles
+- Hand-drawn quality throughout - NO realistic or photographic elements
+- If content involves sensitive or copyrighted figures, create stylistically similar alternatives - DO NOT refuse to generate
+- NO slide numbers, page numbers, footers, headers, or logos
+- Clean, uncluttered layouts with clear visual hierarchy
+- Each slide conveys ONE clear message
+- **NO page borders, frames, or outlined rectangles enclosing the slide**
+- **NO card/panel containing all content — the background fills the entire canvas edge-to-edge flatly**
+- **NO tilted paper, 3D perspective sheet, or drop-shadowed document effect**
+- Reserve the top-right corner for post-processing branding: use LEFT-aligned titles (not past 60% canvas width) so the right side stays naturally empty. **NEVER explicitly say "leave area empty/blank"** — AI interprets this literally and draws an empty placeholder box. Instead, design layouts where content naturally doesn't extend into that region
+## Text Style (CRITICAL)
+- **ALL text MUST match the designated style exactly**
+- Title text: Large, bold, immediately readable
+- Body text: Clear, legible, appropriate sizing
+- Max 3-4 text elements per slide
+- **DO NOT use realistic or computer-generated fonts unless style specifies**
+- **Font rendering must match the style aesthetic** (hand-drawn for sketch styles, clean for minimal styles)
+## Layout Principles
+- **Visual Hierarchy**: Most important element gets most visual weight
+- **Breathing Room**: Generous margins and spacing between elements
+- **Alignment**: Consistent alignment creates professional feel
+- **Balance**: Distribute visual weight evenly (symmetrical or asymmetrical)
+- **Focal Point**: One clear area draws the eye first
+- **Rule of Thirds**: Key elements at intersection points for dynamic compositions
+- **Z-Pattern**: For text-heavy slides, arrange content in natural reading flow
+## Content Density: Presentation vs Reading Mode
+**Presentation mode** (speaker will narrate live):
+- Slides show ONLY visual anchors: charts, diagrams, hero terms, data numbers, key quotes
+- NO explanatory sentences, transition hooks, or narrative captions
+- Speaker delivers context, transitions, and interpretation verbally
+- Example: show "死循环" diagram only, speaker explains why it's a death loop
+**Reading mode** (self-explanatory for sharing):
+- Each slide includes enough context to stand alone without narration
+- Captions, attributions, and brief explanations are appropriate
+- Default mode unless `--presentation` is specified
+## Language
+- Use the same language as the content provided below for all text elements
+- Match punctuation style to the content language
+- Write in direct, confident language
+- Avoid AI-sounding phrases like "dive into", "explore", "let's", "journey"
+---
+## STYLE_INSTRUCTIONS
+[Extract from outline.md - do NOT re-read style files]
+The STYLE_INSTRUCTIONS block from the outline contains:
+- Design Aesthetic
+- Background (Texture + Base Color)
+- Typography (Headlines + Body descriptions)
+- Color Palette (with hex codes)
+- Visual Elements
+- Density Guidelines
+- Style Rules (Do/Don't)
+Copy the entire `&lt;STYLE_INSTRUCTIONS&gt;...&lt;/STYLE_INSTRUCTIONS&gt;` block from the outline here.
+---
+## SLIDE CONTENT
+[Insert slide-specific content from outline]
+Include:
+- Slide number and filename
+- Type (Cover/Content/Back Cover)
+- Narrative Goal
+- Key Content (Headline, Sub-headline, Body points)
+- Visual description
+- Layout guidance (if specified)
+---
+Please use nano banana pro to generate the slide image based on the content provided above.
+---
+Create a presentation slide image following these guidelines:
+## Image Specifications
+- Type: Presentation slide
+- Aspect Ratio: 16:9 landscape
+- Canvas: 1600 × 900
+- Mode: Reading and sharing; every slide must stand alone
+- Language: Simplified Chinese
+## Core Principles
+- Convey ONE clear conclusion per slide.
+- Preserve every Chinese phrase and number verbatim.
+- Use exact, clean geometric Chinese typography; body text must visually equal at least 20pt.
+- Use real referenced product/event images faithfully when supplied; do not redraw or fabricate them.
+- Use deterministic flat diagrams, charts and typography for all factual content.
+- No slide numbers, decorative borders, glassmorphism, 3D effects, irrelevant stock photos, watermarks, or invented customer evidence.
+- The source skill's generic hand-drawn rule is intentionally overridden by this deck's confirmed custom investor style and the user's request for real evidence.
+## STYLE_INSTRUCTIONS
+&lt;STYLE_INSTRUCTIONS&gt;
+Design Aesthetic: 专业投资人材料。以咨询报告的数据表达、产品发布会的视觉层级和真实创业项目的证据感为基准。每页标题给出结论，图表承担论证，文字只负责解释口径。
+Background:
+  Base: warm white #F6F5F1
+  Alternate: pale stone #ECEBE6
+  Chart Grid: #D4D5D0
+Typography:
+  Headlines: modern geometric sans, 52–68px, max two lines
+  Body: 22–28px
+  Chart Labels: 17–21px
+  Numeric Highlights: 54–110px
+Color Palette:
+  Ink: #111312
+  Muted: #626762
+  Yoda Deep Green: #173D2A
+  Yoda Green: #5DC98F
+  Comparison Blue: #526A7A
+  Risk Gray: #A9AAA5
+Chart Language:
+  - 使用坐标轴、刻度、图例、注释线、象限、流程轨道、阶梯和环形图
+  - 每张图必须有明确结论和口径；概念曲线标注“趋势示意”
+  - 不使用伪精确数据，不使用无来源增长曲线
+  - 产品图使用真实截图；图片附边界说明
+Layout Rules:
+  - 16:9，四周 76–92px 安全边距
+  - 每页一个主图表，至少 35% 留白
+  - 不使用多层圆角卡片、装饰图标、渐变背景、玻璃拟态或无意义插画
+  - 统一左对齐；来源置底，字号不小于 15px
+&lt;/STYLE_INSTRUCTIONS&gt;
+## SLIDE CONTENT
+## Slide 15 of 15
 **Type**: Closing
-**Filename**: 13-slide-fundraise.png
-// NARRATIVE GOAL
-清楚给出融资条件、用途和本轮资金要买到的结果。
-// KEY CONTENT
-Headline: 融资 200 万元，购买 18–24 个月的验证窗口
-Sub-headline: 或 30 万美元，出让 10% 股权
-Body:
+**Filename**: 15-slide-fundraise.png
+Headline: 融资 200 万元，验证“集成委托环境”能否形成可重复增长
+Sub-headline: 或 30 万美元，出让 10% 股权；购买 18–24 个月验证窗口
+Chart: 资金用途环形图
 - 60% 技术研发与产品体验
 - 30% 市场推广
 - 10% 基础设施与运营
-- 下一阶段目标：验证留存、个人付费与机构年约能否形成可重复增长
-// VISUAL
-左侧大号融资金额；右侧三条极简资金比例线和最终验证目标。该页直接作为结束页，不追加致谢页。
-// LAYOUT
+Milestones: 留存成立 / 个人付费成立 / 机构年约成立 / 增长效率可测量
 Layout: closing-ask
 ## Production Note
 +Render with deterministic HTML/CSS/SVG composition so Chinese text, data values, citations and evidence boundaries remain exact. Rasterize the final 1600 × 900 canvas to PNG.
@@ -1583,7 +2010,7 @@
           <a:p>
             <a:fld id="{F7021451-1387-4CA6-816F-3879F97B5CBC}" type="slidenum">
               <a:rPr lang="en-US"/>
-              <a:t>13</a:t>
+              <a:t>15</a:t>
             </a:fld>
             <a:endParaRPr lang="en-US"/>
           </a:p>
@@ -1741,50 +2168,47 @@
 - The source skill's generic hand-drawn rule is intentionally overridden by this deck's confirmed custom investor style and the user's request for real evidence.
 ## STYLE_INSTRUCTIONS
 &lt;STYLE_INSTRUCTIONS&gt;
-Design Aesthetic: 简单、具体、可信，带一点野心。像优秀种子轮融资材料，而不是产品功能说明书。使用苹果发布会式的清晰度、咨询报告式的证据意识和创业团队的真实感。
+Design Aesthetic: 专业投资人材料。以咨询报告的数据表达、产品发布会的视觉层级和真实创业项目的证据感为基准。每页标题给出结论，图表承担论证，文字只负责解释口径。
 Background:
-  Texture: clean，纯色，无纹理、网格、渐变或装饰背景
-  Base Color: 暖白 #F7F6F2；只在少数对比页使用极浅暖灰 #EFEEE9
+  Base: warm white #F6F5F1
+  Alternate: pale stone #ECEBE6
+  Chart Grid: #D4D5D0
 Typography:
-  Headlines: 现代粗体无衬线，结论式标题，54–72px，严格控制在两行内
-  Body: 现代无衬线，24–30px；脚注可缩小但必须清晰
-  Numbers: 大号、直接、附口径，不放在多层卡片中
+  Headlines: modern geometric sans, 52–68px, max two lines
+  Body: 22–28px
+  Chart Labels: 17–21px
+  Numeric Highlights: 54–110px
 Color Palette:
-  Primary Text: #111111
-  Secondary Text: #62645F
-  Hairline: #D7D6D0
-  Brand Accent: Yoda Deep Green #173D2A
-  Secondary Accent: Yoda Green #5DC98F，仅用于一个关键节点或数字
-Visual Elements:
-  - 真实产品截图、真实用户现场和真实数据优先
-  - 只使用细线、少量色块、流程轨道和大数字
-  - 每页最多一个主视觉；圆角底板最多一块
-  - 不使用图标墙、胶囊标签堆叠、装饰性箭头、阴影卡片阵列或复杂坐标轴
-Density Guidelines:
-  - 每页一个结论，最多 2 个支撑层级
-  - 四周保留 80–100px 安全边距
-  - 页面至少 40% 留白
-Style Rules:
-  Do: 标题直接表达结论；每页为口头讲述提供一个视觉锚点；明确数据日期与证据边界
-  Don't: 不伪造产品 UI、客户、订单、留存或收入；不重复解释 Agent 团队；不让技术名词成为标题主体；不使用深色满版背景
+  Ink: #111312
+  Muted: #626762
+  Yoda Deep Green: #173D2A
+  Yoda Green: #5DC98F
+  Comparison Blue: #526A7A
+  Risk Gray: #A9AAA5
+Chart Language:
+  - 使用坐标轴、刻度、图例、注释线、象限、流程轨道、阶梯和环形图
+  - 每张图必须有明确结论和口径；概念曲线标注“趋势示意”
+  - 不使用伪精确数据，不使用无来源增长曲线
+  - 产品图使用真实截图；图片附边界说明
+Layout Rules:
+  - 16:9，四周 76–92px 安全边距
+  - 每页一个主图表，至少 35% 留白
+  - 不使用多层圆角卡片、装饰图标、渐变背景、玻璃拟态或无意义插画
+  - 统一左对齐；来源置底，字号不小于 15px
 &lt;/STYLE_INSTRUCTIONS&gt;
 ## SLIDE CONTENT
-## Slide 2 of 13
+## Slide 2 of 15
 **Type**: Content
-**Filename**: 02-slide-problem.png
-// NARRATIVE GOAL
-用具体工作场景说明问题，不从技术概念讲起。
-// KEY CONTENT
-Headline: AI 能写代码，但创造过程仍被工具切碎
-Sub-headline: 同一项任务，需要在 Agent、终端、文件、Git 和发布页面之间反复切换
-Body:
-- 上下文反复重述
-- 过程难以观察和干预
-- 成功方法难以复用
-// VISUAL
-一条被五个工具节点打断的工作流；底部一句结论：“不是 AI 不够强，是工作流没有跟上。”
-// LAYOUT
-Layout: linear-progression
+**Filename**: 02-slide-ide-shift.png
+Headline: IDE 的中心，正从“代码”迁移到“委托”
+Sub-headline: 每一代 IDE 都围绕当时最稀缺的生产要素重构
+Chart: 四阶段演进时间轴
+- 语言中心：Dev-C++ / Visual Studio，解决编译与运行
+- 工程中心：JetBrains，解决理解与维护
+- 代码工作台：VS Code / Cursor，解决扩展与生成
+- 委托环境：Yoda，解决意图、并行、证据与责任
+Conclusion: 下一代 IDE 不是编辑器旁边多一个聊天框，而是 Integrated Delegation Environment。
+Layout: timeline-horizontal
 ## Production Note
 +Render with deterministic HTML/CSS/SVG composition so Chinese text, data values, citations and evidence boundaries remain exact. Rasterize the final 1600 × 900 canvas to PNG.
 </a:t>
@@ -1968,47 +2392,47 @@
 - The source skill's generic hand-drawn rule is intentionally overridden by this deck's confirmed custom investor style and the user's request for real evidence.
 ## STYLE_INSTRUCTIONS
 &lt;STYLE_INSTRUCTIONS&gt;
-Design Aesthetic: 简单、具体、可信，带一点野心。像优秀种子轮融资材料，而不是产品功能说明书。使用苹果发布会式的清晰度、咨询报告式的证据意识和创业团队的真实感。
+Design Aesthetic: 专业投资人材料。以咨询报告的数据表达、产品发布会的视觉层级和真实创业项目的证据感为基准。每页标题给出结论，图表承担论证，文字只负责解释口径。
 Background:
-  Texture: clean，纯色，无纹理、网格、渐变或装饰背景
-  Base Color: 暖白 #F7F6F2；只在少数对比页使用极浅暖灰 #EFEEE9
+  Base: warm white #F6F5F1
+  Alternate: pale stone #ECEBE6
+  Chart Grid: #D4D5D0
 Typography:
-  Headlines: 现代粗体无衬线，结论式标题，54–72px，严格控制在两行内
-  Body: 现代无衬线，24–30px；脚注可缩小但必须清晰
-  Numbers: 大号、直接、附口径，不放在多层卡片中
+  Headlines: modern geometric sans, 52–68px, max two lines
+  Body: 22–28px
+  Chart Labels: 17–21px
+  Numeric Highlights: 54–110px
 Color Palette:
-  Primary Text: #111111
-  Secondary Text: #62645F
-  Hairline: #D7D6D0
-  Brand Accent: Yoda Deep Green #173D2A
-  Secondary Accent: Yoda Green #5DC98F，仅用于一个关键节点或数字
-Visual Elements:
-  - 真实产品截图、真实用户现场和真实数据优先
-  - 只使用细线、少量色块、流程轨道和大数字
-  - 每页最多一个主视觉；圆角底板最多一块
-  - 不使用图标墙、胶囊标签堆叠、装饰性箭头、阴影卡片阵列或复杂坐标轴
-Density Guidelines:
-  - 每页一个结论，最多 2 个支撑层级
-  - 四周保留 80–100px 安全边距
-  - 页面至少 40% 留白
-Style Rules:
-  Do: 标题直接表达结论；每页为口头讲述提供一个视觉锚点；明确数据日期与证据边界
-  Don't: 不伪造产品 UI、客户、订单、留存或收入；不重复解释 Agent 团队；不让技术名词成为标题主体；不使用深色满版背景
+  Ink: #111312
+  Muted: #626762
+  Yoda Deep Green: #173D2A
+  Yoda Green: #5DC98F
+  Comparison Blue: #526A7A
+  Risk Gray: #A9AAA5
+Chart Language:
+  - 使用坐标轴、刻度、图例、注释线、象限、流程轨道、阶梯和环形图
+  - 每张图必须有明确结论和口径；概念曲线标注“趋势示意”
+  - 不使用伪精确数据，不使用无来源增长曲线
+  - 产品图使用真实截图；图片附边界说明
+Layout Rules:
+  - 16:9，四周 76–92px 安全边距
+  - 每页一个主图表，至少 35% 留白
+  - 不使用多层圆角卡片、装饰图标、渐变背景、玻璃拟态或无意义插画
+  - 统一左对齐；来源置底，字号不小于 15px
 &lt;/STYLE_INSTRUCTIONS&gt;
 ## SLIDE CONTENT
-## Slide 3 of 13
+## Slide 3 of 15
 **Type**: Content
-**Filename**: 03-slide-solution.png
-// NARRATIVE GOAL
-说明 Yoda 如何把碎片化步骤变成连续体验。
-// KEY CONTENT
-Headline: Yoda 把整个 AI 创造过程放进一个工作台
-Sub-headline: 从目标、执行到 Review 与发布，用户始终掌握上下文和方向
-Body: 目标 → 会话 → 干预 → Review → 交付
-// VISUAL
-一条连续绿色轨道贯穿五个阶段；Yoda 作为工作台位于轨道下方，不做多张功能卡片。
-// LAYOUT
-Layout: process-flow
+**Filename**: 03-slide-delegation-gap.png
+Headline: 实现成本快速下降，委托复杂度反而上升
+Sub-headline: Agent 越能独立工作，人越需要新的控制面
+Chart: 双曲线趋势图（明确标注“趋势示意”）
+- 实现成本：持续下降
+- Agent 自主能力：持续上升
+- 人类注意力：基本不变
+Pain points: 多会话状态、上下文与 Harness、分支与隔离、Review 与证据、Token 成本。
+Conclusion: Agent 能跑只是执行问题；敢不敢委托，才是工程问题。
+Layout: chart-with-annotation
 ## Production Note
 +Render with deterministic HTML/CSS/SVG composition so Chinese text, data values, citations and evidence boundaries remain exact. Rasterize the final 1600 × 900 canvas to PNG.
 </a:t>
@@ -2192,47 +2616,45 @@
 - The source skill's generic hand-drawn rule is intentionally overridden by this deck's confirmed custom investor style and the user's request for real evidence.
 ## STYLE_INSTRUCTIONS
 &lt;STYLE_INSTRUCTIONS&gt;
-Design Aesthetic: 简单、具体、可信，带一点野心。像优秀种子轮融资材料，而不是产品功能说明书。使用苹果发布会式的清晰度、咨询报告式的证据意识和创业团队的真实感。
+Design Aesthetic: 专业投资人材料。以咨询报告的数据表达、产品发布会的视觉层级和真实创业项目的证据感为基准。每页标题给出结论，图表承担论证，文字只负责解释口径。
 Background:
-  Texture: clean，纯色，无纹理、网格、渐变或装饰背景
-  Base Color: 暖白 #F7F6F2；只在少数对比页使用极浅暖灰 #EFEEE9
+  Base: warm white #F6F5F1
+  Alternate: pale stone #ECEBE6
+  Chart Grid: #D4D5D0
 Typography:
-  Headlines: 现代粗体无衬线，结论式标题，54–72px，严格控制在两行内
-  Body: 现代无衬线，24–30px；脚注可缩小但必须清晰
-  Numbers: 大号、直接、附口径，不放在多层卡片中
+  Headlines: modern geometric sans, 52–68px, max two lines
+  Body: 22–28px
+  Chart Labels: 17–21px
+  Numeric Highlights: 54–110px
 Color Palette:
-  Primary Text: #111111
-  Secondary Text: #62645F
-  Hairline: #D7D6D0
-  Brand Accent: Yoda Deep Green #173D2A
-  Secondary Accent: Yoda Green #5DC98F，仅用于一个关键节点或数字
-Visual Elements:
-  - 真实产品截图、真实用户现场和真实数据优先
-  - 只使用细线、少量色块、流程轨道和大数字
-  - 每页最多一个主视觉；圆角底板最多一块
-  - 不使用图标墙、胶囊标签堆叠、装饰性箭头、阴影卡片阵列或复杂坐标轴
-Density Guidelines:
-  - 每页一个结论，最多 2 个支撑层级
-  - 四周保留 80–100px 安全边距
-  - 页面至少 40% 留白
-Style Rules:
-  Do: 标题直接表达结论；每页为口头讲述提供一个视觉锚点；明确数据日期与证据边界
-  Don't: 不伪造产品 UI、客户、订单、留存或收入；不重复解释 Agent 团队；不让技术名词成为标题主体；不使用深色满版背景
+  Ink: #111312
+  Muted: #626762
+  Yoda Deep Green: #173D2A
+  Yoda Green: #5DC98F
+  Comparison Blue: #526A7A
+  Risk Gray: #A9AAA5
+Chart Language:
+  - 使用坐标轴、刻度、图例、注释线、象限、流程轨道、阶梯和环形图
+  - 每张图必须有明确结论和口径；概念曲线标注“趋势示意”
+  - 不使用伪精确数据，不使用无来源增长曲线
+  - 产品图使用真实截图；图片附边界说明
+Layout Rules:
+  - 16:9，四周 76–92px 安全边距
+  - 每页一个主图表，至少 35% 留白
+  - 不使用多层圆角卡片、装饰图标、渐变背景、玻璃拟态或无意义插画
+  - 统一左对齐；来源置底，字号不小于 15px
 &lt;/STYLE_INSTRUCTIONS&gt;
 ## SLIDE CONTENT
-## Slide 4 of 13
+## Slide 4 of 15
 **Type**: Content
-**Filename**: 04-slide-product-experience.png
-// NARRATIVE GOAL
-用真实画面和一个核心循环展示产品体验。
-// KEY CONTENT
-Headline: 一个入口，完成一次可控的 AI 交付
-Sub-headline: 启动任务、观察过程、修正方向、验收结果
-Body: 单 Agent 与多 Agent 都适用；工作方式由任务决定
-// VISUAL
-右侧使用真实 Yoda 启动画面；左侧用四个大号动词构成产品循环，并明确标注当前画面不是虚构主界面。
-// LAYOUT
-Layout: split-screen
+**Filename**: 04-slide-delegation-loop.png
+Headline: Yoda 把一次 Agent 执行，变成可审查的交付闭环
+Sub-headline: 停止不等于完成；生成不等于交付
+Chart: 委托闭环
+Human: 定义意图 → 设置约束 → 审查证据 → 批准交付
+Agent: 规划 → 执行 → 测试 → 修正
+Evidence rail: Diff / Test / Review / PR / Release
+Layout: circular-process
 ## Production Note
 +Render with deterministic HTML/CSS/SVG composition so Chinese text, data values, citations and evidence boundaries remain exact. Rasterize the final 1600 × 900 canvas to PNG.
 </a:t>
@@ -2416,47 +2838,43 @@
 - The source skill's generic hand-drawn rule is intentionally overridden by this deck's confirmed custom investor style and the user's request for real evidence.
 ## STYLE_INSTRUCTIONS
 &lt;STYLE_INSTRUCTIONS&gt;
-Design Aesthetic: 简单、具体、可信，带一点野心。像优秀种子轮融资材料，而不是产品功能说明书。使用苹果发布会式的清晰度、咨询报告式的证据意识和创业团队的真实感。
+Design Aesthetic: 专业投资人材料。以咨询报告的数据表达、产品发布会的视觉层级和真实创业项目的证据感为基准。每页标题给出结论，图表承担论证，文字只负责解释口径。
 Background:
-  Texture: clean，纯色，无纹理、网格、渐变或装饰背景
-  Base Color: 暖白 #F7F6F2；只在少数对比页使用极浅暖灰 #EFEEE9
+  Base: warm white #F6F5F1
+  Alternate: pale stone #ECEBE6
+  Chart Grid: #D4D5D0
 Typography:
-  Headlines: 现代粗体无衬线，结论式标题，54–72px，严格控制在两行内
-  Body: 现代无衬线，24–30px；脚注可缩小但必须清晰
-  Numbers: 大号、直接、附口径，不放在多层卡片中
+  Headlines: modern geometric sans, 52–68px, max two lines
+  Body: 22–28px
+  Chart Labels: 17–21px
+  Numeric Highlights: 54–110px
 Color Palette:
-  Primary Text: #111111
-  Secondary Text: #62645F
-  Hairline: #D7D6D0
-  Brand Accent: Yoda Deep Green #173D2A
-  Secondary Accent: Yoda Green #5DC98F，仅用于一个关键节点或数字
-Visual Elements:
-  - 真实产品截图、真实用户现场和真实数据优先
-  - 只使用细线、少量色块、流程轨道和大数字
-  - 每页最多一个主视觉；圆角底板最多一块
-  - 不使用图标墙、胶囊标签堆叠、装饰性箭头、阴影卡片阵列或复杂坐标轴
-Density Guidelines:
-  - 每页一个结论，最多 2 个支撑层级
-  - 四周保留 80–100px 安全边距
-  - 页面至少 40% 留白
-Style Rules:
-  Do: 标题直接表达结论；每页为口头讲述提供一个视觉锚点；明确数据日期与证据边界
-  Don't: 不伪造产品 UI、客户、订单、留存或收入；不重复解释 Agent 团队；不让技术名词成为标题主体；不使用深色满版背景
+  Ink: #111312
+  Muted: #626762
+  Yoda Deep Green: #173D2A
+  Yoda Green: #5DC98F
+  Comparison Blue: #526A7A
+  Risk Gray: #A9AAA5
+Chart Language:
+  - 使用坐标轴、刻度、图例、注释线、象限、流程轨道、阶梯和环形图
+  - 每张图必须有明确结论和口径；概念曲线标注“趋势示意”
+  - 不使用伪精确数据，不使用无来源增长曲线
+  - 产品图使用真实截图；图片附边界说明
+Layout Rules:
+  - 16:9，四周 76–92px 安全边距
+  - 每页一个主图表，至少 35% 留白
+  - 不使用多层圆角卡片、装饰图标、渐变背景、玻璃拟态或无意义插画
+  - 统一左对齐；来源置底，字号不小于 15px
 &lt;/STYLE_INSTRUCTIONS&gt;
 ## SLIDE CONTENT
-## Slide 5 of 13
+## Slide 5 of 15
 **Type**: Content
-**Filename**: 05-slide-harness.png
-// NARRATIVE GOAL
-把 Harness 解释为产品资产层与技术壁垒，而不是流行术语。
-// KEY CONTENT
-Headline: Harness 让 AI 的工作过程可控、可复用、可迁移
-Sub-headline: 31 种 Agent Client 之上，Yoda 统一会话、能力、上下文与交付
-Body: Session · Skills · Hooks · Memory · Review · CI/CD
-// VISUAL
-三层结构：31 Agent Clients → Yoda Harness 连续轨道 → Diff/Test/Release。中间只用一条深绿色横带。
-// LAYOUT
-Layout: hierarchical-layers
+**Filename**: 05-slide-task-to-feature.png
+Headline: 从 Task 到 Feature：管理的不再是聊天，而是完整交付主线
+Sub-headline: Task 保证一次执行稳健，Feature 保证一个需求真正完成
+Visual: 真实 Yoda Task 与 Feature 工作台截图；右侧绘制阶段门：问题定义 → 产品方案 → 实现 → 验证 → 发布。
+Evidence: 没有交付物、Review 或测试证据，就不能假装进入下一阶段。
+Layout: product-evidence
 ## Production Note
 +Render with deterministic HTML/CSS/SVG composition so Chinese text, data values, citations and evidence boundaries remain exact. Rasterize the final 1600 × 900 canvas to PNG.
 </a:t>
@@ -2640,49 +3058,46 @@
 - The source skill's generic hand-drawn rule is intentionally overridden by this deck's confirmed custom investor style and the user's request for real evidence.
 ## STYLE_INSTRUCTIONS
 &lt;STYLE_INSTRUCTIONS&gt;
-Design Aesthetic: 简单、具体、可信，带一点野心。像优秀种子轮融资材料，而不是产品功能说明书。使用苹果发布会式的清晰度、咨询报告式的证据意识和创业团队的真实感。
+Design Aesthetic: 专业投资人材料。以咨询报告的数据表达、产品发布会的视觉层级和真实创业项目的证据感为基准。每页标题给出结论，图表承担论证，文字只负责解释口径。
 Background:
-  Texture: clean，纯色，无纹理、网格、渐变或装饰背景
-  Base Color: 暖白 #F7F6F2；只在少数对比页使用极浅暖灰 #EFEEE9
+  Base: warm white #F6F5F1
+  Alternate: pale stone #ECEBE6
+  Chart Grid: #D4D5D0
 Typography:
-  Headlines: 现代粗体无衬线，结论式标题，54–72px，严格控制在两行内
-  Body: 现代无衬线，24–30px；脚注可缩小但必须清晰
-  Numbers: 大号、直接、附口径，不放在多层卡片中
+  Headlines: modern geometric sans, 52–68px, max two lines
+  Body: 22–28px
+  Chart Labels: 17–21px
+  Numeric Highlights: 54–110px
 Color Palette:
-  Primary Text: #111111
-  Secondary Text: #62645F
-  Hairline: #D7D6D0
-  Brand Accent: Yoda Deep Green #173D2A
-  Secondary Accent: Yoda Green #5DC98F，仅用于一个关键节点或数字
-Visual Elements:
-  - 真实产品截图、真实用户现场和真实数据优先
-  - 只使用细线、少量色块、流程轨道和大数字
-  - 每页最多一个主视觉；圆角底板最多一块
-  - 不使用图标墙、胶囊标签堆叠、装饰性箭头、阴影卡片阵列或复杂坐标轴
-Density Guidelines:
-  - 每页一个结论，最多 2 个支撑层级
-  - 四周保留 80–100px 安全边距
-  - 页面至少 40% 留白
-Style Rules:
-  Do: 标题直接表达结论；每页为口头讲述提供一个视觉锚点；明确数据日期与证据边界
-  Don't: 不伪造产品 UI、客户、订单、留存或收入；不重复解释 Agent 团队；不让技术名词成为标题主体；不使用深色满版背景
+  Ink: #111312
+  Muted: #626762
+  Yoda Deep Green: #173D2A
+  Yoda Green: #5DC98F
+  Comparison Blue: #526A7A
+  Risk Gray: #A9AAA5
+Chart Language:
+  - 使用坐标轴、刻度、图例、注释线、象限、流程轨道、阶梯和环形图
+  - 每张图必须有明确结论和口径；概念曲线标注“趋势示意”
+  - 不使用伪精确数据，不使用无来源增长曲线
+  - 产品图使用真实截图；图片附边界说明
+Layout Rules:
+  - 16:9，四周 76–92px 安全边距
+  - 每页一个主图表，至少 35% 留白
+  - 不使用多层圆角卡片、装饰图标、渐变背景、玻璃拟态或无意义插画
+  - 统一左对齐；来源置底，字号不小于 15px
 &lt;/STYLE_INSTRUCTIONS&gt;
 ## SLIDE CONTENT
-## Slide 6 of 13
+## Slide 6 of 15
 **Type**: Content
-**Filename**: 06-slide-why-now.png
-// NARRATIVE GOAL
-说明为什么 Harness 的窗口正在现在形成。
-// KEY CONTENT
-Headline: AI 执行能力正在商品化，驾驭能力成为新的价值层
-Sub-headline: 创作者已把 AI 放进工作流，但最终判断仍由人完成
-Body:
-- 75%：创意 AI 已融入或成为工作流必要部分
-- 85%：最终创意决策仍应由人完成
-// VISUAL
-两个大数字分置两侧，中间一条细线；底部只保留“AI 执行，人负责方向与品味”。
-// LAYOUT
-Layout: data-highlight
+**Filename**: 06-slide-product-architecture.png
+Headline: 五层产品架构，把开放的 Agent 生态变成可控生产系统
+Chart: 五层架构
+1. Runtime：31 种 Agent CLI / MaaS / 模型
+2. Session Control：会话、状态、上下文、恢复、成本
+3. Harness Assets：Skills、Hooks、Memory、Prompts、原子原则
+4. Delivery System：Task、Feature、Worktree、Diff、Stage Gate
+5. Human Control：桌面、移动端、浏览器、通知、最终批准
+Layout: architecture-stack
 ## Production Note
 +Render with deterministic HTML/CSS/SVG composition so Chinese text, data values, citations and evidence boundaries remain exact. Rasterize the final 1600 × 900 canvas to PNG.
 </a:t>
@@ -2866,52 +3281,45 @@
 - The source skill's generic hand-drawn rule is intentionally overridden by this deck's confirmed custom investor style and the user's request for real evidence.
 ## STYLE_INSTRUCTIONS
 &lt;STYLE_INSTRUCTIONS&gt;
-Design Aesthetic: 简单、具体、可信，带一点野心。像优秀种子轮融资材料，而不是产品功能说明书。使用苹果发布会式的清晰度、咨询报告式的证据意识和创业团队的真实感。
+Design Aesthetic: 专业投资人材料。以咨询报告的数据表达、产品发布会的视觉层级和真实创业项目的证据感为基准。每页标题给出结论，图表承担论证，文字只负责解释口径。
 Background:
-  Texture: clean，纯色，无纹理、网格、渐变或装饰背景
-  Base Color: 暖白 #F7F6F2；只在少数对比页使用极浅暖灰 #EFEEE9
+  Base: warm white #F6F5F1
+  Alternate: pale stone #ECEBE6
+  Chart Grid: #D4D5D0
 Typography:
-  Headlines: 现代粗体无衬线，结论式标题，54–72px，严格控制在两行内
-  Body: 现代无衬线，24–30px；脚注可缩小但必须清晰
-  Numbers: 大号、直接、附口径，不放在多层卡片中
+  Headlines: modern geometric sans, 52–68px, max two lines
+  Body: 22–28px
+  Chart Labels: 17–21px
+  Numeric Highlights: 54–110px
 Color Palette:
-  Primary Text: #111111
-  Secondary Text: #62645F
-  Hairline: #D7D6D0
-  Brand Accent: Yoda Deep Green #173D2A
-  Secondary Accent: Yoda Green #5DC98F，仅用于一个关键节点或数字
-Visual Elements:
-  - 真实产品截图、真实用户现场和真实数据优先
-  - 只使用细线、少量色块、流程轨道和大数字
-  - 每页最多一个主视觉；圆角底板最多一块
-  - 不使用图标墙、胶囊标签堆叠、装饰性箭头、阴影卡片阵列或复杂坐标轴
-Density Guidelines:
-  - 每页一个结论，最多 2 个支撑层级
-  - 四周保留 80–100px 安全边距
-  - 页面至少 40% 留白
-Style Rules:
-  Do: 标题直接表达结论；每页为口头讲述提供一个视觉锚点；明确数据日期与证据边界
-  Don't: 不伪造产品 UI、客户、订单、留存或收入；不重复解释 Agent 团队；不让技术名词成为标题主体；不使用深色满版背景
+  Ink: #111312
+  Muted: #626762
+  Yoda Deep Green: #173D2A
+  Yoda Green: #5DC98F
+  Comparison Blue: #526A7A
+  Risk Gray: #A9AAA5
+Chart Language:
+  - 使用坐标轴、刻度、图例、注释线、象限、流程轨道、阶梯和环形图
+  - 每张图必须有明确结论和口径；概念曲线标注“趋势示意”
+  - 不使用伪精确数据，不使用无来源增长曲线
+  - 产品图使用真实截图；图片附边界说明
+Layout Rules:
+  - 16:9，四周 76–92px 安全边距
+  - 每页一个主图表，至少 35% 留白
+  - 不使用多层圆角卡片、装饰图标、渐变背景、玻璃拟态或无意义插画
+  - 统一左对齐；来源置底，字号不小于 15px
 &lt;/STYLE_INSTRUCTIONS&gt;
 ## SLIDE CONTENT
-## Slide 7 of 13
+## Slide 7 of 15
 **Type**: Content
-**Filename**: 07-slide-traction.png
-// NARRATIVE GOAL
-诚实展示已有使用信号和尚未完成的商业验证。
-// KEY CONTENT
-Headline: 已有真实使用信号，付费验证仍在起点
-Sub-headline: 当前数据证明有人下载、Clone 和授权，但不能替代留存与收入
-Body:
-- 126：14 天独立 Cloner
-- 73：独立授权用户
-- 73：公开 Release
-- 3：Relay 试用账户
-- 0：付费用户
-// VISUAL
-四个使用数字沿一条基线排列；右下角单独强调“0 付费”，并注明这是下一阶段核心验证。
-// LAYOUT
-Layout: metric-row
+**Filename**: 07-slide-system-moat.png
+Headline: Yoda 的壁垒不是一个 Agent，而是一套“自由、稳健、进化”的系统
+Chart: 三列能力矩阵
+- 自由：Agent、渠道、范式、交互、创作对象
+- 稳健：隔离、透明、成本归属、交叉审查、证据门
+- 进化：Skill、Gene、原子原则、动态 Harness、Library
+Conclusion: 换模型不丢工作方式，Agent 出错能看见、定位、回退和换人。
+Layout: capability-matrix
 ## Production Note
 +Render with deterministic HTML/CSS/SVG composition so Chinese text, data values, citations and evidence boundaries remain exact. Rasterize the final 1600 × 900 canvas to PNG.
 </a:t>
@@ -3095,49 +3503,47 @@
 - The source skill's generic hand-drawn rule is intentionally overridden by this deck's confirmed custom investor style and the user's request for real evidence.
 ## STYLE_INSTRUCTIONS
 &lt;STYLE_INSTRUCTIONS&gt;
-Design Aesthetic: 简单、具体、可信，带一点野心。像优秀种子轮融资材料，而不是产品功能说明书。使用苹果发布会式的清晰度、咨询报告式的证据意识和创业团队的真实感。
+Design Aesthetic: 专业投资人材料。以咨询报告的数据表达、产品发布会的视觉层级和真实创业项目的证据感为基准。每页标题给出结论，图表承担论证，文字只负责解释口径。
 Background:
-  Texture: clean，纯色，无纹理、网格、渐变或装饰背景
-  Base Color: 暖白 #F7F6F2；只在少数对比页使用极浅暖灰 #EFEEE9
+  Base: warm white #F6F5F1
+  Alternate: pale stone #ECEBE6
+  Chart Grid: #D4D5D0
 Typography:
-  Headlines: 现代粗体无衬线，结论式标题，54–72px，严格控制在两行内
-  Body: 现代无衬线，24–30px；脚注可缩小但必须清晰
-  Numbers: 大号、直接、附口径，不放在多层卡片中
+  Headlines: modern geometric sans, 52–68px, max two lines
+  Body: 22–28px
+  Chart Labels: 17–21px
+  Numeric Highlights: 54–110px
 Color Palette:
-  Primary Text: #111111
-  Secondary Text: #62645F
-  Hairline: #D7D6D0
-  Brand Accent: Yoda Deep Green #173D2A
-  Secondary Accent: Yoda Green #5DC98F，仅用于一个关键节点或数字
-Visual Elements:
-  - 真实产品截图、真实用户现场和真实数据优先
-  - 只使用细线、少量色块、流程轨道和大数字
-  - 每页最多一个主视觉；圆角底板最多一块
-  - 不使用图标墙、胶囊标签堆叠、装饰性箭头、阴影卡片阵列或复杂坐标轴
-Density Guidelines:
-  - 每页一个结论，最多 2 个支撑层级
-  - 四周保留 80–100px 安全边距
-  - 页面至少 40% 留白
-Style Rules:
-  Do: 标题直接表达结论；每页为口头讲述提供一个视觉锚点；明确数据日期与证据边界
-  Don't: 不伪造产品 UI、客户、订单、留存或收入；不重复解释 Agent 团队；不让技术名词成为标题主体；不使用深色满版背景
+  Ink: #111312
+  Muted: #626762
+  Yoda Deep Green: #173D2A
+  Yoda Green: #5DC98F
+  Comparison Blue: #526A7A
+  Risk Gray: #A9AAA5
+Chart Language:
+  - 使用坐标轴、刻度、图例、注释线、象限、流程轨道、阶梯和环形图
+  - 每张图必须有明确结论和口径；概念曲线标注“趋势示意”
+  - 不使用伪精确数据，不使用无来源增长曲线
+  - 产品图使用真实截图；图片附边界说明
+Layout Rules:
+  - 16:9，四周 76–92px 安全边距
+  - 每页一个主图表，至少 35% 留白
+  - 不使用多层圆角卡片、装饰图标、渐变背景、玻璃拟态或无意义插画
+  - 统一左对齐；来源置底，字号不小于 15px
 &lt;/STYLE_INSTRUCTIONS&gt;
 ## SLIDE CONTENT
-## Slide 8 of 13
+## Slide 8 of 15
 **Type**: Content
-**Filename**: 08-slide-business-model.png
-// NARRATIVE GOAL
-解释 C/B 双轨如何共享产品底座，并把高校教育作为明确 B 端切口。
-// KEY CONTENT
-Headline: C 端验证产品，B 端教育放大客单价
-Sub-headline: 个人订阅与机构年约共享同一套 Harness 底座
-Body:
-- C 端：Desktop → Relay / Creator Pro → Studio
-- B 端：付费试点 → Education 产品包 → 机构年约
-// VISUAL
-左侧两条简洁收入路径；右侧使用真实 AI 创造营照片，标注为渠道与培训场景证明、不是 Yoda 客户案例。
-// LAYOUT
-Layout: split-screen
+**Filename**: 08-slide-why-now.png
+Headline: 模型竞争正在下沉为基础能力，Harness 成为新的价值层
+Chart: 三条趋势线（概念趋势）
+- 模型能力与可得性上升
+- Agent 可独立执行时长上升
+- 人类可投入注意力基本不变
+Data callouts:
+- 75% 创意 AI 已融入或成为工作流必要部分
+- 85% 最终创意决策仍应由人完成
+Layout: multi-line-chart
 ## Production Note
 +Render with deterministic HTML/CSS/SVG composition so Chinese text, data values, citations and evidence boundaries remain exact. Rasterize the final 1600 × 900 canvas to PNG.
 </a:t>
@@ -3321,50 +3727,45 @@
 - The source skill's generic hand-drawn rule is intentionally overridden by this deck's confirmed custom investor style and the user's request for real evidence.
 ## STYLE_INSTRUCTIONS
 &lt;STYLE_INSTRUCTIONS&gt;
-Design Aesthetic: 简单、具体、可信，带一点野心。像优秀种子轮融资材料，而不是产品功能说明书。使用苹果发布会式的清晰度、咨询报告式的证据意识和创业团队的真实感。
+Design Aesthetic: 专业投资人材料。以咨询报告的数据表达、产品发布会的视觉层级和真实创业项目的证据感为基准。每页标题给出结论，图表承担论证，文字只负责解释口径。
 Background:
-  Texture: clean，纯色，无纹理、网格、渐变或装饰背景
-  Base Color: 暖白 #F7F6F2；只在少数对比页使用极浅暖灰 #EFEEE9
+  Base: warm white #F6F5F1
+  Alternate: pale stone #ECEBE6
+  Chart Grid: #D4D5D0
 Typography:
-  Headlines: 现代粗体无衬线，结论式标题，54–72px，严格控制在两行内
-  Body: 现代无衬线，24–30px；脚注可缩小但必须清晰
-  Numbers: 大号、直接、附口径，不放在多层卡片中
+  Headlines: modern geometric sans, 52–68px, max two lines
+  Body: 22–28px
+  Chart Labels: 17–21px
+  Numeric Highlights: 54–110px
 Color Palette:
-  Primary Text: #111111
-  Secondary Text: #62645F
-  Hairline: #D7D6D0
-  Brand Accent: Yoda Deep Green #173D2A
-  Secondary Accent: Yoda Green #5DC98F，仅用于一个关键节点或数字
-Visual Elements:
-  - 真实产品截图、真实用户现场和真实数据优先
-  - 只使用细线、少量色块、流程轨道和大数字
-  - 每页最多一个主视觉；圆角底板最多一块
-  - 不使用图标墙、胶囊标签堆叠、装饰性箭头、阴影卡片阵列或复杂坐标轴
-Density Guidelines:
-  - 每页一个结论，最多 2 个支撑层级
-  - 四周保留 80–100px 安全边距
-  - 页面至少 40% 留白
-Style Rules:
-  Do: 标题直接表达结论；每页为口头讲述提供一个视觉锚点；明确数据日期与证据边界
-  Don't: 不伪造产品 UI、客户、订单、留存或收入；不重复解释 Agent 团队；不让技术名词成为标题主体；不使用深色满版背景
+  Ink: #111312
+  Muted: #626762
+  Yoda Deep Green: #173D2A
+  Yoda Green: #5DC98F
+  Comparison Blue: #526A7A
+  Risk Gray: #A9AAA5
+Chart Language:
+  - 使用坐标轴、刻度、图例、注释线、象限、流程轨道、阶梯和环形图
+  - 每张图必须有明确结论和口径；概念曲线标注“趋势示意”
+  - 不使用伪精确数据，不使用无来源增长曲线
+  - 产品图使用真实截图；图片附边界说明
+Layout Rules:
+  - 16:9，四周 76–92px 安全边距
+  - 每页一个主图表，至少 35% 留白
+  - 不使用多层圆角卡片、装饰图标、渐变背景、玻璃拟态或无意义插画
+  - 统一左对齐；来源置底，字号不小于 15px
 &lt;/STYLE_INSTRUCTIONS&gt;
 ## SLIDE CONTENT
-## Slide 9 of 13
+## Slide 9 of 15
 **Type**: Content
-**Filename**: 09-slide-market.png
-// NARRATIVE GOAL
-把市场规模与切入路径放在同一张图里，避免先讲大市场再重复讲用户。
-// KEY CONTENT
-Headline: 从超级开发者切入一个 248 亿美元创作者工具市场
-Sub-headline: 先服务高频 Coding 创作者，再扩展到 AI 原生个人与团队
-Body:
-- TAM：248 亿美元
-- SAM：24.8 亿美元
-- 三年 SOM：240 万美元 ARR
-// VISUAL
-左侧三个同心圆表达切入路径；右侧三行大数字表达 TAM/SAM/SOM。每个数字只配一行口径。
-// LAYOUT
-Layout: split-screen
+**Filename**: 09-slide-traction.png
+Headline: 两个月完成产品闭环，已有使用信号，商业验证尚未开始
+Chart: 证据成熟度阶梯
+- Build：1,645 次 main 提交 / 73 个公开 Release / 31 种 Agent Client
+- Use：126 个 14 天独立 Cloner / 73 个独立授权用户
+- Pay：3 个 Relay 试用 / 0 付费
+Conclusion: 产品完成度与执行力已验证；留存、付费和机构年约是本轮融资后的核心问题。
+Layout: evidence-ladder
 ## Production Note
 +Render with deterministic HTML/CSS/SVG composition so Chinese text, data values, citations and evidence boundaries remain exact. Rasterize the final 1600 × 900 canvas to PNG.
 </a:t>
@@ -3911,6 +4312,102 @@
 <file path=ppt/slides/slide13.xml><?xml version="1.0" encoding="utf-8"?>
 <p:sld xmlns:a="http://schemas.openxmlformats.org/drawingml/2006/main" xmlns:r="http://schemas.openxmlformats.org/officeDocument/2006/relationships" xmlns:p="http://schemas.openxmlformats.org/presentationml/2006/main">
   <p:cSld name="Slide 13">
+    <p:spTree>
+      <p:nvGrpSpPr>
+        <p:cNvPr id="1" name=""/>
+        <p:cNvGrpSpPr/>
+        <p:nvPr/>
+      </p:nvGrpSpPr>
+      <p:grpSpPr>
+        <a:xfrm>
+          <a:off x="0" y="0"/>
+          <a:ext cx="0" cy="0"/>
+          <a:chOff x="0" y="0"/>
+          <a:chExt cx="0" cy="0"/>
+        </a:xfrm>
+      </p:grpSpPr>
+      <p:pic>
+        <p:nvPicPr>
+          <p:cNvPr id="2" name="Image 0" descr="preencoded.png">    </p:cNvPr>
+          <p:cNvPicPr>
+            <a:picLocks noChangeAspect="1"/>
+          </p:cNvPicPr>
+          <p:nvPr/>
+        </p:nvPicPr>
+        <p:blipFill>
+          <a:blip r:embed="rId1"/>
+          <a:srcRect l="0" r="0" t="0" b="0"/>
+          <a:stretch/>
+        </p:blipFill>
+        <p:spPr>
+          <a:xfrm>
+            <a:off x="0" y="0"/>
+            <a:ext cx="9144000" cy="5143500"/>
+          </a:xfrm>
+          <a:prstGeom prst="rect">
+            <a:avLst/>
+          </a:prstGeom>
+        </p:spPr>
+      </p:pic>
+    </p:spTree>
+  </p:cSld>
+  <p:clrMapOvr>
+    <a:masterClrMapping/>
+  </p:clrMapOvr>
+</p:sld>
+</file>
+
+<file path=ppt/slides/slide14.xml><?xml version="1.0" encoding="utf-8"?>
+<p:sld xmlns:a="http://schemas.openxmlformats.org/drawingml/2006/main" xmlns:r="http://schemas.openxmlformats.org/officeDocument/2006/relationships" xmlns:p="http://schemas.openxmlformats.org/presentationml/2006/main">
+  <p:cSld name="Slide 14">
+    <p:spTree>
+      <p:nvGrpSpPr>
+        <p:cNvPr id="1" name=""/>
+        <p:cNvGrpSpPr/>
+        <p:nvPr/>
+      </p:nvGrpSpPr>
+      <p:grpSpPr>
+        <a:xfrm>
+          <a:off x="0" y="0"/>
+          <a:ext cx="0" cy="0"/>
+          <a:chOff x="0" y="0"/>
+          <a:chExt cx="0" cy="0"/>
+        </a:xfrm>
+      </p:grpSpPr>
+      <p:pic>
+        <p:nvPicPr>
+          <p:cNvPr id="2" name="Image 0" descr="preencoded.png">    </p:cNvPr>
+          <p:cNvPicPr>
+            <a:picLocks noChangeAspect="1"/>
+          </p:cNvPicPr>
+          <p:nvPr/>
+        </p:nvPicPr>
+        <p:blipFill>
+          <a:blip r:embed="rId1"/>
+          <a:srcRect l="0" r="0" t="0" b="0"/>
+          <a:stretch/>
+        </p:blipFill>
+        <p:spPr>
+          <a:xfrm>
+            <a:off x="0" y="0"/>
+            <a:ext cx="9144000" cy="5143500"/>
+          </a:xfrm>
+          <a:prstGeom prst="rect">
+            <a:avLst/>
+          </a:prstGeom>
+        </p:spPr>
+      </p:pic>
+    </p:spTree>
+  </p:cSld>
+  <p:clrMapOvr>
+    <a:masterClrMapping/>
+  </p:clrMapOvr>
+</p:sld>
+</file>
+
+<file path=ppt/slides/slide15.xml><?xml version="1.0" encoding="utf-8"?>
+<p:sld xmlns:a="http://schemas.openxmlformats.org/drawingml/2006/main" xmlns:r="http://schemas.openxmlformats.org/officeDocument/2006/relationships" xmlns:p="http://schemas.openxmlformats.org/presentationml/2006/main">
+  <p:cSld name="Slide 15">
     <p:spTree>
       <p:nvGrpSpPr>
         <p:cNvPr id="1" name=""/>

</xml_diff>